<commit_message>
Slides: support certificates, the review of the day's increments, the roadmap's remaining three
The support operation's proof is now its certificate (both fixpoints' ranks); the counts
are 555 tests and 168 conformance cases; the review list adds what the combined review of
26 October and the support review found; the timeline adds both commits; support
certificates leave the roadmap. Built without fit warnings; not rendered (no LibreOffice
on this machine).

Co-Authored-By: Claude Opus 5.5 <noreply@anthropic.com>
Claude-Session: https://claude.ai/code/session_013RgeQG29grTkK2yzfquiAN
</commit_message>
<xml_diff>
--- a/docs/GRAPH_slides.pptx
+++ b/docs/GRAPH_slides.pptx
@@ -132,21 +132,21 @@
   <p:extLst>
     <p:ext uri="{521415D9-36F7-43E2-AB2F-B90AF26B5E84}">
       <p14:sectionLst xmlns:p14="http://schemas.microsoft.com/office/powerpoint/2010/main">
-        <p14:section name="Why GRAPH" id="{c2b2d9c3-b435-d215-b461-89a284f61615}">
+        <p14:section name="Why GRAPH" id="{05daf7a5-eab4-f971-a5ba-7b11225af34d}">
           <p14:sldIdLst>
             <p14:sldId id="256"/>
             <p14:sldId id="257"/>
             <p14:sldId id="258"/>
           </p14:sldIdLst>
         </p14:section>
-        <p14:section name="Architecture" id="{fa2108c0-661b-fcf4-cde0-a4cb827c0497}">
+        <p14:section name="Architecture" id="{fe45c9a5-9d51-6cf7-c32f-40ddc6627bf5}">
           <p14:sldIdLst>
             <p14:sldId id="259"/>
             <p14:sldId id="260"/>
             <p14:sldId id="261"/>
           </p14:sldIdLst>
         </p14:section>
-        <p14:section name="Operations" id="{02975f07-7211-93d6-e6de-03ab14204200}">
+        <p14:section name="Operations" id="{22846d14-73f8-4365-5efb-5f7055d49e53}">
           <p14:sldIdLst>
             <p14:sldId id="262"/>
             <p14:sldId id="263"/>
@@ -162,7 +162,7 @@
             <p14:sldId id="273"/>
           </p14:sldIdLst>
         </p14:section>
-        <p14:section name="Trust and results" id="{b0b7b96d-ef84-e475-48cf-981d5d64bb4c}">
+        <p14:section name="Trust and results" id="{a0c83cb0-5894-643b-0134-b24b76ed1bdd}">
           <p14:sldIdLst>
             <p14:sldId id="274"/>
             <p14:sldId id="275"/>
@@ -170,18 +170,18 @@
             <p14:sldId id="277"/>
           </p14:sldIdLst>
         </p14:section>
-        <p14:section name="Development" id="{459e5e19-2dfb-d571-c657-f47877b0dced}">
+        <p14:section name="Development" id="{30d527bf-c956-0911-4c0f-5e9aca6f13a9}">
           <p14:sldIdLst>
             <p14:sldId id="278"/>
           </p14:sldIdLst>
         </p14:section>
-        <p14:section name="Roadmap" id="{03498892-ed1e-9321-c50f-16ddfc050df3}">
+        <p14:section name="Roadmap" id="{59db7551-b2c0-398b-f87c-dc3b7c154a47}">
           <p14:sldIdLst>
             <p14:sldId id="279"/>
             <p14:sldId id="280"/>
           </p14:sldIdLst>
         </p14:section>
-        <p14:section name="Close" id="{45c9677f-a975-c23f-4985-422e3adb8027}">
+        <p14:section name="Close" id="{f09b0bb3-f445-0fb4-53ba-4beac22651c6}">
           <p14:sldIdLst>
             <p14:sldId id="281"/>
           </p14:sldIdLst>
@@ -1273,9 +1273,9 @@
           </c:marker>
           <c:cat>
             <c:multiLvlStrRef>
-              <c:f>Sheet1!$A$2:$A$19</c:f>
+              <c:f>Sheet1!$A$2:$A$20</c:f>
               <c:multiLvlStrCache>
-                <c:ptCount val="18"/>
+                <c:ptCount val="19"/>
                 <c:lvl>
                   <c:pt idx="0">
                     <c:v>v0</c:v>
@@ -1331,16 +1331,19 @@
                   <c:pt idx="17">
                     <c:v>d-sep.</c:v>
                   </c:pt>
+                  <c:pt idx="18">
+                    <c:v>sup. cert.</c:v>
+                  </c:pt>
                 </c:lvl>
               </c:multiLvlStrCache>
             </c:multiLvlStrRef>
           </c:cat>
           <c:val>
             <c:numRef>
-              <c:f>Sheet1!$B$2:$B$19</c:f>
+              <c:f>Sheet1!$B$2:$B$20</c:f>
               <c:numCache>
                 <c:formatCode>General</c:formatCode>
-                <c:ptCount val="18"/>
+                <c:ptCount val="19"/>
                 <c:pt idx="0">
                   <c:v>34</c:v>
                 </c:pt>
@@ -1394,6 +1397,9 @@
                 </c:pt>
                 <c:pt idx="17">
                   <c:v>165</c:v>
+                </c:pt>
+                <c:pt idx="18">
+                  <c:v>168</c:v>
                 </c:pt>
               </c:numCache>
             </c:numRef>
@@ -2013,8 +2019,8 @@
           <a:p>
             <a:r>
               <a:rPr lang="en-US" dirty="0"/>
-              <a:t>Sources: docs/API_CONTRACT.md §4: Support, Derivation; git log 5e61ca0, eeadc6a.
-support: What falls when nodes fail. Theory: A node with no support stands; an all_of node needs every support, any other node one. What stands is the least fixpoint, so support in a circle grounds nothing. Algorithm: Two fixpoints by counting standing supports, before and after the failures, over only the region they reach: lost and weakened nodes, with their causes. Checked by: verify_result recomputes what stands from the records by re-evaluating every rule. Generalizes SCALE's "rests on a retraction, all or in part".
+              <a:t>Sources: docs/API_CONTRACT.md §4: Support, Derivation; git log 5e61ca0, eeadc6a, 297ca1e.
+support: What falls when nodes fail. Theory: A node with no support stands; an all_of node needs every support, any other node one. What stands is the least fixpoint, so support in a circle grounds nothing. Algorithm: Two fixpoints by counting standing supports, before and after the failures, over only the region they reach: lost and weakened nodes, with their causes. Certificate: Both fixpoints' ranks: a ranked node meets its rule on lower ranks; the unranked fail theirs on unranked supports, an unfounded set. Generalizes SCALE's "rests on a retraction".
 derivation: The best route from feedstocks to each product. Theory: Lightest derivations: a reaction needs all its reactants, a species any reaction that makes it. Cheapest (min_sum), lowest highest barrier (min_max), fastest slowest step (max_min). Algorithm: Knuth's generalization of Dijkstra's algorithm (1977); the lightest derivation problem of Felzenszwalb and McAllester (2007). A settled value is final. Certificate proves: Values no rule improves on, over the targets' region, prove the best values and the underivable targets at once. The derivation DAG is the witness.</a:t>
             </a:r>
             <a:endParaRPr lang="en-US" dirty="0"/>
@@ -2820,7 +2826,7 @@
           <a:p>
             <a:r>
               <a:rPr lang="en-US" dirty="0"/>
-              <a:t>Sources: git log e365fdc, 0a58767, 05d3ea5, 1d6dbbf, 83f9ffe; README.md (Revalidation); docs/API_CONTRACT.md §7 (verdicts and reasons). With one diff of the projections, each result is checked in time proportional to the edit (binary search in the answer's canonical lists). On 700 random edits the diff and full checks give the same record and every 'holds' matches a fresh run. Measured on a heavily loaded machine. Revalidation by certificate (0a58767, extended in 05d3ea5): components, biconnectivity, max_flow, matching, dominators and incidence are always checked in full: a node or edge the answer names that is gone refutes it (node_gone, witness_gone); a claim the new records contradict refutes it (answer_refuted); otherwise it holds exactly when the certificate still checks (as verify_result checks it), and is unknown (certificate_broken) when it does not, or (no_certificate) when it has none. Tested on 600 random edits: whenever a result holds, a fresh run gives the same canonical answer.</a:t>
+              <a:t>Sources: git log e365fdc, 0a58767, 05d3ea5, 1d6dbbf, 83f9ffe, 297ca1e; README.md (Revalidation); docs/API_CONTRACT.md §7 (verdicts and reasons). With one diff of the projections, each result is checked in time proportional to the edit (binary search in the answer's canonical lists). On 700 random edits the diff and full checks give the same record and every 'holds' matches a fresh run. Measured on a heavily loaded machine. Revalidation by certificate (0a58767, extended in 05d3ea5): components, biconnectivity, max_flow, matching, dominators and incidence are always checked in full: a node or edge the answer names that is gone refutes it (node_gone, witness_gone); a claim the new records contradict refutes it (answer_refuted); otherwise it holds exactly when the certificate still checks (as verify_result checks it), and is unknown (certificate_broken) when it does not, or (no_certificate) when it has none. Tested on 600 random edits: whenever a result holds, a fresh run gives the same canonical answer.</a:t>
             </a:r>
             <a:endParaRPr lang="en-US" dirty="0"/>
           </a:p>
@@ -3265,7 +3271,7 @@
           <a:p>
             <a:r>
               <a:rPr lang="en-US" dirty="0"/>
-              <a:t>Source: git log (23 commits, 550c362 to 573ce2b; some rows group neighbouring commits). Conformance case counts are from the commit messages (34 at v0, then 49, 54, 62, 70, 74, 78, 91, 100, 112, 116, 121, 133) and cases.json now (165). Tests: 178 → 543. Commit times are local (-0400).</a:t>
+              <a:t>Source: git log (23 commits, 550c362 to 573ce2b; some rows group neighbouring commits). Conformance case counts are from the commit messages (34 at v0, then 49, 54, 62, 70, 74, 78, 91, 100, 112, 116, 121, 133) and cases.json now (168). Tests: 178 → 555. Commit times are local (-0400).</a:t>
             </a:r>
             <a:endParaRPr lang="en-US" dirty="0"/>
           </a:p>
@@ -6399,7 +6405,7 @@
                   <a:schemeClr val="accent1"/>
                 </a:solidFill>
               </a:rPr>
-              <a:t>CHECKED BY</a:t>
+              <a:t>CERTIFICATE</a:t>
             </a:r>
             <a:endParaRPr lang="en-US" sz="1100" dirty="0"/>
           </a:p>
@@ -6430,28 +6436,14 @@
               <a:buNone/>
             </a:pPr>
             <a:r>
-              <a:rPr lang="en-US" sz="1400" dirty="0">
+              <a:rPr lang="en-US" sz="1500" dirty="0">
                 <a:solidFill>
                   <a:schemeClr val="tx1"/>
                 </a:solidFill>
-                <a:latin typeface="Courier New" pitchFamily="34" charset="0"/>
-                <a:ea typeface="Courier New" pitchFamily="34" charset="-122"/>
-                <a:cs typeface="Courier New" pitchFamily="34" charset="-120"/>
-              </a:rPr>
-              <a:t>verify_result</a:t>
-            </a:r>
-            <a:pPr indent="0" marL="0">
-              <a:buNone/>
-            </a:pPr>
-            <a:r>
-              <a:rPr lang="en-US" sz="1500" dirty="0">
-                <a:solidFill>
-                  <a:schemeClr val="tx1"/>
-                </a:solidFill>
-              </a:rPr>
-              <a:t> recomputes what stands from the records by re-evaluating every rule. Generalizes SCALE's "rests on a retraction, all or in part".</a:t>
-            </a:r>
-            <a:endParaRPr lang="en-US" sz="1400" dirty="0"/>
+              </a:rPr>
+              <a:t>Both fixpoints' ranks: a ranked node meets its rule on lower ranks; the unranked fail theirs on unranked supports, an unfounded set. Generalizes SCALE's "rests on a retraction".</a:t>
+            </a:r>
+            <a:endParaRPr lang="en-US" sz="1500" dirty="0"/>
           </a:p>
         </p:txBody>
       </p:sp>
@@ -17661,7 +17653,7 @@
                 <a:ea typeface="Cambria" pitchFamily="34" charset="-122"/>
                 <a:cs typeface="Cambria" pitchFamily="34" charset="-120"/>
               </a:rPr>
-              <a:t>543</a:t>
+              <a:t>555</a:t>
             </a:r>
             <a:endParaRPr lang="en-US" sz="3400" dirty="0"/>
           </a:p>
@@ -17736,7 +17728,7 @@
                 <a:ea typeface="Cambria" pitchFamily="34" charset="-122"/>
                 <a:cs typeface="Cambria" pitchFamily="34" charset="-120"/>
               </a:rPr>
-              <a:t>165</a:t>
+              <a:t>168</a:t>
             </a:r>
             <a:endParaRPr lang="en-US" sz="3400" dirty="0"/>
           </a:p>
@@ -17990,11 +17982,11 @@
         <p:spPr>
           <a:xfrm>
             <a:off x="548640" y="2898648"/>
-            <a:ext cx="2567864" cy="2176272"/>
+            <a:ext cx="2567864" cy="1993392"/>
           </a:xfrm>
           <a:prstGeom prst="roundRect">
             <a:avLst>
-              <a:gd name="adj" fmla="val 4202"/>
+              <a:gd name="adj" fmla="val 4587"/>
             </a:avLst>
           </a:prstGeom>
           <a:solidFill>
@@ -18092,7 +18084,7 @@
         <p:spPr>
           <a:xfrm>
             <a:off x="749808" y="3721608"/>
-            <a:ext cx="2165528" cy="1261872"/>
+            <a:ext cx="2165528" cy="1078992"/>
           </a:xfrm>
           <a:prstGeom prst="rect">
             <a:avLst/>
@@ -18142,11 +18134,11 @@
         <p:spPr>
           <a:xfrm>
             <a:off x="3390824" y="2898648"/>
-            <a:ext cx="2567864" cy="2176272"/>
+            <a:ext cx="2567864" cy="1993392"/>
           </a:xfrm>
           <a:prstGeom prst="roundRect">
             <a:avLst>
-              <a:gd name="adj" fmla="val 4202"/>
+              <a:gd name="adj" fmla="val 4587"/>
             </a:avLst>
           </a:prstGeom>
           <a:solidFill>
@@ -18244,7 +18236,7 @@
         <p:spPr>
           <a:xfrm>
             <a:off x="3591992" y="3721608"/>
-            <a:ext cx="2165528" cy="1261872"/>
+            <a:ext cx="2165528" cy="1078992"/>
           </a:xfrm>
           <a:prstGeom prst="rect">
             <a:avLst/>
@@ -18280,11 +18272,11 @@
         <p:spPr>
           <a:xfrm>
             <a:off x="6233008" y="2898648"/>
-            <a:ext cx="2567864" cy="2176272"/>
+            <a:ext cx="2567864" cy="1993392"/>
           </a:xfrm>
           <a:prstGeom prst="roundRect">
             <a:avLst>
-              <a:gd name="adj" fmla="val 4202"/>
+              <a:gd name="adj" fmla="val 4587"/>
             </a:avLst>
           </a:prstGeom>
           <a:solidFill>
@@ -18382,7 +18374,7 @@
         <p:spPr>
           <a:xfrm>
             <a:off x="6434176" y="3721608"/>
-            <a:ext cx="2165528" cy="1261872"/>
+            <a:ext cx="2165528" cy="1078992"/>
           </a:xfrm>
           <a:prstGeom prst="rect">
             <a:avLst/>
@@ -18418,11 +18410,11 @@
         <p:spPr>
           <a:xfrm>
             <a:off x="9075191" y="2898648"/>
-            <a:ext cx="2567864" cy="2176272"/>
+            <a:ext cx="2567864" cy="1993392"/>
           </a:xfrm>
           <a:prstGeom prst="roundRect">
             <a:avLst>
-              <a:gd name="adj" fmla="val 4202"/>
+              <a:gd name="adj" fmla="val 4587"/>
             </a:avLst>
           </a:prstGeom>
           <a:solidFill>
@@ -18520,7 +18512,7 @@
         <p:spPr>
           <a:xfrm>
             <a:off x="9276359" y="3721608"/>
-            <a:ext cx="2165528" cy="1261872"/>
+            <a:ext cx="2165528" cy="1078992"/>
           </a:xfrm>
           <a:prstGeom prst="rect">
             <a:avLst/>
@@ -18555,8 +18547,8 @@
         </p:nvSpPr>
         <p:spPr>
           <a:xfrm>
-            <a:off x="548640" y="5230368"/>
-            <a:ext cx="11094415" cy="987552"/>
+            <a:off x="548640" y="5047488"/>
+            <a:ext cx="11094415" cy="1170432"/>
           </a:xfrm>
           <a:prstGeom prst="rect">
             <a:avLst/>
@@ -18597,7 +18589,7 @@
                   <a:schemeClr val="accent6"/>
                 </a:solidFill>
               </a:rPr>
-              <a:t>Codex reviews each increment adversarially before commit. Found and fixed with regressions: a request_id collision and two certificate holes (structure); an unverified interrupted bound (flows); a quadratic cycle check (dominators); a float entry that let a false rank verify, a stale nearest cut revalidated as holding, contradicted answers left unknown (incidence); exact fields beside false values, a path from outside the sources' region, controls never polled (critical path). d-separation: approved with no findings after 10,000 oracle comparisons and 5,000 revalidation checks.</a:t>
+              <a:t>Codex reviews each increment adversarially before commit. Found and fixed with regressions: a request_id collision and two certificate holes (structure); an unverified interrupted bound (flows); a quadratic cycle check (dominators); a float entry that let a false rank verify, a stale nearest cut revalidated as holding, contradicted answers left unknown (incidence); exact fields beside false values, a path from outside the sources' region, controls never polled (critical path); a quadratic certificate check (support). d-separation: no findings. A review of all of 26 October together: a nonuniform PageRank start, a lenient ranking revalidation, a quadratic cyclic join.</a:t>
             </a:r>
             <a:endParaRPr lang="en-US" sz="1200" dirty="0"/>
           </a:p>
@@ -19727,7 +19719,7 @@
                   <a:schemeClr val="accent6"/>
                 </a:solidFill>
               </a:rPr>
-              <a:t>Thirty-one commits on 25–26 October 2026: from four operations to nineteen.</a:t>
+              <a:t>Thirty-four commits on 25–26 October 2026: from four operations to nineteen.</a:t>
             </a:r>
             <a:endParaRPr lang="en-US" sz="1600" dirty="0"/>
           </a:p>
@@ -19741,8 +19733,8 @@
         </p:nvSpPr>
         <p:spPr>
           <a:xfrm>
-            <a:off x="1508760" y="1842516"/>
-            <a:ext cx="0" cy="4224528"/>
+            <a:off x="1508760" y="1824766"/>
+            <a:ext cx="0" cy="4260028"/>
           </a:xfrm>
           <a:prstGeom prst="line">
             <a:avLst/>
@@ -19765,7 +19757,7 @@
         <p:spPr>
           <a:xfrm>
             <a:off x="1783080" y="1691640"/>
-            <a:ext cx="4754880" cy="301752"/>
+            <a:ext cx="4754880" cy="266252"/>
           </a:xfrm>
           <a:prstGeom prst="rect">
             <a:avLst/>
@@ -19800,7 +19792,7 @@
         </p:nvSpPr>
         <p:spPr>
           <a:xfrm>
-            <a:off x="1435608" y="2071116"/>
+            <a:off x="1435608" y="2017866"/>
             <a:ext cx="146304" cy="146304"/>
           </a:xfrm>
           <a:prstGeom prst="ellipse">
@@ -19825,8 +19817,8 @@
         </p:nvSpPr>
         <p:spPr>
           <a:xfrm>
-            <a:off x="548640" y="1993392"/>
-            <a:ext cx="777240" cy="301752"/>
+            <a:off x="548640" y="1957892"/>
+            <a:ext cx="777240" cy="266252"/>
           </a:xfrm>
           <a:prstGeom prst="rect">
             <a:avLst/>
@@ -19861,8 +19853,8 @@
         </p:nvSpPr>
         <p:spPr>
           <a:xfrm>
-            <a:off x="1783080" y="1993392"/>
-            <a:ext cx="4800600" cy="301752"/>
+            <a:off x="1783080" y="1957892"/>
+            <a:ext cx="4800600" cy="266252"/>
           </a:xfrm>
           <a:prstGeom prst="rect">
             <a:avLst/>
@@ -19897,7 +19889,7 @@
         </p:nvSpPr>
         <p:spPr>
           <a:xfrm>
-            <a:off x="1435608" y="2372868"/>
+            <a:off x="1435608" y="2284117"/>
             <a:ext cx="146304" cy="146304"/>
           </a:xfrm>
           <a:prstGeom prst="ellipse">
@@ -19922,8 +19914,8 @@
         </p:nvSpPr>
         <p:spPr>
           <a:xfrm>
-            <a:off x="548640" y="2295144"/>
-            <a:ext cx="777240" cy="301752"/>
+            <a:off x="548640" y="2224144"/>
+            <a:ext cx="777240" cy="266252"/>
           </a:xfrm>
           <a:prstGeom prst="rect">
             <a:avLst/>
@@ -19958,8 +19950,8 @@
         </p:nvSpPr>
         <p:spPr>
           <a:xfrm>
-            <a:off x="1783080" y="2295144"/>
-            <a:ext cx="4800600" cy="301752"/>
+            <a:off x="1783080" y="2224144"/>
+            <a:ext cx="4800600" cy="266252"/>
           </a:xfrm>
           <a:prstGeom prst="rect">
             <a:avLst/>
@@ -19994,7 +19986,7 @@
         </p:nvSpPr>
         <p:spPr>
           <a:xfrm>
-            <a:off x="1435608" y="2674620"/>
+            <a:off x="1435608" y="2550369"/>
             <a:ext cx="146304" cy="146304"/>
           </a:xfrm>
           <a:prstGeom prst="ellipse">
@@ -20019,8 +20011,8 @@
         </p:nvSpPr>
         <p:spPr>
           <a:xfrm>
-            <a:off x="548640" y="2596896"/>
-            <a:ext cx="777240" cy="301752"/>
+            <a:off x="548640" y="2490395"/>
+            <a:ext cx="777240" cy="266252"/>
           </a:xfrm>
           <a:prstGeom prst="rect">
             <a:avLst/>
@@ -20055,8 +20047,8 @@
         </p:nvSpPr>
         <p:spPr>
           <a:xfrm>
-            <a:off x="1783080" y="2596896"/>
-            <a:ext cx="4800600" cy="301752"/>
+            <a:off x="1783080" y="2490395"/>
+            <a:ext cx="4800600" cy="266252"/>
           </a:xfrm>
           <a:prstGeom prst="rect">
             <a:avLst/>
@@ -20091,7 +20083,7 @@
         </p:nvSpPr>
         <p:spPr>
           <a:xfrm>
-            <a:off x="1435608" y="2976372"/>
+            <a:off x="1435608" y="2816621"/>
             <a:ext cx="146304" cy="146304"/>
           </a:xfrm>
           <a:prstGeom prst="ellipse">
@@ -20116,8 +20108,8 @@
         </p:nvSpPr>
         <p:spPr>
           <a:xfrm>
-            <a:off x="548640" y="2898648"/>
-            <a:ext cx="777240" cy="301752"/>
+            <a:off x="548640" y="2756647"/>
+            <a:ext cx="777240" cy="266252"/>
           </a:xfrm>
           <a:prstGeom prst="rect">
             <a:avLst/>
@@ -20152,8 +20144,8 @@
         </p:nvSpPr>
         <p:spPr>
           <a:xfrm>
-            <a:off x="1783080" y="2898648"/>
-            <a:ext cx="4800600" cy="301752"/>
+            <a:off x="1783080" y="2756647"/>
+            <a:ext cx="4800600" cy="266252"/>
           </a:xfrm>
           <a:prstGeom prst="rect">
             <a:avLst/>
@@ -20188,8 +20180,8 @@
         </p:nvSpPr>
         <p:spPr>
           <a:xfrm>
-            <a:off x="1783080" y="3200400"/>
-            <a:ext cx="4754880" cy="301752"/>
+            <a:off x="1783080" y="3022899"/>
+            <a:ext cx="4754880" cy="266252"/>
           </a:xfrm>
           <a:prstGeom prst="rect">
             <a:avLst/>
@@ -20224,7 +20216,7 @@
         </p:nvSpPr>
         <p:spPr>
           <a:xfrm>
-            <a:off x="1435608" y="3579876"/>
+            <a:off x="1435608" y="3349124"/>
             <a:ext cx="146304" cy="146304"/>
           </a:xfrm>
           <a:prstGeom prst="ellipse">
@@ -20249,8 +20241,8 @@
         </p:nvSpPr>
         <p:spPr>
           <a:xfrm>
-            <a:off x="548640" y="3502152"/>
-            <a:ext cx="777240" cy="301752"/>
+            <a:off x="548640" y="3289151"/>
+            <a:ext cx="777240" cy="266252"/>
           </a:xfrm>
           <a:prstGeom prst="rect">
             <a:avLst/>
@@ -20285,8 +20277,8 @@
         </p:nvSpPr>
         <p:spPr>
           <a:xfrm>
-            <a:off x="1783080" y="3502152"/>
-            <a:ext cx="4800600" cy="301752"/>
+            <a:off x="1783080" y="3289151"/>
+            <a:ext cx="4800600" cy="266252"/>
           </a:xfrm>
           <a:prstGeom prst="rect">
             <a:avLst/>
@@ -20335,7 +20327,7 @@
         </p:nvSpPr>
         <p:spPr>
           <a:xfrm>
-            <a:off x="1435608" y="3881628"/>
+            <a:off x="1435608" y="3615376"/>
             <a:ext cx="146304" cy="146304"/>
           </a:xfrm>
           <a:prstGeom prst="ellipse">
@@ -20360,8 +20352,8 @@
         </p:nvSpPr>
         <p:spPr>
           <a:xfrm>
-            <a:off x="548640" y="3803904"/>
-            <a:ext cx="777240" cy="301752"/>
+            <a:off x="548640" y="3555402"/>
+            <a:ext cx="777240" cy="266252"/>
           </a:xfrm>
           <a:prstGeom prst="rect">
             <a:avLst/>
@@ -20396,8 +20388,8 @@
         </p:nvSpPr>
         <p:spPr>
           <a:xfrm>
-            <a:off x="1783080" y="3803904"/>
-            <a:ext cx="4800600" cy="301752"/>
+            <a:off x="1783080" y="3555402"/>
+            <a:ext cx="4800600" cy="266252"/>
           </a:xfrm>
           <a:prstGeom prst="rect">
             <a:avLst/>
@@ -20471,7 +20463,7 @@
         </p:nvSpPr>
         <p:spPr>
           <a:xfrm>
-            <a:off x="1435608" y="4183380"/>
+            <a:off x="1435608" y="3881628"/>
             <a:ext cx="146304" cy="146304"/>
           </a:xfrm>
           <a:prstGeom prst="ellipse">
@@ -20496,8 +20488,8 @@
         </p:nvSpPr>
         <p:spPr>
           <a:xfrm>
-            <a:off x="548640" y="4105656"/>
-            <a:ext cx="777240" cy="301752"/>
+            <a:off x="548640" y="3821654"/>
+            <a:ext cx="777240" cy="266252"/>
           </a:xfrm>
           <a:prstGeom prst="rect">
             <a:avLst/>
@@ -20532,8 +20524,8 @@
         </p:nvSpPr>
         <p:spPr>
           <a:xfrm>
-            <a:off x="1783080" y="4105656"/>
-            <a:ext cx="4800600" cy="301752"/>
+            <a:off x="1783080" y="3821654"/>
+            <a:ext cx="4800600" cy="266252"/>
           </a:xfrm>
           <a:prstGeom prst="rect">
             <a:avLst/>
@@ -20582,7 +20574,7 @@
         </p:nvSpPr>
         <p:spPr>
           <a:xfrm>
-            <a:off x="1435608" y="4485132"/>
+            <a:off x="1435608" y="4147880"/>
             <a:ext cx="146304" cy="146304"/>
           </a:xfrm>
           <a:prstGeom prst="ellipse">
@@ -20607,8 +20599,8 @@
         </p:nvSpPr>
         <p:spPr>
           <a:xfrm>
-            <a:off x="548640" y="4407408"/>
-            <a:ext cx="777240" cy="301752"/>
+            <a:off x="548640" y="4087906"/>
+            <a:ext cx="777240" cy="266252"/>
           </a:xfrm>
           <a:prstGeom prst="rect">
             <a:avLst/>
@@ -20643,8 +20635,8 @@
         </p:nvSpPr>
         <p:spPr>
           <a:xfrm>
-            <a:off x="1783080" y="4407408"/>
-            <a:ext cx="4800600" cy="301752"/>
+            <a:off x="1783080" y="4087906"/>
+            <a:ext cx="4800600" cy="266252"/>
           </a:xfrm>
           <a:prstGeom prst="rect">
             <a:avLst/>
@@ -20718,7 +20710,7 @@
         </p:nvSpPr>
         <p:spPr>
           <a:xfrm>
-            <a:off x="1435608" y="4786884"/>
+            <a:off x="1435608" y="4414132"/>
             <a:ext cx="146304" cy="146304"/>
           </a:xfrm>
           <a:prstGeom prst="ellipse">
@@ -20743,8 +20735,8 @@
         </p:nvSpPr>
         <p:spPr>
           <a:xfrm>
-            <a:off x="548640" y="4709160"/>
-            <a:ext cx="777240" cy="301752"/>
+            <a:off x="548640" y="4354158"/>
+            <a:ext cx="777240" cy="266252"/>
           </a:xfrm>
           <a:prstGeom prst="rect">
             <a:avLst/>
@@ -20779,8 +20771,8 @@
         </p:nvSpPr>
         <p:spPr>
           <a:xfrm>
-            <a:off x="1783080" y="4709160"/>
-            <a:ext cx="4800600" cy="301752"/>
+            <a:off x="1783080" y="4354158"/>
+            <a:ext cx="4800600" cy="266252"/>
           </a:xfrm>
           <a:prstGeom prst="rect">
             <a:avLst/>
@@ -20843,7 +20835,7 @@
         </p:nvSpPr>
         <p:spPr>
           <a:xfrm>
-            <a:off x="1435608" y="5088636"/>
+            <a:off x="1435608" y="4680383"/>
             <a:ext cx="146304" cy="146304"/>
           </a:xfrm>
           <a:prstGeom prst="ellipse">
@@ -20868,8 +20860,8 @@
         </p:nvSpPr>
         <p:spPr>
           <a:xfrm>
-            <a:off x="548640" y="5010912"/>
-            <a:ext cx="777240" cy="301752"/>
+            <a:off x="548640" y="4620409"/>
+            <a:ext cx="777240" cy="266252"/>
           </a:xfrm>
           <a:prstGeom prst="rect">
             <a:avLst/>
@@ -20904,8 +20896,8 @@
         </p:nvSpPr>
         <p:spPr>
           <a:xfrm>
-            <a:off x="1783080" y="5010912"/>
-            <a:ext cx="4800600" cy="301752"/>
+            <a:off x="1783080" y="4620409"/>
+            <a:ext cx="4800600" cy="266252"/>
           </a:xfrm>
           <a:prstGeom prst="rect">
             <a:avLst/>
@@ -20954,7 +20946,7 @@
         </p:nvSpPr>
         <p:spPr>
           <a:xfrm>
-            <a:off x="1435608" y="5390388"/>
+            <a:off x="1435608" y="4946635"/>
             <a:ext cx="146304" cy="146304"/>
           </a:xfrm>
           <a:prstGeom prst="ellipse">
@@ -20979,8 +20971,8 @@
         </p:nvSpPr>
         <p:spPr>
           <a:xfrm>
-            <a:off x="548640" y="5312664"/>
-            <a:ext cx="777240" cy="301752"/>
+            <a:off x="548640" y="4886661"/>
+            <a:ext cx="777240" cy="266252"/>
           </a:xfrm>
           <a:prstGeom prst="rect">
             <a:avLst/>
@@ -21015,8 +21007,8 @@
         </p:nvSpPr>
         <p:spPr>
           <a:xfrm>
-            <a:off x="1783080" y="5312664"/>
-            <a:ext cx="4800600" cy="301752"/>
+            <a:off x="1783080" y="4886661"/>
+            <a:ext cx="4800600" cy="266252"/>
           </a:xfrm>
           <a:prstGeom prst="rect">
             <a:avLst/>
@@ -21065,7 +21057,7 @@
         </p:nvSpPr>
         <p:spPr>
           <a:xfrm>
-            <a:off x="1435608" y="5692140"/>
+            <a:off x="1435608" y="5212887"/>
             <a:ext cx="146304" cy="146304"/>
           </a:xfrm>
           <a:prstGeom prst="ellipse">
@@ -21090,8 +21082,8 @@
         </p:nvSpPr>
         <p:spPr>
           <a:xfrm>
-            <a:off x="548640" y="5614416"/>
-            <a:ext cx="777240" cy="301752"/>
+            <a:off x="548640" y="5152913"/>
+            <a:ext cx="777240" cy="266252"/>
           </a:xfrm>
           <a:prstGeom prst="rect">
             <a:avLst/>
@@ -21126,8 +21118,8 @@
         </p:nvSpPr>
         <p:spPr>
           <a:xfrm>
-            <a:off x="1783080" y="5614416"/>
-            <a:ext cx="4800600" cy="301752"/>
+            <a:off x="1783080" y="5152913"/>
+            <a:ext cx="4800600" cy="266252"/>
           </a:xfrm>
           <a:prstGeom prst="rect">
             <a:avLst/>
@@ -21176,7 +21168,215 @@
         </p:nvSpPr>
         <p:spPr>
           <a:xfrm>
-            <a:off x="1417320" y="5975604"/>
+            <a:off x="1435608" y="5479139"/>
+            <a:ext cx="146304" cy="146304"/>
+          </a:xfrm>
+          <a:prstGeom prst="ellipse">
+            <a:avLst/>
+          </a:prstGeom>
+          <a:solidFill>
+            <a:schemeClr val="accent1"/>
+          </a:solidFill>
+          <a:ln w="19050">
+            <a:solidFill>
+              <a:schemeClr val="bg1"/>
+            </a:solidFill>
+            <a:prstDash val="solid"/>
+          </a:ln>
+        </p:spPr>
+      </p:sp>
+      <p:sp>
+        <p:nvSpPr>
+          <p:cNvPr id="44" name="Text 42"/>
+          <p:cNvSpPr txBox="1"/>
+          <p:nvPr/>
+        </p:nvSpPr>
+        <p:spPr>
+          <a:xfrm>
+            <a:off x="548640" y="5419165"/>
+            <a:ext cx="777240" cy="266252"/>
+          </a:xfrm>
+          <a:prstGeom prst="rect">
+            <a:avLst/>
+          </a:prstGeom>
+          <a:noFill/>
+          <a:ln/>
+        </p:spPr>
+        <p:txBody>
+          <a:bodyPr wrap="square" lIns="0" tIns="0" rIns="0" bIns="0" rtlCol="0" anchor="ctr"/>
+          <a:lstStyle/>
+          <a:p>
+            <a:pPr algn="r" indent="0" marL="0">
+              <a:buNone/>
+            </a:pPr>
+            <a:r>
+              <a:rPr lang="en-US" sz="1300" dirty="0">
+                <a:solidFill>
+                  <a:schemeClr val="accent6"/>
+                </a:solidFill>
+              </a:rPr>
+              <a:t>11:44</a:t>
+            </a:r>
+            <a:endParaRPr lang="en-US" sz="1300" dirty="0"/>
+          </a:p>
+        </p:txBody>
+      </p:sp>
+      <p:sp>
+        <p:nvSpPr>
+          <p:cNvPr id="45" name="Text 43"/>
+          <p:cNvSpPr txBox="1"/>
+          <p:nvPr/>
+        </p:nvSpPr>
+        <p:spPr>
+          <a:xfrm>
+            <a:off x="1783080" y="5419165"/>
+            <a:ext cx="4800600" cy="266252"/>
+          </a:xfrm>
+          <a:prstGeom prst="rect">
+            <a:avLst/>
+          </a:prstGeom>
+          <a:noFill/>
+          <a:ln/>
+        </p:spPr>
+        <p:txBody>
+          <a:bodyPr wrap="square" lIns="0" tIns="0" rIns="0" bIns="0" rtlCol="0" anchor="ctr"/>
+          <a:lstStyle/>
+          <a:p>
+            <a:pPr indent="0" marL="0">
+              <a:buNone/>
+            </a:pPr>
+            <a:r>
+              <a:rPr lang="en-US" sz="1300" dirty="0">
+                <a:solidFill>
+                  <a:schemeClr val="tx1"/>
+                </a:solidFill>
+                <a:latin typeface="Courier New" pitchFamily="34" charset="0"/>
+                <a:ea typeface="Courier New" pitchFamily="34" charset="-122"/>
+                <a:cs typeface="Courier New" pitchFamily="34" charset="-120"/>
+              </a:rPr>
+              <a:t>d_separation</a:t>
+            </a:r>
+            <a:pPr indent="0" marL="0">
+              <a:buNone/>
+            </a:pPr>
+            <a:r>
+              <a:rPr lang="en-US" sz="1400" dirty="0">
+                <a:solidFill>
+                  <a:schemeClr val="tx1"/>
+                </a:solidFill>
+              </a:rPr>
+              <a:t> (causal independence)</a:t>
+            </a:r>
+            <a:endParaRPr lang="en-US" sz="1300" dirty="0"/>
+          </a:p>
+        </p:txBody>
+      </p:sp>
+      <p:sp>
+        <p:nvSpPr>
+          <p:cNvPr id="46" name="milestone 17:45"/>
+          <p:cNvSpPr/>
+          <p:nvPr/>
+        </p:nvSpPr>
+        <p:spPr>
+          <a:xfrm>
+            <a:off x="1435608" y="5745390"/>
+            <a:ext cx="146304" cy="146304"/>
+          </a:xfrm>
+          <a:prstGeom prst="ellipse">
+            <a:avLst/>
+          </a:prstGeom>
+          <a:solidFill>
+            <a:schemeClr val="accent1"/>
+          </a:solidFill>
+          <a:ln w="19050">
+            <a:solidFill>
+              <a:schemeClr val="bg1"/>
+            </a:solidFill>
+            <a:prstDash val="solid"/>
+          </a:ln>
+        </p:spPr>
+      </p:sp>
+      <p:sp>
+        <p:nvSpPr>
+          <p:cNvPr id="47" name="Text 45"/>
+          <p:cNvSpPr txBox="1"/>
+          <p:nvPr/>
+        </p:nvSpPr>
+        <p:spPr>
+          <a:xfrm>
+            <a:off x="548640" y="5685416"/>
+            <a:ext cx="777240" cy="266252"/>
+          </a:xfrm>
+          <a:prstGeom prst="rect">
+            <a:avLst/>
+          </a:prstGeom>
+          <a:noFill/>
+          <a:ln/>
+        </p:spPr>
+        <p:txBody>
+          <a:bodyPr wrap="square" lIns="0" tIns="0" rIns="0" bIns="0" rtlCol="0" anchor="ctr"/>
+          <a:lstStyle/>
+          <a:p>
+            <a:pPr algn="r" indent="0" marL="0">
+              <a:buNone/>
+            </a:pPr>
+            <a:r>
+              <a:rPr lang="en-US" sz="1300" dirty="0">
+                <a:solidFill>
+                  <a:schemeClr val="accent6"/>
+                </a:solidFill>
+              </a:rPr>
+              <a:t>17:45</a:t>
+            </a:r>
+            <a:endParaRPr lang="en-US" sz="1300" dirty="0"/>
+          </a:p>
+        </p:txBody>
+      </p:sp>
+      <p:sp>
+        <p:nvSpPr>
+          <p:cNvPr id="48" name="Text 46"/>
+          <p:cNvSpPr txBox="1"/>
+          <p:nvPr/>
+        </p:nvSpPr>
+        <p:spPr>
+          <a:xfrm>
+            <a:off x="1783080" y="5685416"/>
+            <a:ext cx="4800600" cy="266252"/>
+          </a:xfrm>
+          <a:prstGeom prst="rect">
+            <a:avLst/>
+          </a:prstGeom>
+          <a:noFill/>
+          <a:ln/>
+        </p:spPr>
+        <p:txBody>
+          <a:bodyPr wrap="square" lIns="0" tIns="0" rIns="0" bIns="0" rtlCol="0" anchor="ctr"/>
+          <a:lstStyle/>
+          <a:p>
+            <a:pPr indent="0" marL="0">
+              <a:buNone/>
+            </a:pPr>
+            <a:r>
+              <a:rPr lang="en-US" sz="1400" dirty="0">
+                <a:solidFill>
+                  <a:schemeClr val="tx1"/>
+                </a:solidFill>
+              </a:rPr>
+              <a:t>Fixes from a review of the day's increments</a:t>
+            </a:r>
+            <a:endParaRPr lang="en-US" sz="1400" dirty="0"/>
+          </a:p>
+        </p:txBody>
+      </p:sp>
+      <p:sp>
+        <p:nvSpPr>
+          <p:cNvPr id="49" name="milestone 18:23"/>
+          <p:cNvSpPr/>
+          <p:nvPr/>
+        </p:nvSpPr>
+        <p:spPr>
+          <a:xfrm>
+            <a:off x="1417320" y="5993354"/>
             <a:ext cx="182880" cy="182880"/>
           </a:xfrm>
           <a:prstGeom prst="ellipse">
@@ -21195,14 +21395,14 @@
       </p:sp>
       <p:sp>
         <p:nvSpPr>
-          <p:cNvPr id="44" name="Text 42"/>
+          <p:cNvPr id="50" name="Text 48"/>
           <p:cNvSpPr txBox="1"/>
           <p:nvPr/>
         </p:nvSpPr>
         <p:spPr>
           <a:xfrm>
-            <a:off x="548640" y="5916168"/>
-            <a:ext cx="777240" cy="301752"/>
+            <a:off x="548640" y="5951668"/>
+            <a:ext cx="777240" cy="266252"/>
           </a:xfrm>
           <a:prstGeom prst="rect">
             <a:avLst/>
@@ -21223,7 +21423,7 @@
                   <a:schemeClr val="accent6"/>
                 </a:solidFill>
               </a:rPr>
-              <a:t>11:44</a:t>
+              <a:t>18:23</a:t>
             </a:r>
             <a:endParaRPr lang="en-US" sz="1300" dirty="0"/>
           </a:p>
@@ -21231,14 +21431,14 @@
       </p:sp>
       <p:sp>
         <p:nvSpPr>
-          <p:cNvPr id="45" name="Text 43"/>
+          <p:cNvPr id="51" name="Text 49"/>
           <p:cNvSpPr txBox="1"/>
           <p:nvPr/>
         </p:nvSpPr>
         <p:spPr>
           <a:xfrm>
-            <a:off x="1783080" y="5916168"/>
-            <a:ext cx="4800600" cy="301752"/>
+            <a:off x="1783080" y="5951668"/>
+            <a:ext cx="4800600" cy="266252"/>
           </a:xfrm>
           <a:prstGeom prst="rect">
             <a:avLst/>
@@ -21254,34 +21454,20 @@
               <a:buNone/>
             </a:pPr>
             <a:r>
-              <a:rPr lang="en-US" sz="1300" dirty="0">
+              <a:rPr lang="en-US" sz="1400" dirty="0">
                 <a:solidFill>
                   <a:schemeClr val="tx1"/>
                 </a:solidFill>
-                <a:latin typeface="Courier New" pitchFamily="34" charset="0"/>
-                <a:ea typeface="Courier New" pitchFamily="34" charset="-122"/>
-                <a:cs typeface="Courier New" pitchFamily="34" charset="-120"/>
-              </a:rPr>
-              <a:t>d_separation</a:t>
-            </a:r>
-            <a:pPr indent="0" marL="0">
-              <a:buNone/>
-            </a:pPr>
-            <a:r>
-              <a:rPr lang="en-US" sz="1400" dirty="0">
-                <a:solidFill>
-                  <a:schemeClr val="tx1"/>
-                </a:solidFill>
-              </a:rPr>
-              <a:t> (causal independence)</a:t>
-            </a:r>
-            <a:endParaRPr lang="en-US" sz="1300" dirty="0"/>
-          </a:p>
-        </p:txBody>
-      </p:sp>
-      <p:sp>
-        <p:nvSpPr>
-          <p:cNvPr id="46" name="growth operations"/>
+              </a:rPr>
+              <a:t>Support certificates · support revalidated</a:t>
+            </a:r>
+            <a:endParaRPr lang="en-US" sz="1400" dirty="0"/>
+          </a:p>
+        </p:txBody>
+      </p:sp>
+      <p:sp>
+        <p:nvSpPr>
+          <p:cNvPr id="52" name="growth operations"/>
           <p:cNvSpPr/>
           <p:nvPr/>
         </p:nvSpPr>
@@ -21303,7 +21489,7 @@
       </p:sp>
       <p:sp>
         <p:nvSpPr>
-          <p:cNvPr id="47" name="Text 45"/>
+          <p:cNvPr id="53" name="Text 51"/>
           <p:cNvSpPr txBox="1"/>
           <p:nvPr/>
         </p:nvSpPr>
@@ -21356,7 +21542,7 @@
       </p:sp>
       <p:sp>
         <p:nvSpPr>
-          <p:cNvPr id="48" name="growth runtime tests"/>
+          <p:cNvPr id="54" name="growth runtime tests"/>
           <p:cNvSpPr/>
           <p:nvPr/>
         </p:nvSpPr>
@@ -21378,7 +21564,7 @@
       </p:sp>
       <p:sp>
         <p:nvSpPr>
-          <p:cNvPr id="49" name="Text 47"/>
+          <p:cNvPr id="55" name="Text 53"/>
           <p:cNvSpPr txBox="1"/>
           <p:nvPr/>
         </p:nvSpPr>
@@ -21409,7 +21595,7 @@
                 <a:ea typeface="Cambria" pitchFamily="34" charset="-122"/>
                 <a:cs typeface="Cambria" pitchFamily="34" charset="-120"/>
               </a:rPr>
-              <a:t>178 → 543</a:t>
+              <a:t>178 → 555</a:t>
             </a:r>
             <a:endParaRPr lang="en-US" sz="2800" dirty="0"/>
           </a:p>
@@ -21431,7 +21617,7 @@
       </p:sp>
       <p:graphicFrame>
         <p:nvGraphicFramePr>
-          <p:cNvPr id="50" name="conformance growth chart" descr=""/>
+          <p:cNvPr id="56" name="conformance growth chart" descr=""/>
           <p:cNvGraphicFramePr/>
           <p:nvPr/>
         </p:nvGraphicFramePr>
@@ -21737,18 +21923,18 @@
       </p:sp>
       <p:sp>
         <p:nvSpPr>
-          <p:cNvPr id="8" name="roadmap Support certificates"/>
+          <p:cNvPr id="8" name="roadmap k-best paths"/>
           <p:cNvSpPr/>
           <p:nvPr/>
         </p:nvSpPr>
         <p:spPr>
           <a:xfrm>
             <a:off x="548640" y="1911096"/>
-            <a:ext cx="11094415" cy="1008126"/>
+            <a:ext cx="11094415" cy="1374648"/>
           </a:xfrm>
           <a:prstGeom prst="roundRect">
             <a:avLst>
-              <a:gd name="adj" fmla="val 9070"/>
+              <a:gd name="adj" fmla="val 6652"/>
             </a:avLst>
           </a:prstGeom>
           <a:solidFill>
@@ -21759,13 +21945,13 @@
       </p:sp>
       <p:sp>
         <p:nvSpPr>
-          <p:cNvPr id="9" name="icon Support certificates"/>
-          <p:cNvSpPr/>
-          <p:nvPr/>
-        </p:nvSpPr>
-        <p:spPr>
-          <a:xfrm>
-            <a:off x="713232" y="2195703"/>
+          <p:cNvPr id="9" name="icon k-best paths"/>
+          <p:cNvSpPr/>
+          <p:nvPr/>
+        </p:nvSpPr>
+        <p:spPr>
+          <a:xfrm>
+            <a:off x="713232" y="2378964"/>
             <a:ext cx="438912" cy="438912"/>
           </a:xfrm>
           <a:prstGeom prst="ellipse">
@@ -21779,7 +21965,7 @@
       </p:sp>
       <p:pic>
         <p:nvPicPr>
-          <p:cNvPr id="10" name="Image 0" descr="Support certificates">    </p:cNvPr>
+          <p:cNvPr id="10" name="Image 0" descr="k-best paths">    </p:cNvPr>
           <p:cNvPicPr>
             <a:picLocks noChangeAspect="1"/>
           </p:cNvPicPr>
@@ -21793,7 +21979,7 @@
         </p:blipFill>
         <p:spPr>
           <a:xfrm>
-            <a:off x="809793" y="2292264"/>
+            <a:off x="809793" y="2475525"/>
             <a:ext cx="245791" cy="245791"/>
           </a:xfrm>
           <a:prstGeom prst="rect">
@@ -21810,7 +21996,7 @@
         <p:spPr>
           <a:xfrm>
             <a:off x="1325880" y="1911096"/>
-            <a:ext cx="1828800" cy="1008126"/>
+            <a:ext cx="1828800" cy="1374648"/>
           </a:xfrm>
           <a:prstGeom prst="rect">
             <a:avLst/>
@@ -21831,7 +22017,7 @@
                   <a:schemeClr val="tx1"/>
                 </a:solidFill>
               </a:rPr>
-              <a:t>Support certificates</a:t>
+              <a:t>k-best paths</a:t>
             </a:r>
             <a:endParaRPr lang="en-US" sz="1500" dirty="0"/>
           </a:p>
@@ -21846,7 +22032,7 @@
         <p:spPr>
           <a:xfrm>
             <a:off x="3383280" y="1911096"/>
-            <a:ext cx="3017520" cy="1008126"/>
+            <a:ext cx="3017520" cy="1374648"/>
           </a:xfrm>
           <a:prstGeom prst="rect">
             <a:avLst/>
@@ -21867,7 +22053,7 @@
                   <a:schemeClr val="tx1"/>
                 </a:solidFill>
               </a:rPr>
-              <a:t>Support answers checked and revalidated without recomputing.</a:t>
+              <a:t>Alternative routes and explanations, not only one optimum.</a:t>
             </a:r>
             <a:endParaRPr lang="en-US" sz="1400" dirty="0"/>
           </a:p>
@@ -21882,7 +22068,7 @@
         <p:spPr>
           <a:xfrm>
             <a:off x="6629400" y="1911096"/>
-            <a:ext cx="3017520" cy="1008126"/>
+            <a:ext cx="3017520" cy="1374648"/>
           </a:xfrm>
           <a:prstGeom prst="rect">
             <a:avLst/>
@@ -21903,7 +22089,7 @@
                   <a:schemeClr val="tx1"/>
                 </a:solidFill>
               </a:rPr>
-              <a:t>Derivation ranks and closure under every rule prove the least fixpoint.</a:t>
+              <a:t>Path witnesses; a deviation partition with potentials proves the first k.</a:t>
             </a:r>
             <a:endParaRPr lang="en-US" sz="1400" dirty="0"/>
           </a:p>
@@ -21918,7 +22104,7 @@
         <p:spPr>
           <a:xfrm>
             <a:off x="9875520" y="1911096"/>
-            <a:ext cx="1676095" cy="1008126"/>
+            <a:ext cx="1676095" cy="1374648"/>
           </a:xfrm>
           <a:prstGeom prst="rect">
             <a:avLst/>
@@ -21939,7 +22125,7 @@
                   <a:schemeClr val="accent6"/>
                 </a:solidFill>
               </a:rPr>
-              <a:t>Dowling–Gallier 1984; McConnell et al. 2011</a:t>
+              <a:t>Yen 1971 (k shortest simple paths)</a:t>
             </a:r>
             <a:endParaRPr lang="en-US" sz="1200" dirty="0"/>
           </a:p>
@@ -21947,18 +22133,18 @@
       </p:sp>
       <p:sp>
         <p:nvSpPr>
-          <p:cNvPr id="15" name="roadmap k-best paths"/>
-          <p:cNvSpPr/>
-          <p:nvPr/>
-        </p:nvSpPr>
-        <p:spPr>
-          <a:xfrm>
-            <a:off x="548640" y="3010662"/>
-            <a:ext cx="11094415" cy="1008126"/>
+          <p:cNvPr id="15" name="roadmap Pattern query planning"/>
+          <p:cNvSpPr/>
+          <p:nvPr/>
+        </p:nvSpPr>
+        <p:spPr>
+          <a:xfrm>
+            <a:off x="548640" y="3377184"/>
+            <a:ext cx="11094415" cy="1374648"/>
           </a:xfrm>
           <a:prstGeom prst="roundRect">
             <a:avLst>
-              <a:gd name="adj" fmla="val 9070"/>
+              <a:gd name="adj" fmla="val 6652"/>
             </a:avLst>
           </a:prstGeom>
           <a:solidFill>
@@ -21969,13 +22155,13 @@
       </p:sp>
       <p:sp>
         <p:nvSpPr>
-          <p:cNvPr id="16" name="icon k-best paths"/>
-          <p:cNvSpPr/>
-          <p:nvPr/>
-        </p:nvSpPr>
-        <p:spPr>
-          <a:xfrm>
-            <a:off x="713232" y="3295269"/>
+          <p:cNvPr id="16" name="icon Pattern query planning"/>
+          <p:cNvSpPr/>
+          <p:nvPr/>
+        </p:nvSpPr>
+        <p:spPr>
+          <a:xfrm>
+            <a:off x="713232" y="3845052"/>
             <a:ext cx="438912" cy="438912"/>
           </a:xfrm>
           <a:prstGeom prst="ellipse">
@@ -21989,7 +22175,7 @@
       </p:sp>
       <p:pic>
         <p:nvPicPr>
-          <p:cNvPr id="17" name="Image 1" descr="k-best paths">    </p:cNvPr>
+          <p:cNvPr id="17" name="Image 1" descr="Pattern query planning">    </p:cNvPr>
           <p:cNvPicPr>
             <a:picLocks noChangeAspect="1"/>
           </p:cNvPicPr>
@@ -22003,7 +22189,7 @@
         </p:blipFill>
         <p:spPr>
           <a:xfrm>
-            <a:off x="809793" y="3391830"/>
+            <a:off x="809793" y="3941613"/>
             <a:ext cx="245791" cy="245791"/>
           </a:xfrm>
           <a:prstGeom prst="rect">
@@ -22019,8 +22205,8 @@
         </p:nvSpPr>
         <p:spPr>
           <a:xfrm>
-            <a:off x="1325880" y="3010662"/>
-            <a:ext cx="1828800" cy="1008126"/>
+            <a:off x="1325880" y="3377184"/>
+            <a:ext cx="1828800" cy="1374648"/>
           </a:xfrm>
           <a:prstGeom prst="rect">
             <a:avLst/>
@@ -22041,7 +22227,7 @@
                   <a:schemeClr val="tx1"/>
                 </a:solidFill>
               </a:rPr>
-              <a:t>k-best paths</a:t>
+              <a:t>Pattern query planning</a:t>
             </a:r>
             <a:endParaRPr lang="en-US" sz="1500" dirty="0"/>
           </a:p>
@@ -22055,8 +22241,8 @@
         </p:nvSpPr>
         <p:spPr>
           <a:xfrm>
-            <a:off x="3383280" y="3010662"/>
-            <a:ext cx="3017520" cy="1008126"/>
+            <a:off x="3383280" y="3377184"/>
+            <a:ext cx="3017520" cy="1374648"/>
           </a:xfrm>
           <a:prstGeom prst="rect">
             <a:avLst/>
@@ -22077,7 +22263,7 @@
                   <a:schemeClr val="tx1"/>
                 </a:solidFill>
               </a:rPr>
-              <a:t>Alternative routes and explanations, not only one optimum.</a:t>
+              <a:t>Start the semi-join reduction from the most selective variable.</a:t>
             </a:r>
             <a:endParaRPr lang="en-US" sz="1400" dirty="0"/>
           </a:p>
@@ -22091,8 +22277,8 @@
         </p:nvSpPr>
         <p:spPr>
           <a:xfrm>
-            <a:off x="6629400" y="3010662"/>
-            <a:ext cx="3017520" cy="1008126"/>
+            <a:off x="6629400" y="3377184"/>
+            <a:ext cx="3017520" cy="1374648"/>
           </a:xfrm>
           <a:prstGeom prst="rect">
             <a:avLst/>
@@ -22113,7 +22299,7 @@
                   <a:schemeClr val="tx1"/>
                 </a:solidFill>
               </a:rPr>
-              <a:t>Path witnesses; a deviation partition with potentials proves the first k.</a:t>
+              <a:t>The same answers; the work statistics, part of result_id, change.</a:t>
             </a:r>
             <a:endParaRPr lang="en-US" sz="1400" dirty="0"/>
           </a:p>
@@ -22127,8 +22313,8 @@
         </p:nvSpPr>
         <p:spPr>
           <a:xfrm>
-            <a:off x="9875520" y="3010662"/>
-            <a:ext cx="1676095" cy="1008126"/>
+            <a:off x="9875520" y="3377184"/>
+            <a:ext cx="1676095" cy="1374648"/>
           </a:xfrm>
           <a:prstGeom prst="rect">
             <a:avLst/>
@@ -22149,7 +22335,7 @@
                   <a:schemeClr val="accent6"/>
                 </a:solidFill>
               </a:rPr>
-              <a:t>Yen 1971 (k shortest simple paths)</a:t>
+              <a:t>Selinger et al. 1979 (access paths)</a:t>
             </a:r>
             <a:endParaRPr lang="en-US" sz="1200" dirty="0"/>
           </a:p>
@@ -22157,18 +22343,18 @@
       </p:sp>
       <p:sp>
         <p:nvSpPr>
-          <p:cNvPr id="22" name="roadmap Pattern query planning"/>
-          <p:cNvSpPr/>
-          <p:nvPr/>
-        </p:nvSpPr>
-        <p:spPr>
-          <a:xfrm>
-            <a:off x="548640" y="4110228"/>
-            <a:ext cx="11094415" cy="1008126"/>
+          <p:cNvPr id="22" name="roadmap Incremental repair"/>
+          <p:cNvSpPr/>
+          <p:nvPr/>
+        </p:nvSpPr>
+        <p:spPr>
+          <a:xfrm>
+            <a:off x="548640" y="4843272"/>
+            <a:ext cx="11094415" cy="1374648"/>
           </a:xfrm>
           <a:prstGeom prst="roundRect">
             <a:avLst>
-              <a:gd name="adj" fmla="val 9070"/>
+              <a:gd name="adj" fmla="val 6652"/>
             </a:avLst>
           </a:prstGeom>
           <a:solidFill>
@@ -22179,13 +22365,13 @@
       </p:sp>
       <p:sp>
         <p:nvSpPr>
-          <p:cNvPr id="23" name="icon Pattern query planning"/>
-          <p:cNvSpPr/>
-          <p:nvPr/>
-        </p:nvSpPr>
-        <p:spPr>
-          <a:xfrm>
-            <a:off x="713232" y="4394835"/>
+          <p:cNvPr id="23" name="icon Incremental repair"/>
+          <p:cNvSpPr/>
+          <p:nvPr/>
+        </p:nvSpPr>
+        <p:spPr>
+          <a:xfrm>
+            <a:off x="713232" y="5311140"/>
             <a:ext cx="438912" cy="438912"/>
           </a:xfrm>
           <a:prstGeom prst="ellipse">
@@ -22199,7 +22385,7 @@
       </p:sp>
       <p:pic>
         <p:nvPicPr>
-          <p:cNvPr id="24" name="Image 2" descr="Pattern query planning">    </p:cNvPr>
+          <p:cNvPr id="24" name="Image 2" descr="Incremental repair">    </p:cNvPr>
           <p:cNvPicPr>
             <a:picLocks noChangeAspect="1"/>
           </p:cNvPicPr>
@@ -22213,7 +22399,7 @@
         </p:blipFill>
         <p:spPr>
           <a:xfrm>
-            <a:off x="809793" y="4491396"/>
+            <a:off x="809793" y="5407701"/>
             <a:ext cx="245791" cy="245791"/>
           </a:xfrm>
           <a:prstGeom prst="rect">
@@ -22229,8 +22415,8 @@
         </p:nvSpPr>
         <p:spPr>
           <a:xfrm>
-            <a:off x="1325880" y="4110228"/>
-            <a:ext cx="1828800" cy="1008126"/>
+            <a:off x="1325880" y="4843272"/>
+            <a:ext cx="1828800" cy="1374648"/>
           </a:xfrm>
           <a:prstGeom prst="rect">
             <a:avLst/>
@@ -22251,7 +22437,7 @@
                   <a:schemeClr val="tx1"/>
                 </a:solidFill>
               </a:rPr>
-              <a:t>Pattern query planning</a:t>
+              <a:t>Incremental repair</a:t>
             </a:r>
             <a:endParaRPr lang="en-US" sz="1500" dirty="0"/>
           </a:p>
@@ -22265,8 +22451,8 @@
         </p:nvSpPr>
         <p:spPr>
           <a:xfrm>
-            <a:off x="3383280" y="4110228"/>
-            <a:ext cx="3017520" cy="1008126"/>
+            <a:off x="3383280" y="4843272"/>
+            <a:ext cx="3017520" cy="1374648"/>
           </a:xfrm>
           <a:prstGeom prst="rect">
             <a:avLst/>
@@ -22287,7 +22473,7 @@
                   <a:schemeClr val="tx1"/>
                 </a:solidFill>
               </a:rPr>
-              <a:t>Start the semi-join reduction from the most selective variable.</a:t>
+              <a:t>Repair cached answers that revalidation finds broken.</a:t>
             </a:r>
             <a:endParaRPr lang="en-US" sz="1400" dirty="0"/>
           </a:p>
@@ -22301,8 +22487,8 @@
         </p:nvSpPr>
         <p:spPr>
           <a:xfrm>
-            <a:off x="6629400" y="4110228"/>
-            <a:ext cx="3017520" cy="1008126"/>
+            <a:off x="6629400" y="4843272"/>
+            <a:ext cx="3017520" cy="1374648"/>
           </a:xfrm>
           <a:prstGeom prst="rect">
             <a:avLst/>
@@ -22323,7 +22509,7 @@
                   <a:schemeClr val="tx1"/>
                 </a:solidFill>
               </a:rPr>
-              <a:t>The same answers; the work statistics, part of result_id, change.</a:t>
+              <a:t>A fresh answer with an ordinary certificate on the new projection.</a:t>
             </a:r>
             <a:endParaRPr lang="en-US" sz="1400" dirty="0"/>
           </a:p>
@@ -22337,218 +22523,8 @@
         </p:nvSpPr>
         <p:spPr>
           <a:xfrm>
-            <a:off x="9875520" y="4110228"/>
-            <a:ext cx="1676095" cy="1008126"/>
-          </a:xfrm>
-          <a:prstGeom prst="rect">
-            <a:avLst/>
-          </a:prstGeom>
-          <a:noFill/>
-          <a:ln/>
-        </p:spPr>
-        <p:txBody>
-          <a:bodyPr wrap="square" lIns="0" tIns="0" rIns="0" bIns="0" rtlCol="0" anchor="ctr"/>
-          <a:lstStyle/>
-          <a:p>
-            <a:pPr indent="0" marL="0">
-              <a:buNone/>
-            </a:pPr>
-            <a:r>
-              <a:rPr lang="en-US" sz="1200" i="1" dirty="0">
-                <a:solidFill>
-                  <a:schemeClr val="accent6"/>
-                </a:solidFill>
-              </a:rPr>
-              <a:t>Selinger et al. 1979 (access paths)</a:t>
-            </a:r>
-            <a:endParaRPr lang="en-US" sz="1200" dirty="0"/>
-          </a:p>
-        </p:txBody>
-      </p:sp>
-      <p:sp>
-        <p:nvSpPr>
-          <p:cNvPr id="29" name="roadmap Incremental repair"/>
-          <p:cNvSpPr/>
-          <p:nvPr/>
-        </p:nvSpPr>
-        <p:spPr>
-          <a:xfrm>
-            <a:off x="548640" y="5209794"/>
-            <a:ext cx="11094415" cy="1008126"/>
-          </a:xfrm>
-          <a:prstGeom prst="roundRect">
-            <a:avLst>
-              <a:gd name="adj" fmla="val 9070"/>
-            </a:avLst>
-          </a:prstGeom>
-          <a:solidFill>
-            <a:schemeClr val="bg2"/>
-          </a:solidFill>
-          <a:ln/>
-        </p:spPr>
-      </p:sp>
-      <p:sp>
-        <p:nvSpPr>
-          <p:cNvPr id="30" name="icon Incremental repair"/>
-          <p:cNvSpPr/>
-          <p:nvPr/>
-        </p:nvSpPr>
-        <p:spPr>
-          <a:xfrm>
-            <a:off x="713232" y="5494401"/>
-            <a:ext cx="438912" cy="438912"/>
-          </a:xfrm>
-          <a:prstGeom prst="ellipse">
-            <a:avLst/>
-          </a:prstGeom>
-          <a:solidFill>
-            <a:schemeClr val="accent1"/>
-          </a:solidFill>
-          <a:ln/>
-        </p:spPr>
-      </p:sp>
-      <p:pic>
-        <p:nvPicPr>
-          <p:cNvPr id="31" name="Image 3" descr="Incremental repair">    </p:cNvPr>
-          <p:cNvPicPr>
-            <a:picLocks noChangeAspect="1"/>
-          </p:cNvPicPr>
-          <p:nvPr/>
-        </p:nvPicPr>
-        <p:blipFill>
-          <a:blip r:embed="rId4"/>
-          <a:stretch>
-            <a:fillRect/>
-          </a:stretch>
-        </p:blipFill>
-        <p:spPr>
-          <a:xfrm>
-            <a:off x="809793" y="5590962"/>
-            <a:ext cx="245791" cy="245791"/>
-          </a:xfrm>
-          <a:prstGeom prst="rect">
-            <a:avLst/>
-          </a:prstGeom>
-        </p:spPr>
-      </p:pic>
-      <p:sp>
-        <p:nvSpPr>
-          <p:cNvPr id="32" name="Text 26"/>
-          <p:cNvSpPr txBox="1"/>
-          <p:nvPr/>
-        </p:nvSpPr>
-        <p:spPr>
-          <a:xfrm>
-            <a:off x="1325880" y="5209794"/>
-            <a:ext cx="1828800" cy="1008126"/>
-          </a:xfrm>
-          <a:prstGeom prst="rect">
-            <a:avLst/>
-          </a:prstGeom>
-          <a:noFill/>
-          <a:ln/>
-        </p:spPr>
-        <p:txBody>
-          <a:bodyPr wrap="square" lIns="0" tIns="0" rIns="0" bIns="0" rtlCol="0" anchor="ctr"/>
-          <a:lstStyle/>
-          <a:p>
-            <a:pPr indent="0" marL="0">
-              <a:buNone/>
-            </a:pPr>
-            <a:r>
-              <a:rPr lang="en-US" sz="1500" b="1" dirty="0">
-                <a:solidFill>
-                  <a:schemeClr val="tx1"/>
-                </a:solidFill>
-              </a:rPr>
-              <a:t>Incremental repair</a:t>
-            </a:r>
-            <a:endParaRPr lang="en-US" sz="1500" dirty="0"/>
-          </a:p>
-        </p:txBody>
-      </p:sp>
-      <p:sp>
-        <p:nvSpPr>
-          <p:cNvPr id="33" name="Text 27"/>
-          <p:cNvSpPr txBox="1"/>
-          <p:nvPr/>
-        </p:nvSpPr>
-        <p:spPr>
-          <a:xfrm>
-            <a:off x="3383280" y="5209794"/>
-            <a:ext cx="3017520" cy="1008126"/>
-          </a:xfrm>
-          <a:prstGeom prst="rect">
-            <a:avLst/>
-          </a:prstGeom>
-          <a:noFill/>
-          <a:ln/>
-        </p:spPr>
-        <p:txBody>
-          <a:bodyPr wrap="square" lIns="0" tIns="0" rIns="0" bIns="0" rtlCol="0" anchor="ctr"/>
-          <a:lstStyle/>
-          <a:p>
-            <a:pPr indent="0" marL="0">
-              <a:buNone/>
-            </a:pPr>
-            <a:r>
-              <a:rPr lang="en-US" sz="1400" dirty="0">
-                <a:solidFill>
-                  <a:schemeClr val="tx1"/>
-                </a:solidFill>
-              </a:rPr>
-              <a:t>Repair cached answers that revalidation finds broken.</a:t>
-            </a:r>
-            <a:endParaRPr lang="en-US" sz="1400" dirty="0"/>
-          </a:p>
-        </p:txBody>
-      </p:sp>
-      <p:sp>
-        <p:nvSpPr>
-          <p:cNvPr id="34" name="Text 28"/>
-          <p:cNvSpPr txBox="1"/>
-          <p:nvPr/>
-        </p:nvSpPr>
-        <p:spPr>
-          <a:xfrm>
-            <a:off x="6629400" y="5209794"/>
-            <a:ext cx="3017520" cy="1008126"/>
-          </a:xfrm>
-          <a:prstGeom prst="rect">
-            <a:avLst/>
-          </a:prstGeom>
-          <a:noFill/>
-          <a:ln/>
-        </p:spPr>
-        <p:txBody>
-          <a:bodyPr wrap="square" lIns="0" tIns="0" rIns="0" bIns="0" rtlCol="0" anchor="ctr"/>
-          <a:lstStyle/>
-          <a:p>
-            <a:pPr indent="0" marL="0">
-              <a:buNone/>
-            </a:pPr>
-            <a:r>
-              <a:rPr lang="en-US" sz="1400" dirty="0">
-                <a:solidFill>
-                  <a:schemeClr val="tx1"/>
-                </a:solidFill>
-              </a:rPr>
-              <a:t>A fresh answer with an ordinary certificate on the new projection.</a:t>
-            </a:r>
-            <a:endParaRPr lang="en-US" sz="1400" dirty="0"/>
-          </a:p>
-        </p:txBody>
-      </p:sp>
-      <p:sp>
-        <p:nvSpPr>
-          <p:cNvPr id="35" name="Text 29"/>
-          <p:cNvSpPr txBox="1"/>
-          <p:nvPr/>
-        </p:nvSpPr>
-        <p:spPr>
-          <a:xfrm>
-            <a:off x="9875520" y="5209794"/>
-            <a:ext cx="1676095" cy="1008126"/>
+            <a:off x="9875520" y="4843272"/>
+            <a:ext cx="1676095" cy="1374648"/>
           </a:xfrm>
           <a:prstGeom prst="rect">
             <a:avLst/>

</xml_diff>

<commit_message>
Slides: injective patterns and spanning forests
- Slide 12 adds an injective-pattern card (substructure search, 0.05 s for 7,200 hexagon
  matches against networkx's 0.54 s).
- Slide 16 adds the spanning forest (Kruskal, the cycle property, binary lifting).
- Twenty operations, 582 tests and 180 conformance cases.
- Both Codex findings are listed.
- The networkx head-to-head gains two bars.
- The timeline and roadmap are updated.

The deck describes the repository at 741c2dd. Cycle bases (a482dbf) and weighted
matching (066dbab) come in the next update.

Co-Authored-By: Claude Opus 5.5 <noreply@anthropic.com>
</commit_message>
<xml_diff>
--- a/docs/GRAPH_slides.pptx
+++ b/docs/GRAPH_slides.pptx
@@ -133,21 +133,21 @@
   <p:extLst>
     <p:ext uri="{521415D9-36F7-43E2-AB2F-B90AF26B5E84}">
       <p14:sectionLst xmlns:p14="http://schemas.microsoft.com/office/powerpoint/2010/main">
-        <p14:section name="Why GRAPH" id="{3b5b011a-e849-9d18-073b-050743e4bec7}">
+        <p14:section name="Why GRAPH" id="{8714fdd0-597c-f169-b0fb-cc405bd4545b}">
           <p14:sldIdLst>
             <p14:sldId id="256"/>
             <p14:sldId id="257"/>
             <p14:sldId id="258"/>
           </p14:sldIdLst>
         </p14:section>
-        <p14:section name="Architecture" id="{05291d25-9439-8ed4-aefe-84de7a313ef9}">
+        <p14:section name="Architecture" id="{37b6bcb3-547b-8255-cce8-bbbfbb1fee8b}">
           <p14:sldIdLst>
             <p14:sldId id="259"/>
             <p14:sldId id="260"/>
             <p14:sldId id="261"/>
           </p14:sldIdLst>
         </p14:section>
-        <p14:section name="Operations" id="{15058014-131b-f815-136a-8882c58fee2f}">
+        <p14:section name="Operations" id="{92bc6c68-5372-089c-964d-e0a13da45faa}">
           <p14:sldIdLst>
             <p14:sldId id="262"/>
             <p14:sldId id="263"/>
@@ -163,7 +163,7 @@
             <p14:sldId id="273"/>
           </p14:sldIdLst>
         </p14:section>
-        <p14:section name="Trust and results" id="{eed35332-851e-b12a-b97d-0b1024b72f90}">
+        <p14:section name="Trust and results" id="{6bfd7de0-9433-b816-f1f6-3993d5db93d0}">
           <p14:sldIdLst>
             <p14:sldId id="274"/>
             <p14:sldId id="275"/>
@@ -172,18 +172,18 @@
             <p14:sldId id="278"/>
           </p14:sldIdLst>
         </p14:section>
-        <p14:section name="Development" id="{20b584aa-5daa-f2a8-f6e0-5ecac511a8c9}">
+        <p14:section name="Development" id="{e71647a7-0f83-64f7-1da5-4f7e65862b19}">
           <p14:sldIdLst>
             <p14:sldId id="279"/>
           </p14:sldIdLst>
         </p14:section>
-        <p14:section name="Roadmap" id="{88afddbf-9db6-28f5-bd99-8903515638df}">
+        <p14:section name="Roadmap" id="{6002abff-183f-41b7-3d03-554b8389fba1}">
           <p14:sldIdLst>
             <p14:sldId id="280"/>
             <p14:sldId id="281"/>
           </p14:sldIdLst>
         </p14:section>
-        <p14:section name="Close" id="{e737b35b-5ed3-4dff-e3f2-8bc69b905b4b}">
+        <p14:section name="Close" id="{078975ea-46d2-d87d-5eb4-202109caa7de}">
           <p14:sldIdLst>
             <p14:sldId id="282"/>
           </p14:sldIdLst>
@@ -859,9 +859,9 @@
           </c:dLbls>
           <c:cat>
             <c:multiLvlStrRef>
-              <c:f>Sheet1!$A$2:$A$8</c:f>
+              <c:f>Sheet1!$A$2:$A$10</c:f>
               <c:multiLvlStrCache>
-                <c:ptCount val="7"/>
+                <c:ptCount val="9"/>
                 <c:lvl>
                   <c:pt idx="0">
                     <c:v>Strong components</c:v>
@@ -884,16 +884,22 @@
                   <c:pt idx="6">
                     <c:v>Negative costs</c:v>
                   </c:pt>
+                  <c:pt idx="7">
+                    <c:v>Hexagon search</c:v>
+                  </c:pt>
+                  <c:pt idx="8">
+                    <c:v>Spanning forest</c:v>
+                  </c:pt>
                 </c:lvl>
               </c:multiLvlStrCache>
             </c:multiLvlStrRef>
           </c:cat>
           <c:val>
             <c:numRef>
-              <c:f>Sheet1!$B$2:$B$8</c:f>
+              <c:f>Sheet1!$B$2:$B$10</c:f>
               <c:numCache>
                 <c:formatCode>General</c:formatCode>
-                <c:ptCount val="7"/>
+                <c:ptCount val="9"/>
                 <c:pt idx="0">
                   <c:v>0.38</c:v>
                 </c:pt>
@@ -914,6 +920,12 @@
                 </c:pt>
                 <c:pt idx="6">
                   <c:v>0.1</c:v>
+                </c:pt>
+                <c:pt idx="7">
+                  <c:v>0.05</c:v>
+                </c:pt>
+                <c:pt idx="8">
+                  <c:v>0.89</c:v>
                 </c:pt>
               </c:numCache>
             </c:numRef>
@@ -966,9 +978,9 @@
           </c:dLbls>
           <c:cat>
             <c:multiLvlStrRef>
-              <c:f>Sheet1!$A$2:$A$8</c:f>
+              <c:f>Sheet1!$A$2:$A$10</c:f>
               <c:multiLvlStrCache>
-                <c:ptCount val="7"/>
+                <c:ptCount val="9"/>
                 <c:lvl>
                   <c:pt idx="0">
                     <c:v>Strong components</c:v>
@@ -991,16 +1003,22 @@
                   <c:pt idx="6">
                     <c:v>Negative costs</c:v>
                   </c:pt>
+                  <c:pt idx="7">
+                    <c:v>Hexagon search</c:v>
+                  </c:pt>
+                  <c:pt idx="8">
+                    <c:v>Spanning forest</c:v>
+                  </c:pt>
                 </c:lvl>
               </c:multiLvlStrCache>
             </c:multiLvlStrRef>
           </c:cat>
           <c:val>
             <c:numRef>
-              <c:f>Sheet1!$C$2:$C$8</c:f>
+              <c:f>Sheet1!$C$2:$C$10</c:f>
               <c:numCache>
                 <c:formatCode>General</c:formatCode>
-                <c:ptCount val="7"/>
+                <c:ptCount val="9"/>
                 <c:pt idx="0">
                   <c:v>0.34</c:v>
                 </c:pt>
@@ -1021,6 +1039,12 @@
                 </c:pt>
                 <c:pt idx="6">
                   <c:v>0.13</c:v>
+                </c:pt>
+                <c:pt idx="7">
+                  <c:v>0.54</c:v>
+                </c:pt>
+                <c:pt idx="8">
+                  <c:v>0.92</c:v>
                 </c:pt>
               </c:numCache>
             </c:numRef>
@@ -1250,7 +1274,7 @@
               <a:lstStyle/>
               <a:p>
                 <a:pPr>
-                  <a:defRPr b="0" i="0" strike="noStrike" sz="1100" u="none">
+                  <a:defRPr b="0" i="0" strike="noStrike" sz="1000" u="none">
                     <a:solidFill>
                       <a:srgbClr val="1A2421"/>
                     </a:solidFill>
@@ -1287,9 +1311,9 @@
           </c:marker>
           <c:cat>
             <c:multiLvlStrRef>
-              <c:f>Sheet1!$A$2:$A$21</c:f>
+              <c:f>Sheet1!$A$2:$A$23</c:f>
               <c:multiLvlStrCache>
-                <c:ptCount val="20"/>
+                <c:ptCount val="22"/>
                 <c:lvl>
                   <c:pt idx="0">
                     <c:v>v0</c:v>
@@ -1351,16 +1375,22 @@
                   <c:pt idx="19">
                     <c:v>neg. costs</c:v>
                   </c:pt>
+                  <c:pt idx="20">
+                    <c:v>injective</c:v>
+                  </c:pt>
+                  <c:pt idx="21">
+                    <c:v>forest</c:v>
+                  </c:pt>
                 </c:lvl>
               </c:multiLvlStrCache>
             </c:multiLvlStrRef>
           </c:cat>
           <c:val>
             <c:numRef>
-              <c:f>Sheet1!$B$2:$B$21</c:f>
+              <c:f>Sheet1!$B$2:$B$23</c:f>
               <c:numCache>
                 <c:formatCode>General</c:formatCode>
-                <c:ptCount val="20"/>
+                <c:ptCount val="22"/>
                 <c:pt idx="0">
                   <c:v>34</c:v>
                 </c:pt>
@@ -1421,6 +1451,12 @@
                 <c:pt idx="19">
                   <c:v>173</c:v>
                 </c:pt>
+                <c:pt idx="20">
+                  <c:v>176</c:v>
+                </c:pt>
+                <c:pt idx="21">
+                  <c:v>180</c:v>
+                </c:pt>
               </c:numCache>
             </c:numRef>
           </c:val>
@@ -1433,7 +1469,7 @@
             <a:lstStyle/>
             <a:p>
               <a:pPr>
-                <a:defRPr b="0" i="0" strike="noStrike" sz="1100" u="none">
+                <a:defRPr b="0" i="0" strike="noStrike" sz="1000" u="none">
                   <a:solidFill>
                     <a:srgbClr val="1A2421"/>
                   </a:solidFill>
@@ -2219,9 +2255,10 @@
           <a:p>
             <a:r>
               <a:rPr lang="en-US" dirty="0"/>
-              <a:t>Sources: docs/API_CONTRACT.md §4: Pattern; §6; git log 8b79971, 7b39f7d.
-pattern · trees: Tree patterns without dead ends. Theory: Variables bound by types (through the hierarchy) or explicit IDs, then steps, each one hop from an earlier variable; optional steps keep their row. Algorithm: Yannakakis' semi-join reduction: discover down, prune up, prune down. Rows in canonical order; the exact total is counted without listing (60⁴ rows in well under a second). Checked by: verify_result checks every row against the records; rows and totals match a brute-force enumerator (400 random patterns) and SCALE's own engine.
-pattern · cycles: Corroboration and contradiction motifs. Theory: A step may close a cycle between bound variables: two supports of a claim from one dataset, a triangle of citations. Algorithm: Worst-case optimal join (Ngo, Porat, Ré and Rudra; Veldhuizen's Leapfrog Triejoin): intersect candidates with what every closing step allows, smallest set first. Checked by: Row for row against a brute-force enumerator (300 random cyclic patterns). An interruption keeps a prefix of the rows and never denies.</a:t>
+              <a:t>Sources: docs/API_CONTRACT.md §4: Pattern, Injective patterns; §6; tests/test_injective_pattern.py; git log 8b79971, 7b39f7d, b7e4f12.
+pattern · trees: Tree patterns without dead ends. Theory: Variables bound by types (through the hierarchy) or IDs, then steps, each one hop from an earlier variable; optional steps keep their row. Algorithm: Yannakakis' semi-join reduction: discover down, prune up, prune down. Totals are counted exactly without listing the rows. Checked by: verify_result checks every row; rows and totals match a brute-force enumerator (400 random patterns) and SCALE's own engine. Rows come in canonical order; counting without listing handles 60⁴ rows in well under a second (git log 8b79971).
+pattern · cycles: Corroboration and contradiction motifs. Theory: A step may close a cycle between bound variables: two supports of a claim from one dataset, a triangle of citations. Algorithm: Worst-case optimal join (Ngo, Porat, Ré and Rudra; Leapfrog Triejoin): candidates meet what every closing step allows. Checked by: Row for row against a brute-force enumerator (300 random cyclic patterns). An interruption keeps a prefix of the rows, never denies. The join intersects a variable's candidates with what every closing step allows, iterating the smallest set first (Veldhuizen's Leapfrog Triejoin).
+pattern · injective: Substructure search. Theory: injective: true: distinct variables bind distinct nodes, distinct steps distinct edges. Motifs, catalytic sites, rings. No optional steps yet. Algorithm: Over the same Yannakakis-pruned candidates, skipping held nodes and used edges. NP-complete: budget-bounded; exact totals when done. Checked by: Brute force filtered for distinctness, row for row (400 random patterns); networkx's monomorphisms. Interrupted: no absence claimed. Subgraph monomorphism (docs/API_CONTRACT.md §4, Injective patterns): it counts every binding, so a pattern with automorphisms matches one subgraph several times (a hexagon twelve times). The rows are those of the same pattern without injective that use no node or edge twice, in the same canonical order. Distinctness is global, so no count along the kept hops respects it: an injective pattern, tree or cycle, is enumerated as a cycle's is, over the same semi-join-reduced candidates (a match with distinct nodes is a match). Totals are exact when the enumeration ends; an interruption leaves total null and claims no absence. No optional steps yet (unsupported, unsupported_mode): which node an optional step would bind among those left is not yet defined. The verifier and the contract checks reject a row that repeats a node or an edge. Every pattern request now states injective, so earlier pattern requests have new request and result IDs with the same answers (the golden workload's 160 pattern results regenerated). Row enumeration (cycles, injective patterns, tree rows) runs on an explicit stack: a Codex adversarial review found a 1,100-step chain hit Python's recursion limit. Tests (tests/test_injective_pattern.py): 400 random patterns row for row against the brute-force oracle filtered for distinctness; five shapes (a path, a star, a triangle, a square with a chord, a two-cycle) agree with networkx's subgraph monomorphisms (DiGraphMatcher); 3 hand-worked conformance cases. Benchmark (git log b7e4f12): 7,200 hexagon matches (600 rings × 12 symmetries) in a 1,300-atom graphene-like sheet in 0.05 s; networkx's GraphMatcher 0.54 s.</a:t>
             </a:r>
             <a:endParaRPr lang="en-US" dirty="0"/>
           </a:p>
@@ -2577,9 +2614,10 @@
           <a:p>
             <a:r>
               <a:rPr lang="en-US" dirty="0"/>
-              <a:t>Sources: docs/API_CONTRACT.md §4: Components, Biconnectivity; git log 99fb868.
-components: How a graph falls into pieces. Theory: Weak (hops either way: fragments) or strong (a walk each way: feedback loops, circular derivations), flagged initial, terminal and cyclic. A terminal class is one a walk never leaves. Algorithm: Breadth-first search (weak) or Tarjan's depth-first search (1972) for strong components. Linear time. Certificate proves: Spanning trees prove each listed component connected (strong: one out, one in); a closed partition in topological order proves nothing outside belongs with it.
-biconnectivity: Where a single failure splits a structure. Theory: Articulation points (with the pieces each leaves), bridges and blocks. Parallel edges are distinct links, so two between the same nodes are never bridges. Algorithm: One depth-first search with low points (Hopcroft and Tarjan, 1973). Linear time. Certificate proves: The depth-first forest: a checker confirms it is one, recomputes every low point from the records, and each claim follows.</a:t>
+              <a:t>Sources: docs/API_CONTRACT.md §4: Components, Biconnectivity, Spanning forest; §6; §7; tests/test_spanning_forest.py; git log 99fb868, 741c2dd.
+components: How a graph falls into pieces. Theory: Weak (fragments) or strong (feedback loops, circular derivations), flagged initial, terminal and cyclic. Algorithm: Breadth-first search (weak) or Tarjan's depth-first search (1972) for strong components. Linear time. Certificate proves: Spanning trees prove each listed component connected (strong: one out, one in); a closed partition in topological order proves nothing outside belongs with it. Weak: hops either way. Strong: a walk each way. A terminal class is one a walk never leaves.
+biconnectivity: Where a single failure splits a structure. Theory: Articulation points (with the pieces each leaves), bridges and blocks. Parallel edges are distinct links, never bridges. Algorithm: One depth-first search with low points (Hopcroft and Tarjan, 1973). Linear time. Certificate proves: The depth-first forest: a checker confirms it is one, recomputes every low point from the records, and each claim follows. Parallel edges are distinct links, so two between the same nodes are never bridges.
+spanning_forest: Backbones, single-linkage clusters. Theory: The minimum (or maximum) spanning forest: one tree per piece. Any finite exact weights; ties go to the smaller edge ID. Algorithm: Kruskal (1956) with a union-find, links in the order of (weight, edge ID): the forest is unique in that order. Proves itself by: Tarjan's cycle property: each link left out comes after every edge of its tree path (path maxima by binary lifting). Revalidation re-checks it. docs/API_CONTRACT.md §4, Spanning forest: each edge in scope is a link between its ends, whichever way the scope follows it; a loop never joins anything; a node with no link is a tree of its own. Weights are compared exactly (floats as exact rationals, negatives allowed); without weights every link weighs 1 and the forest is the first in edge ID order. objective max takes weights descending, then edge ID. Reading each node's links is one expansion; an interrupted search claims nothing (every field null). Answer: the forest's edges in ascending ID, their count, the number of trees and the exact total weight. No certificate is needed: links in scope with no cycle, spanning every piece, and every link left out after every edge of its tree path in that order, are the forest Kruskal's algorithm keeps; the verifier finds those path maxima by binary lifting in O((n + m) log n). Revalidation (§7) re-verifies these claims on the new records, so a lighter or earlier new link refutes a cached forest. A Codex adversarial review found that the verifier skipped a forest given as a tuple (a Result's frozen answer), which let a stale forest revalidate as holding; fixed, with regression tests (a Result, a plain dict, a frozen answer). Tests (tests/test_spanning_forest.py): 800 random cases agree with an independent Kruskal; weights and trees agree with networkx's minimum and maximum spanning edges; forged forests are refused (ties, gaps, cycles, loops, weights, objective); revalidation agrees with fresh runs on 400 random edits; 4 hand-worked conformance cases. Benchmark (git log 741c2dd): 100,000 nodes and 300,000 edges in 0.89 s (networkx minimum_spanning_edges: 0.92 s); the verifier proves the forest in 3.05 s.</a:t>
             </a:r>
             <a:endParaRPr lang="en-US" dirty="0"/>
           </a:p>
@@ -2846,7 +2884,7 @@
           <a:p>
             <a:r>
               <a:rPr lang="en-US" dirty="0"/>
-              <a:t>Sources: git log e365fdc, 0a58767, 05d3ea5, 1d6dbbf, 83f9ffe, 297ca1e; README.md (Revalidation); docs/API_CONTRACT.md §7 (verdicts and reasons). With one diff of the projections, each result is checked in time proportional to the edit (binary search in the answer's canonical lists). On 700 random edits the diff and full checks give the same record and every 'holds' matches a fresh run. Measured on a heavily loaded machine. Revalidation by certificate (0a58767, extended in 05d3ea5): components, biconnectivity, max_flow, matching, dominators and incidence are always checked in full: a node or edge the answer names that is gone refutes it (node_gone, witness_gone); a claim the new records contradict refutes it (answer_refuted); otherwise it holds exactly when the certificate still checks (as verify_result checks it), and is unknown (certificate_broken) when it does not, or (no_certificate) when it has none. Tested on 600 random edits: whenever a result holds, a fresh run gives the same canonical answer.</a:t>
+              <a:t>Sources: git log e365fdc, 0a58767, 05d3ea5, 1d6dbbf, 83f9ffe, 297ca1e, 741c2dd; README.md (Revalidation); docs/API_CONTRACT.md §7 (a spanning forest holds while its links, the cycle property and the pieces it spans still check, as verify_result checks them; an edit that breaks any of these refutes it) (verdicts and reasons). With one diff of the projections, each result is checked in time proportional to the edit (binary search in the answer's canonical lists). On 700 random edits the diff and full checks give the same record and every 'holds' matches a fresh run. Measured on a heavily loaded machine. Revalidation by certificate (0a58767, extended in 05d3ea5): components, biconnectivity, max_flow, matching, dominators and incidence are always checked in full: a node or edge the answer names that is gone refutes it (node_gone, witness_gone); a claim the new records contradict refutes it (answer_refuted); otherwise it holds exactly when the certificate still checks (as verify_result checks it), and is unknown (certificate_broken) when it does not, or (no_certificate) when it has none. Tested on 600 random edits: whenever a result holds, a fresh run gives the same canonical answer.</a:t>
             </a:r>
             <a:endParaRPr lang="en-US" dirty="0"/>
           </a:p>
@@ -3022,7 +3060,7 @@
           <a:p>
             <a:r>
               <a:rPr lang="en-US" dirty="0"/>
-              <a:t>Counts as of this build: python3 -m pytest (563 pass), src/graph_runtime/conformance/cases.json (173 cases), SCALE parity (16 tests) and STATES parity (6 tests) in their environments; 73 / 73 real consumer requests answer the same with both engines (git log f144c48). Oracles: tests/oracle.py; regular paths against Brzozowski derivatives on 1,500 random graphs (git log f65497b); PageRank against the exact linear system over fractions on 500 graphs (git log 0d4d2b3); negative costs against an independent fixpoint on 1,500 random graphs (tests/test_negative_costs.py). Parity: docs/SCALE_INTEGRATION.md, docs/STATES_INTEGRATION.md. Reviews: git log 8917563, 7ff04db; Codex adversarial reviews before commit: 99fb868 (a request field named kind was overwritten by the digest's record kind, now connectivity; unlisted groups and stray trees in the components certificate), 573ce2b (an interrupted max flow's upper bound was not verified), 1e8678d, 05d3ea5, 1d6dbbf, 04532ba, 107dc68, 297ca1e; 97723bb and 260d7b2 (negative costs and the faster projection identity, reviewed together: no soundness or identity counterexample, 12,000 larger random graphs all matching an independent oracle; one medium issue, diff-based revalidation reading the whole certificate even for an unrelated edit, fixed, and a regression test now forbids it).</a:t>
+              <a:t>Counts as of this build: python3 -m pytest (582 pass), src/graph_runtime/conformance/cases.json (180 cases), SCALE parity (16 tests) and STATES parity (6 tests) in their environments; 73 / 73 real consumer requests answer the same with both engines (git log f144c48). Oracles: tests/oracle.py; regular paths against Brzozowski derivatives on 1,500 random graphs (git log f65497b); PageRank against the exact linear system over fractions on 500 graphs (git log 0d4d2b3); negative costs against an independent fixpoint on 1,500 random graphs (tests/test_negative_costs.py). Parity: docs/SCALE_INTEGRATION.md, docs/STATES_INTEGRATION.md. Reviews: git log 8917563, 7ff04db; Codex adversarial reviews before commit: 99fb868 (a request field named kind was overwritten by the digest's record kind, now connectivity; unlisted groups and stray trees in the components certificate), 573ce2b (an interrupted max flow's upper bound was not verified), 1e8678d, 05d3ea5, 1d6dbbf, 04532ba, 107dc68, 297ca1e; 97723bb and 260d7b2 (negative costs and the faster projection identity, reviewed together: no soundness or identity counterexample, 12,000 larger random graphs all matching an independent oracle; one medium issue, diff-based revalidation reading the whole certificate even for an unrelated edit, fixed, and a regression test now forbids it); b7e4f12 (injective patterns: a 1,100-step chain hit Python's recursion limit, so row enumeration for cycles, injective patterns and tree rows now runs on an explicit stack, with a regression test covering rows, count and exists); 741c2dd (spanning forests: the verifier skipped a forest given as a tuple, a Result's frozen answer, which let a stale forest revalidate as holding; it now checks tuples and refuses a missing edge list, and so do three other list-only checks; regression tests cover a Result, a plain dict and a frozen answer).</a:t>
             </a:r>
             <a:endParaRPr lang="en-US" dirty="0"/>
           </a:p>
@@ -3203,7 +3241,7 @@
           <a:p>
             <a:r>
               <a:rPr lang="en-US" dirty="0"/>
-              <a:t>Left: docs/STATES_INTEGRATION.md, Cost (benchmarks/consumers.py, 26 October 2026). Mean of 42 contexts: STATES's extract_context 58.5 ms; GRAPH through a lift 305 ms (222 ms lift + 0.34 ms query); GRAPH on the cell 17.1 ms (10.6 ms projection + 0.76 ms query). The cell's projection depends only on the record, so it can be built once and reused. Heavily loaded machine: compare ratios. Right: Structure benchmark (99fb868 increment), git log 573ce2b, 1e8678d and 1d6dbbf; flows, matching, dominators and critical path measured on the owner's machine. Also: weak components 0.45 s, unit-capacity max flow 3.8 s. Negative costs (git log 97723bb; measured on an Apple M4): 20,000 nodes and 100,000 edges, 31% negative, no negative cycle; GRAPH 0.10 s with its feasible-potentials certificate, networkx bellman_ford 0.13 s and goldberg_radzik 0.39 s, the same cost. With a negative cycle planted near the source, networkx find_negative_cycle takes 0.002 s and GRAPH 0.042 s: GRAPH first computes the corridor between the sources and the targets (one linear pass), so that a cycle that cannot reach a target is ignored. Articulation points: GRAPH's biconnectivity (which also finds bridges) against networkx's articulation_points; max flow: 5 sources, 5 targets, integer capacities, against networkx maximum_flow_value; matching: against networkx hopcroft_karp_matching; dominators: against networkx immediate_dominators (GRAPH 0.65 s, 1.37 s with the low-high certificate). GRAPH's answers come with certificates.</a:t>
+              <a:t>Left: docs/STATES_INTEGRATION.md, Cost (benchmarks/consumers.py, 26 October 2026). Mean of 42 contexts: STATES's extract_context 58.5 ms; GRAPH through a lift 305 ms (222 ms lift + 0.34 ms query); GRAPH on the cell 17.1 ms (10.6 ms projection + 0.76 ms query). The cell's projection depends only on the record, so it can be built once and reused. Heavily loaded machine: compare ratios. Right: Structure benchmark (99fb868 increment), git log 573ce2b, 1e8678d and 1d6dbbf; flows, matching, dominators and critical path measured on the owner's machine. Also: weak components 0.45 s, unit-capacity max flow 3.8 s. Negative costs (git log 97723bb; measured on an Apple M4): 20,000 nodes and 100,000 edges, 31% negative, no negative cycle; GRAPH 0.10 s with its feasible-potentials certificate, networkx bellman_ford 0.13 s and goldberg_radzik 0.39 s, the same cost. With a negative cycle planted near the source, networkx find_negative_cycle takes 0.002 s and GRAPH 0.042 s: GRAPH first computes the corridor between the sources and the targets (one linear pass), so that a cycle that cannot reach a target is ignored. Hexagon search (git log b7e4f12): an injective six-ring pattern counted in a graphene-like sheet of 1,300 atoms (networkx hexagonal_lattice_graph(20, 30)), 7,200 matches, 600 rings × 12 symmetries, GRAPH 0.05 s, networkx GraphMatcher's subgraph monomorphisms 0.54 s. Spanning forest (git log 741c2dd): 100,000 nodes and 300,000 random edges with integer weights, GRAPH 0.89 s, networkx minimum_spanning_edges (Kruskal) 0.92 s on the same multigraph; GRAPH's verifier proves the forest in 3.05 s. Machine load for these two was not recorded in the commits. Articulation points: GRAPH's biconnectivity (which also finds bridges) against networkx's articulation_points; max flow: 5 sources, 5 targets, integer capacities, against networkx maximum_flow_value; matching: against networkx hopcroft_karp_matching; dominators: against networkx immediate_dominators (GRAPH 0.65 s, 1.37 s with the low-high certificate). GRAPH's answers come with certificates.</a:t>
             </a:r>
             <a:endParaRPr lang="en-US" dirty="0"/>
           </a:p>
@@ -3379,7 +3417,7 @@
           <a:p>
             <a:r>
               <a:rPr lang="en-US" dirty="0"/>
-              <a:t>Source: git log, 550c362 (25 October, 17:17) to 97723bb (26 October, 22:11): 37 commits, slide commits included; some rows group neighbouring commits, and 22:11 is two (260d7b2, the projection identity hashed with each node ID, relation and type encoded once: 61 to 34 ms, the build 245 to 206 ms on 50,000 nodes and 150,000 edges, identity bytes unchanged on 400 random projections; 97723bb, negative costs). Conformance case counts are from the commit messages (34 at v0, then 49, 54, 62, 70, 74, 78, 91, 100, 112, 116, 121, 133, 143, 148, 153, 158, 165, 168) and cases.json now (173). Tests: 178 → 563. Commit times are local (-0400).</a:t>
+              <a:t>Source: git log, 550c362 (25 October, 17:17) to 741c2dd (26 October, 22:55): 40 commits, slide commits included; some rows group neighbouring commits (11:16 is incidence, 05d3ea5, with critical paths at 11:32, 1d6dbbf, and d-separation at 11:44, 83f9ffe; 17:45 is the fixes from a review of the day's increments, 107dc68, with support certificates at 18:23, 297ca1e), and 22:11 is two (260d7b2, the projection identity hashed with each node ID, relation and type encoded once: 61 to 34 ms, the build 245 to 206 ms on 50,000 nodes and 150,000 edges, identity bytes unchanged on 400 random projections; 97723bb, negative costs). Conformance case counts are from the commit messages (34 at v0, then 49, 54, 62, 70, 74, 78, 91, 100, 112, 116, 121, 133, 143, 148, 153, 158, 165, 168, 173, 176) and cases.json now (180). Tests: 178 → 582. Commit times are local (-0400).</a:t>
             </a:r>
             <a:endParaRPr lang="en-US" dirty="0"/>
           </a:p>
@@ -3467,7 +3505,7 @@
           <a:p>
             <a:r>
               <a:rPr lang="en-US" dirty="0"/>
-              <a:t>Sources: A Codex literature survey of 26 October 2026, kept outside the repository; its recommended order weighs scientific usefulness, implementation effort and the cost of independently proving each answer. Its first item, negative-cost shortest paths, shipped in 97723bb. Survey notes per row: injective patterns (VF2++-style backtracking with Glasgow-style filtering; embeddings checked in O(q + r); a negative needs an exhaustive refutation tree, possibly exponential); minimum spanning forest (Kruskal; the forest is its own certificate by the cycle property); minimum cycle basis (de Pina; GF(2) elimination proves a basis, de Pina's supports with shortest-path proofs prove minimality; relevant cycles after Vismara); min-cost flow and weighted matching (successive shortest paths with potentials; reduced costs non-negative on every residual arc); cyclic pattern counting (variable elimination, FAQ InsideOut; a decomposition and dynamic-programming transcript); k shortest simple paths (Yen with Lawler's partitioning; a partition tree proves the ranking); then a reachability index (pruned landmark 2-hop labels; Cohen, Halperin, Kaplan and Zwick 2003), positive Datalog (semi-naive evaluation; derivation trees), isomorphism and canonical labeling (individualization-refinement; McKay and Piperno 2014), elementary flux modes (exact double description; Gagneur and Klamt 2004). Each increment is planned to ship with code, docs/API_CONTRACT.md, the schema, hand-worked conformance cases, tests against an independent oracle, verification and revalidation, and a Codex adversarial review of its diff.</a:t>
+              <a:t>Sources: A Codex literature survey of 26 October 2026, kept outside the repository; its recommended order weighs scientific usefulness, implementation effort and the cost of independently proving each answer. Its first three items have shipped: negative-cost shortest paths (97723bb); injective patterns (b7e4f12: the survey suggested VF2++-style backtracking with Glasgow-style filtering, embeddings checked in O(q + r), a negative needing an exhaustive refutation tree; GRAPH enumerates over its Yannakakis-pruned candidates, budget-bounded, and an interrupted search claims no absence); and the minimum spanning forest (741c2dd: Kruskal, the forest its own certificate by the cycle property). The fourth, minimum cycle basis (ring perception), is being built. Survey notes per row: minimum cycle basis (de Pina; GF(2) elimination proves a basis, de Pina's supports with shortest-path proofs prove minimality; relevant cycles after Vismara); min-cost flow and weighted matching (successive shortest paths with potentials; reduced costs non-negative on every residual arc); cyclic pattern counting (variable elimination, FAQ InsideOut; a decomposition and dynamic-programming transcript); k shortest simple paths (Yen with Lawler's partitioning; a partition tree proves the ranking); reachability index (strong components condensed, then pruned landmark 2-hop labels; Cohen, Halperin, Kaplan and Zwick 2003; Akiba, Iwata and Yoshida 2013; a positive expands hub routing pointers into ordinary hops, checked in the walk's length; disjoint labels alone do not prove a negative, which needs a closed set); positive Datalog (range-restricted, function-free, semi-naive evaluation; a derivation tree or DAG with strictly increasing ranks, checked in the proof's size; Abiteboul, Hull and Vianu 1995; Green, Karvounarakis and Tannen 2007, provenance semirings); then isomorphism and canonical labeling (individualization-refinement; McKay and Piperno 2014) and elementary flux modes (exact double description; Gagneur and Klamt 2004). Each increment is planned to ship with code, docs/API_CONTRACT.md, the schema, hand-worked conformance cases, tests against an independent oracle, verification and revalidation, and a Codex adversarial review of its diff.</a:t>
             </a:r>
             <a:endParaRPr lang="en-US" dirty="0"/>
           </a:p>
@@ -4083,7 +4121,7 @@
           <a:p>
             <a:r>
               <a:rPr lang="en-US" dirty="0"/>
-              <a:t>Source: src/graph_runtime/request.py (OPERATIONS: 19 names), docs/API_CONTRACT.md §2 and §4. Periodic projections are a kind of projection, not an operation: reachability and dependency impact run on them, and periodicity runs only on them.</a:t>
+              <a:t>Source: src/graph_runtime/request.py (OPERATIONS: 20 names), docs/API_CONTRACT.md §2 and §4. Periodic projections are a kind of projection, not an operation: reachability and dependency impact run on them, and periodicity runs only on them.</a:t>
             </a:r>
             <a:endParaRPr lang="en-US" dirty="0"/>
           </a:p>
@@ -7856,7 +7894,7 @@
                   <a:schemeClr val="tx1"/>
                 </a:solidFill>
               </a:rPr>
-              <a:t>Patterns: multi-step questions</a:t>
+              <a:t>Patterns: multi-step questions, substructures</a:t>
             </a:r>
             <a:endParaRPr lang="en-US" sz="3400" dirty="0"/>
           </a:p>
@@ -7894,7 +7932,7 @@
                   <a:schemeClr val="accent6"/>
                 </a:solidFill>
               </a:rPr>
-              <a:t>SCALE's query plans in generic form: variables, steps, optional steps; trees and cycles.</a:t>
+              <a:t>SCALE's query plans in generic form: variables, steps, optional steps; trees, cycles and injective matches.</a:t>
             </a:r>
             <a:endParaRPr lang="en-US" sz="1600" dirty="0"/>
           </a:p>
@@ -7909,11 +7947,11 @@
         <p:spPr>
           <a:xfrm>
             <a:off x="548640" y="1691640"/>
-            <a:ext cx="5410048" cy="4526280"/>
+            <a:ext cx="3515258" cy="4526280"/>
           </a:xfrm>
           <a:prstGeom prst="roundRect">
             <a:avLst>
-              <a:gd name="adj" fmla="val 2020"/>
+              <a:gd name="adj" fmla="val 2601"/>
             </a:avLst>
           </a:prstGeom>
           <a:solidFill>
@@ -7975,7 +8013,7 @@
         <p:spPr>
           <a:xfrm>
             <a:off x="1408176" y="1874520"/>
-            <a:ext cx="4349344" cy="548640"/>
+            <a:ext cx="2454554" cy="693801"/>
           </a:xfrm>
           <a:prstGeom prst="rect">
             <a:avLst/>
@@ -8027,8 +8065,8 @@
         </p:nvSpPr>
         <p:spPr>
           <a:xfrm>
-            <a:off x="749808" y="2569464"/>
-            <a:ext cx="5007712" cy="2118360"/>
+            <a:off x="749808" y="2714625"/>
+            <a:ext cx="3112922" cy="1849247"/>
           </a:xfrm>
           <a:prstGeom prst="rect">
             <a:avLst/>
@@ -8042,12 +8080,12 @@
           <a:p>
             <a:pPr indent="0" marL="0">
               <a:spcAft>
-                <a:spcPts val="960"/>
+                <a:spcPts val="840"/>
               </a:spcAft>
               <a:buNone/>
             </a:pPr>
             <a:r>
-              <a:rPr lang="en-US" sz="1600" b="1" dirty="0">
+              <a:rPr lang="en-US" sz="1400" b="1" dirty="0">
                 <a:solidFill>
                   <a:schemeClr val="accent1"/>
                 </a:solidFill>
@@ -8056,26 +8094,26 @@
             </a:r>
             <a:pPr indent="0" marL="0">
               <a:spcAft>
-                <a:spcPts val="960"/>
+                <a:spcPts val="840"/>
               </a:spcAft>
               <a:buNone/>
             </a:pPr>
             <a:r>
-              <a:rPr lang="en-US" sz="1600" dirty="0">
+              <a:rPr lang="en-US" sz="1400" dirty="0">
                 <a:solidFill>
                   <a:schemeClr val="tx1"/>
                 </a:solidFill>
               </a:rPr>
-              <a:t>Variables bound by types (through the hierarchy) or explicit IDs, then steps, each one hop from an earlier variable; optional steps keep their row.</a:t>
-            </a:r>
-            <a:endParaRPr lang="en-US" sz="1600" dirty="0"/>
-          </a:p>
-          <a:p>
-            <a:pPr indent="0" marL="0">
-              <a:buNone/>
-            </a:pPr>
-            <a:r>
-              <a:rPr lang="en-US" sz="1600" b="1" dirty="0">
+              <a:t>Variables bound by types (through the hierarchy) or IDs, then steps, each one hop from an earlier variable; optional steps keep their row.</a:t>
+            </a:r>
+            <a:endParaRPr lang="en-US" sz="1400" dirty="0"/>
+          </a:p>
+          <a:p>
+            <a:pPr indent="0" marL="0">
+              <a:buNone/>
+            </a:pPr>
+            <a:r>
+              <a:rPr lang="en-US" sz="1400" b="1" dirty="0">
                 <a:solidFill>
                   <a:schemeClr val="accent1"/>
                 </a:solidFill>
@@ -8086,14 +8124,14 @@
               <a:buNone/>
             </a:pPr>
             <a:r>
-              <a:rPr lang="en-US" sz="1600" dirty="0">
+              <a:rPr lang="en-US" sz="1400" dirty="0">
                 <a:solidFill>
                   <a:schemeClr val="tx1"/>
                 </a:solidFill>
               </a:rPr>
-              <a:t>Yannakakis' semi-join reduction: discover down, prune up, prune down. Rows in canonical order; the exact total is counted without listing (60⁴ rows in well under a second).</a:t>
-            </a:r>
-            <a:endParaRPr lang="en-US" sz="1600" dirty="0"/>
+              <a:t>Yannakakis' semi-join reduction: discover down, prune up, prune down. Totals are counted exactly without listing the rows.</a:t>
+            </a:r>
+            <a:endParaRPr lang="en-US" sz="1400" dirty="0"/>
           </a:p>
         </p:txBody>
       </p:sp>
@@ -8105,12 +8143,12 @@
         </p:nvSpPr>
         <p:spPr>
           <a:xfrm>
-            <a:off x="694944" y="4760976"/>
-            <a:ext cx="5117440" cy="1255776"/>
+            <a:off x="694944" y="4637024"/>
+            <a:ext cx="3222650" cy="1379728"/>
           </a:xfrm>
           <a:prstGeom prst="roundRect">
             <a:avLst>
-              <a:gd name="adj" fmla="val 5825"/>
+              <a:gd name="adj" fmla="val 5302"/>
             </a:avLst>
           </a:prstGeom>
           <a:solidFill>
@@ -8140,7 +8178,7 @@
         </p:blipFill>
         <p:spPr>
           <a:xfrm>
-            <a:off x="804672" y="4852416"/>
+            <a:off x="804672" y="4728464"/>
             <a:ext cx="246888" cy="246888"/>
           </a:xfrm>
           <a:prstGeom prst="rect">
@@ -8156,8 +8194,8 @@
         </p:nvSpPr>
         <p:spPr>
           <a:xfrm>
-            <a:off x="1133856" y="4852416"/>
-            <a:ext cx="4550512" cy="246888"/>
+            <a:off x="1133856" y="4728464"/>
+            <a:ext cx="2655722" cy="246888"/>
           </a:xfrm>
           <a:prstGeom prst="rect">
             <a:avLst/>
@@ -8192,8 +8230,8 @@
         </p:nvSpPr>
         <p:spPr>
           <a:xfrm>
-            <a:off x="804672" y="5145024"/>
-            <a:ext cx="4897984" cy="798576"/>
+            <a:off x="804672" y="5021072"/>
+            <a:ext cx="3003194" cy="922528"/>
           </a:xfrm>
           <a:prstGeom prst="rect">
             <a:avLst/>
@@ -8209,7 +8247,7 @@
               <a:buNone/>
             </a:pPr>
             <a:r>
-              <a:rPr lang="en-US" sz="1500" dirty="0">
+              <a:rPr lang="en-US" sz="1300" dirty="0">
                 <a:solidFill>
                   <a:schemeClr val="tx1"/>
                 </a:solidFill>
@@ -8223,14 +8261,14 @@
               <a:buNone/>
             </a:pPr>
             <a:r>
-              <a:rPr lang="en-US" sz="1600" dirty="0">
+              <a:rPr lang="en-US" sz="1400" dirty="0">
                 <a:solidFill>
                   <a:schemeClr val="tx1"/>
                 </a:solidFill>
               </a:rPr>
-              <a:t> checks every row against the records; rows and totals match a brute-force enumerator (400 random patterns) and SCALE's own engine.</a:t>
-            </a:r>
-            <a:endParaRPr lang="en-US" sz="1500" dirty="0"/>
+              <a:t> checks every row; rows and totals match a brute-force enumerator (400 random patterns) and SCALE's own engine.</a:t>
+            </a:r>
+            <a:endParaRPr lang="en-US" sz="1300" dirty="0"/>
           </a:p>
         </p:txBody>
       </p:sp>
@@ -8242,12 +8280,12 @@
         </p:nvSpPr>
         <p:spPr>
           <a:xfrm>
-            <a:off x="6233008" y="1691640"/>
-            <a:ext cx="5410048" cy="4526280"/>
+            <a:off x="4338218" y="1691640"/>
+            <a:ext cx="3515258" cy="4526280"/>
           </a:xfrm>
           <a:prstGeom prst="roundRect">
             <a:avLst>
-              <a:gd name="adj" fmla="val 2020"/>
+              <a:gd name="adj" fmla="val 2601"/>
             </a:avLst>
           </a:prstGeom>
           <a:solidFill>
@@ -8264,7 +8302,7 @@
         </p:nvSpPr>
         <p:spPr>
           <a:xfrm>
-            <a:off x="6434176" y="1892808"/>
+            <a:off x="4539386" y="1892808"/>
             <a:ext cx="512064" cy="512064"/>
           </a:xfrm>
           <a:prstGeom prst="ellipse">
@@ -8292,7 +8330,7 @@
         </p:blipFill>
         <p:spPr>
           <a:xfrm>
-            <a:off x="6546830" y="2005462"/>
+            <a:off x="4652040" y="2005462"/>
             <a:ext cx="286756" cy="286756"/>
           </a:xfrm>
           <a:prstGeom prst="rect">
@@ -8308,8 +8346,8 @@
         </p:nvSpPr>
         <p:spPr>
           <a:xfrm>
-            <a:off x="7092544" y="1874520"/>
-            <a:ext cx="4349344" cy="548640"/>
+            <a:off x="5197754" y="1874520"/>
+            <a:ext cx="2454554" cy="693801"/>
           </a:xfrm>
           <a:prstGeom prst="rect">
             <a:avLst/>
@@ -8361,8 +8399,8 @@
         </p:nvSpPr>
         <p:spPr>
           <a:xfrm>
-            <a:off x="6434176" y="2569464"/>
-            <a:ext cx="5007712" cy="2118360"/>
+            <a:off x="4539386" y="2714625"/>
+            <a:ext cx="3112922" cy="1849247"/>
           </a:xfrm>
           <a:prstGeom prst="rect">
             <a:avLst/>
@@ -8376,12 +8414,12 @@
           <a:p>
             <a:pPr indent="0" marL="0">
               <a:spcAft>
-                <a:spcPts val="960"/>
+                <a:spcPts val="840"/>
               </a:spcAft>
               <a:buNone/>
             </a:pPr>
             <a:r>
-              <a:rPr lang="en-US" sz="1600" b="1" dirty="0">
+              <a:rPr lang="en-US" sz="1400" b="1" dirty="0">
                 <a:solidFill>
                   <a:schemeClr val="accent1"/>
                 </a:solidFill>
@@ -8390,26 +8428,26 @@
             </a:r>
             <a:pPr indent="0" marL="0">
               <a:spcAft>
-                <a:spcPts val="960"/>
+                <a:spcPts val="840"/>
               </a:spcAft>
               <a:buNone/>
             </a:pPr>
             <a:r>
-              <a:rPr lang="en-US" sz="1600" dirty="0">
+              <a:rPr lang="en-US" sz="1400" dirty="0">
                 <a:solidFill>
                   <a:schemeClr val="tx1"/>
                 </a:solidFill>
               </a:rPr>
               <a:t>A step may close a cycle between bound variables: two supports of a claim from one dataset, a triangle of citations.</a:t>
             </a:r>
-            <a:endParaRPr lang="en-US" sz="1600" dirty="0"/>
-          </a:p>
-          <a:p>
-            <a:pPr indent="0" marL="0">
-              <a:buNone/>
-            </a:pPr>
-            <a:r>
-              <a:rPr lang="en-US" sz="1600" b="1" dirty="0">
+            <a:endParaRPr lang="en-US" sz="1400" dirty="0"/>
+          </a:p>
+          <a:p>
+            <a:pPr indent="0" marL="0">
+              <a:buNone/>
+            </a:pPr>
+            <a:r>
+              <a:rPr lang="en-US" sz="1400" b="1" dirty="0">
                 <a:solidFill>
                   <a:schemeClr val="accent1"/>
                 </a:solidFill>
@@ -8420,14 +8458,14 @@
               <a:buNone/>
             </a:pPr>
             <a:r>
-              <a:rPr lang="en-US" sz="1600" dirty="0">
+              <a:rPr lang="en-US" sz="1400" dirty="0">
                 <a:solidFill>
                   <a:schemeClr val="tx1"/>
                 </a:solidFill>
               </a:rPr>
-              <a:t>Worst-case optimal join (Ngo, Porat, Ré and Rudra; Veldhuizen's Leapfrog Triejoin): intersect candidates with what every closing step allows, smallest set first.</a:t>
-            </a:r>
-            <a:endParaRPr lang="en-US" sz="1600" dirty="0"/>
+              <a:t>Worst-case optimal join (Ngo, Porat, Ré and Rudra; Leapfrog Triejoin): candidates meet what every closing step allows.</a:t>
+            </a:r>
+            <a:endParaRPr lang="en-US" sz="1400" dirty="0"/>
           </a:p>
         </p:txBody>
       </p:sp>
@@ -8439,12 +8477,12 @@
         </p:nvSpPr>
         <p:spPr>
           <a:xfrm>
-            <a:off x="6379312" y="4760976"/>
-            <a:ext cx="5117440" cy="1255776"/>
+            <a:off x="4484522" y="4637024"/>
+            <a:ext cx="3222650" cy="1379728"/>
           </a:xfrm>
           <a:prstGeom prst="roundRect">
             <a:avLst>
-              <a:gd name="adj" fmla="val 5825"/>
+              <a:gd name="adj" fmla="val 5302"/>
             </a:avLst>
           </a:prstGeom>
           <a:solidFill>
@@ -8474,7 +8512,7 @@
         </p:blipFill>
         <p:spPr>
           <a:xfrm>
-            <a:off x="6489040" y="4852416"/>
+            <a:off x="4594250" y="4728464"/>
             <a:ext cx="246888" cy="246888"/>
           </a:xfrm>
           <a:prstGeom prst="rect">
@@ -8490,8 +8528,8 @@
         </p:nvSpPr>
         <p:spPr>
           <a:xfrm>
-            <a:off x="6818224" y="4852416"/>
-            <a:ext cx="4550512" cy="246888"/>
+            <a:off x="4923434" y="4728464"/>
+            <a:ext cx="2655722" cy="246888"/>
           </a:xfrm>
           <a:prstGeom prst="rect">
             <a:avLst/>
@@ -8526,8 +8564,8 @@
         </p:nvSpPr>
         <p:spPr>
           <a:xfrm>
-            <a:off x="6489040" y="5145024"/>
-            <a:ext cx="4897984" cy="798576"/>
+            <a:off x="4594250" y="5021072"/>
+            <a:ext cx="3003194" cy="922528"/>
           </a:xfrm>
           <a:prstGeom prst="rect">
             <a:avLst/>
@@ -8543,14 +8581,351 @@
               <a:buNone/>
             </a:pPr>
             <a:r>
-              <a:rPr lang="en-US" sz="1600" dirty="0">
+              <a:rPr lang="en-US" sz="1400" dirty="0">
                 <a:solidFill>
                   <a:schemeClr val="tx1"/>
                 </a:solidFill>
               </a:rPr>
-              <a:t>Row for row against a brute-force enumerator (300 random cyclic patterns). An interruption keeps a prefix of the rows and never denies.</a:t>
-            </a:r>
-            <a:endParaRPr lang="en-US" sz="1600" dirty="0"/>
+              <a:t>Row for row against a brute-force enumerator (300 random cyclic patterns). An interruption keeps a prefix of the rows, never denies.</a:t>
+            </a:r>
+            <a:endParaRPr lang="en-US" sz="1400" dirty="0"/>
+          </a:p>
+        </p:txBody>
+      </p:sp>
+      <p:sp>
+        <p:nvSpPr>
+          <p:cNvPr id="22" name="operation pattern · injective"/>
+          <p:cNvSpPr/>
+          <p:nvPr/>
+        </p:nvSpPr>
+        <p:spPr>
+          <a:xfrm>
+            <a:off x="8127797" y="1691640"/>
+            <a:ext cx="3515258" cy="4526280"/>
+          </a:xfrm>
+          <a:prstGeom prst="roundRect">
+            <a:avLst>
+              <a:gd name="adj" fmla="val 2601"/>
+            </a:avLst>
+          </a:prstGeom>
+          <a:solidFill>
+            <a:schemeClr val="bg2"/>
+          </a:solidFill>
+          <a:ln/>
+        </p:spPr>
+      </p:sp>
+      <p:sp>
+        <p:nvSpPr>
+          <p:cNvPr id="23" name="icon pattern · injective"/>
+          <p:cNvSpPr/>
+          <p:nvPr/>
+        </p:nvSpPr>
+        <p:spPr>
+          <a:xfrm>
+            <a:off x="8328965" y="1892808"/>
+            <a:ext cx="512064" cy="512064"/>
+          </a:xfrm>
+          <a:prstGeom prst="ellipse">
+            <a:avLst/>
+          </a:prstGeom>
+          <a:solidFill>
+            <a:schemeClr val="accent1"/>
+          </a:solidFill>
+          <a:ln/>
+        </p:spPr>
+      </p:sp>
+      <p:pic>
+        <p:nvPicPr>
+          <p:cNvPr id="24" name="Image 4" descr="pattern · injective">    </p:cNvPr>
+          <p:cNvPicPr>
+            <a:picLocks noChangeAspect="1"/>
+          </p:cNvPicPr>
+          <p:nvPr/>
+        </p:nvPicPr>
+        <p:blipFill>
+          <a:blip r:embed="rId5"/>
+          <a:stretch>
+            <a:fillRect/>
+          </a:stretch>
+        </p:blipFill>
+        <p:spPr>
+          <a:xfrm>
+            <a:off x="8441619" y="2005462"/>
+            <a:ext cx="286756" cy="286756"/>
+          </a:xfrm>
+          <a:prstGeom prst="rect">
+            <a:avLst/>
+          </a:prstGeom>
+        </p:spPr>
+      </p:pic>
+      <p:sp>
+        <p:nvSpPr>
+          <p:cNvPr id="25" name="Text 18"/>
+          <p:cNvSpPr txBox="1"/>
+          <p:nvPr/>
+        </p:nvSpPr>
+        <p:spPr>
+          <a:xfrm>
+            <a:off x="8987333" y="1874520"/>
+            <a:ext cx="2454554" cy="548640"/>
+          </a:xfrm>
+          <a:prstGeom prst="rect">
+            <a:avLst/>
+          </a:prstGeom>
+          <a:noFill/>
+          <a:ln/>
+        </p:spPr>
+        <p:txBody>
+          <a:bodyPr wrap="square" lIns="0" tIns="0" rIns="0" bIns="0" rtlCol="0" anchor="ctr"/>
+          <a:lstStyle/>
+          <a:p>
+            <a:pPr indent="0" marL="0">
+              <a:buNone/>
+            </a:pPr>
+            <a:r>
+              <a:rPr lang="en-US" sz="1500" b="1" dirty="0">
+                <a:solidFill>
+                  <a:schemeClr val="accent1"/>
+                </a:solidFill>
+                <a:latin typeface="Courier New" pitchFamily="34" charset="0"/>
+                <a:ea typeface="Courier New" pitchFamily="34" charset="-122"/>
+                <a:cs typeface="Courier New" pitchFamily="34" charset="-120"/>
+              </a:rPr>
+              <a:t>pattern · injective</a:t>
+            </a:r>
+            <a:endParaRPr lang="en-US" sz="1500" dirty="0"/>
+          </a:p>
+          <a:p>
+            <a:pPr indent="0" marL="0">
+              <a:buNone/>
+            </a:pPr>
+            <a:r>
+              <a:rPr lang="en-US" sz="1500" b="1" dirty="0">
+                <a:solidFill>
+                  <a:schemeClr val="tx1"/>
+                </a:solidFill>
+              </a:rPr>
+              <a:t>Substructure search</a:t>
+            </a:r>
+            <a:endParaRPr lang="en-US" sz="1500" dirty="0"/>
+          </a:p>
+        </p:txBody>
+      </p:sp>
+      <p:sp>
+        <p:nvSpPr>
+          <p:cNvPr id="26" name="Text 19"/>
+          <p:cNvSpPr txBox="1"/>
+          <p:nvPr/>
+        </p:nvSpPr>
+        <p:spPr>
+          <a:xfrm>
+            <a:off x="8328965" y="2569464"/>
+            <a:ext cx="3112922" cy="1994408"/>
+          </a:xfrm>
+          <a:prstGeom prst="rect">
+            <a:avLst/>
+          </a:prstGeom>
+          <a:noFill/>
+          <a:ln/>
+        </p:spPr>
+        <p:txBody>
+          <a:bodyPr wrap="square" lIns="0" tIns="0" rIns="0" bIns="0" rtlCol="0" anchor="t"/>
+          <a:lstStyle/>
+          <a:p>
+            <a:pPr indent="0" marL="0">
+              <a:spcAft>
+                <a:spcPts val="840"/>
+              </a:spcAft>
+              <a:buNone/>
+            </a:pPr>
+            <a:r>
+              <a:rPr lang="en-US" sz="1400" b="1" dirty="0">
+                <a:solidFill>
+                  <a:schemeClr val="accent1"/>
+                </a:solidFill>
+              </a:rPr>
+              <a:t>Theory. </a:t>
+            </a:r>
+            <a:pPr indent="0" marL="0">
+              <a:spcAft>
+                <a:spcPts val="840"/>
+              </a:spcAft>
+              <a:buNone/>
+            </a:pPr>
+            <a:r>
+              <a:rPr lang="en-US" sz="1300" dirty="0">
+                <a:solidFill>
+                  <a:schemeClr val="tx1"/>
+                </a:solidFill>
+                <a:latin typeface="Courier New" pitchFamily="34" charset="0"/>
+                <a:ea typeface="Courier New" pitchFamily="34" charset="-122"/>
+                <a:cs typeface="Courier New" pitchFamily="34" charset="-120"/>
+              </a:rPr>
+              <a:t>injective: true</a:t>
+            </a:r>
+            <a:pPr indent="0" marL="0">
+              <a:spcAft>
+                <a:spcPts val="840"/>
+              </a:spcAft>
+              <a:buNone/>
+            </a:pPr>
+            <a:r>
+              <a:rPr lang="en-US" sz="1400" dirty="0">
+                <a:solidFill>
+                  <a:schemeClr val="tx1"/>
+                </a:solidFill>
+              </a:rPr>
+              <a:t>: distinct variables bind distinct nodes, distinct steps distinct edges. Motifs, catalytic sites, rings. No optional steps yet.</a:t>
+            </a:r>
+            <a:endParaRPr lang="en-US" sz="1400" dirty="0"/>
+          </a:p>
+          <a:p>
+            <a:pPr indent="0" marL="0">
+              <a:buNone/>
+            </a:pPr>
+            <a:r>
+              <a:rPr lang="en-US" sz="1400" b="1" dirty="0">
+                <a:solidFill>
+                  <a:schemeClr val="accent1"/>
+                </a:solidFill>
+              </a:rPr>
+              <a:t>Algorithm. </a:t>
+            </a:r>
+            <a:pPr indent="0" marL="0">
+              <a:buNone/>
+            </a:pPr>
+            <a:r>
+              <a:rPr lang="en-US" sz="1400" dirty="0">
+                <a:solidFill>
+                  <a:schemeClr val="tx1"/>
+                </a:solidFill>
+              </a:rPr>
+              <a:t>Over the same Yannakakis-pruned candidates, skipping held nodes and used edges. NP-complete: budget-bounded; exact totals when done.</a:t>
+            </a:r>
+            <a:endParaRPr lang="en-US" sz="1400" dirty="0"/>
+          </a:p>
+        </p:txBody>
+      </p:sp>
+      <p:sp>
+        <p:nvSpPr>
+          <p:cNvPr id="27" name="proof pattern · injective"/>
+          <p:cNvSpPr/>
+          <p:nvPr/>
+        </p:nvSpPr>
+        <p:spPr>
+          <a:xfrm>
+            <a:off x="8274101" y="4637024"/>
+            <a:ext cx="3222650" cy="1379728"/>
+          </a:xfrm>
+          <a:prstGeom prst="roundRect">
+            <a:avLst>
+              <a:gd name="adj" fmla="val 5302"/>
+            </a:avLst>
+          </a:prstGeom>
+          <a:solidFill>
+            <a:schemeClr val="bg1"/>
+          </a:solidFill>
+          <a:ln w="15875">
+            <a:solidFill>
+              <a:schemeClr val="accent1"/>
+            </a:solidFill>
+            <a:prstDash val="solid"/>
+          </a:ln>
+        </p:spPr>
+      </p:sp>
+      <p:pic>
+        <p:nvPicPr>
+          <p:cNvPr id="28" name="Image 5" descr="certificate">    </p:cNvPr>
+          <p:cNvPicPr>
+            <a:picLocks noChangeAspect="1"/>
+          </p:cNvPicPr>
+          <p:nvPr/>
+        </p:nvPicPr>
+        <p:blipFill>
+          <a:blip r:embed="rId6"/>
+          <a:stretch>
+            <a:fillRect/>
+          </a:stretch>
+        </p:blipFill>
+        <p:spPr>
+          <a:xfrm>
+            <a:off x="8383829" y="4728464"/>
+            <a:ext cx="246888" cy="246888"/>
+          </a:xfrm>
+          <a:prstGeom prst="rect">
+            <a:avLst/>
+          </a:prstGeom>
+        </p:spPr>
+      </p:pic>
+      <p:sp>
+        <p:nvSpPr>
+          <p:cNvPr id="29" name="Text 21"/>
+          <p:cNvSpPr txBox="1"/>
+          <p:nvPr/>
+        </p:nvSpPr>
+        <p:spPr>
+          <a:xfrm>
+            <a:off x="8713013" y="4728464"/>
+            <a:ext cx="2655722" cy="246888"/>
+          </a:xfrm>
+          <a:prstGeom prst="rect">
+            <a:avLst/>
+          </a:prstGeom>
+          <a:noFill/>
+          <a:ln/>
+        </p:spPr>
+        <p:txBody>
+          <a:bodyPr wrap="square" lIns="0" tIns="0" rIns="0" bIns="0" rtlCol="0" anchor="ctr"/>
+          <a:lstStyle/>
+          <a:p>
+            <a:pPr indent="0" marL="0">
+              <a:buNone/>
+            </a:pPr>
+            <a:r>
+              <a:rPr lang="en-US" sz="1100" b="1" spc="100" kern="0" dirty="0">
+                <a:solidFill>
+                  <a:schemeClr val="accent1"/>
+                </a:solidFill>
+              </a:rPr>
+              <a:t>CHECKED BY</a:t>
+            </a:r>
+            <a:endParaRPr lang="en-US" sz="1100" dirty="0"/>
+          </a:p>
+        </p:txBody>
+      </p:sp>
+      <p:sp>
+        <p:nvSpPr>
+          <p:cNvPr id="30" name="Text 22"/>
+          <p:cNvSpPr txBox="1"/>
+          <p:nvPr/>
+        </p:nvSpPr>
+        <p:spPr>
+          <a:xfrm>
+            <a:off x="8383829" y="5021072"/>
+            <a:ext cx="3003194" cy="922528"/>
+          </a:xfrm>
+          <a:prstGeom prst="rect">
+            <a:avLst/>
+          </a:prstGeom>
+          <a:noFill/>
+          <a:ln/>
+        </p:spPr>
+        <p:txBody>
+          <a:bodyPr wrap="square" lIns="0" tIns="0" rIns="0" bIns="0" rtlCol="0" anchor="t"/>
+          <a:lstStyle/>
+          <a:p>
+            <a:pPr indent="0" marL="0">
+              <a:buNone/>
+            </a:pPr>
+            <a:r>
+              <a:rPr lang="en-US" sz="1400" dirty="0">
+                <a:solidFill>
+                  <a:schemeClr val="tx1"/>
+                </a:solidFill>
+              </a:rPr>
+              <a:t>Brute force filtered for distinctness, row for row (400 random patterns); networkx's monomorphisms. Interrupted: no absence claimed.</a:t>
+            </a:r>
+            <a:endParaRPr lang="en-US" sz="1400" dirty="0"/>
           </a:p>
         </p:txBody>
       </p:sp>
@@ -12905,7 +13280,7 @@
                   <a:schemeClr val="tx1"/>
                 </a:solidFill>
               </a:rPr>
-              <a:t>Structure: pieces and weak points</a:t>
+              <a:t>Structure: pieces, weak points, backbones</a:t>
             </a:r>
             <a:endParaRPr lang="en-US" sz="3400" dirty="0"/>
           </a:p>
@@ -12943,7 +13318,7 @@
                   <a:schemeClr val="accent6"/>
                 </a:solidFill>
               </a:rPr>
-              <a:t>Recommended by both literature surveys. Both answers prove themselves on request, from the records alone.</a:t>
+              <a:t>Recommended by the literature surveys. Each answer proves itself from the records alone: two on request, the forest always.</a:t>
             </a:r>
             <a:endParaRPr lang="en-US" sz="1600" dirty="0"/>
           </a:p>
@@ -12958,11 +13333,11 @@
         <p:spPr>
           <a:xfrm>
             <a:off x="548640" y="1691640"/>
-            <a:ext cx="5410048" cy="4526280"/>
+            <a:ext cx="3515258" cy="4526280"/>
           </a:xfrm>
           <a:prstGeom prst="roundRect">
             <a:avLst>
-              <a:gd name="adj" fmla="val 2020"/>
+              <a:gd name="adj" fmla="val 2601"/>
             </a:avLst>
           </a:prstGeom>
           <a:solidFill>
@@ -13024,7 +13399,7 @@
         <p:spPr>
           <a:xfrm>
             <a:off x="1408176" y="1874520"/>
-            <a:ext cx="4349344" cy="548640"/>
+            <a:ext cx="2454554" cy="693801"/>
           </a:xfrm>
           <a:prstGeom prst="rect">
             <a:avLst/>
@@ -13076,8 +13451,8 @@
         </p:nvSpPr>
         <p:spPr>
           <a:xfrm>
-            <a:off x="749808" y="2569464"/>
-            <a:ext cx="5007712" cy="2164842"/>
+            <a:off x="749808" y="2714625"/>
+            <a:ext cx="3112922" cy="1632331"/>
           </a:xfrm>
           <a:prstGeom prst="rect">
             <a:avLst/>
@@ -13091,12 +13466,12 @@
           <a:p>
             <a:pPr indent="0" marL="0">
               <a:spcAft>
-                <a:spcPts val="900"/>
+                <a:spcPts val="840"/>
               </a:spcAft>
               <a:buNone/>
             </a:pPr>
             <a:r>
-              <a:rPr lang="en-US" sz="1500" b="1" dirty="0">
+              <a:rPr lang="en-US" sz="1400" b="1" dirty="0">
                 <a:solidFill>
                   <a:schemeClr val="accent1"/>
                 </a:solidFill>
@@ -13105,26 +13480,26 @@
             </a:r>
             <a:pPr indent="0" marL="0">
               <a:spcAft>
-                <a:spcPts val="900"/>
+                <a:spcPts val="840"/>
               </a:spcAft>
               <a:buNone/>
             </a:pPr>
             <a:r>
-              <a:rPr lang="en-US" sz="1500" dirty="0">
+              <a:rPr lang="en-US" sz="1400" dirty="0">
                 <a:solidFill>
                   <a:schemeClr val="tx1"/>
                 </a:solidFill>
               </a:rPr>
-              <a:t>Weak (hops either way: fragments) or strong (a walk each way: feedback loops, circular derivations), flagged initial, terminal and cyclic. A terminal class is one a walk never leaves.</a:t>
-            </a:r>
-            <a:endParaRPr lang="en-US" sz="1500" dirty="0"/>
-          </a:p>
-          <a:p>
-            <a:pPr indent="0" marL="0">
-              <a:buNone/>
-            </a:pPr>
-            <a:r>
-              <a:rPr lang="en-US" sz="1500" b="1" dirty="0">
+              <a:t>Weak (fragments) or strong (feedback loops, circular derivations), flagged initial, terminal and cyclic.</a:t>
+            </a:r>
+            <a:endParaRPr lang="en-US" sz="1400" dirty="0"/>
+          </a:p>
+          <a:p>
+            <a:pPr indent="0" marL="0">
+              <a:buNone/>
+            </a:pPr>
+            <a:r>
+              <a:rPr lang="en-US" sz="1400" b="1" dirty="0">
                 <a:solidFill>
                   <a:schemeClr val="accent1"/>
                 </a:solidFill>
@@ -13135,14 +13510,14 @@
               <a:buNone/>
             </a:pPr>
             <a:r>
-              <a:rPr lang="en-US" sz="1500" dirty="0">
+              <a:rPr lang="en-US" sz="1400" dirty="0">
                 <a:solidFill>
                   <a:schemeClr val="tx1"/>
                 </a:solidFill>
               </a:rPr>
               <a:t>Breadth-first search (weak) or Tarjan's depth-first search (1972) for strong components. Linear time.</a:t>
             </a:r>
-            <a:endParaRPr lang="en-US" sz="1500" dirty="0"/>
+            <a:endParaRPr lang="en-US" sz="1400" dirty="0"/>
           </a:p>
         </p:txBody>
       </p:sp>
@@ -13154,12 +13529,12 @@
         </p:nvSpPr>
         <p:spPr>
           <a:xfrm>
-            <a:off x="694944" y="4807458"/>
-            <a:ext cx="5117440" cy="1209294"/>
+            <a:off x="694944" y="4420108"/>
+            <a:ext cx="3222650" cy="1596644"/>
           </a:xfrm>
           <a:prstGeom prst="roundRect">
             <a:avLst>
-              <a:gd name="adj" fmla="val 6049"/>
+              <a:gd name="adj" fmla="val 4582"/>
             </a:avLst>
           </a:prstGeom>
           <a:solidFill>
@@ -13189,7 +13564,7 @@
         </p:blipFill>
         <p:spPr>
           <a:xfrm>
-            <a:off x="804672" y="4898898"/>
+            <a:off x="804672" y="4511548"/>
             <a:ext cx="246888" cy="246888"/>
           </a:xfrm>
           <a:prstGeom prst="rect">
@@ -13205,8 +13580,8 @@
         </p:nvSpPr>
         <p:spPr>
           <a:xfrm>
-            <a:off x="1133856" y="4898898"/>
-            <a:ext cx="4550512" cy="246888"/>
+            <a:off x="1133856" y="4511548"/>
+            <a:ext cx="2655722" cy="246888"/>
           </a:xfrm>
           <a:prstGeom prst="rect">
             <a:avLst/>
@@ -13241,8 +13616,8 @@
         </p:nvSpPr>
         <p:spPr>
           <a:xfrm>
-            <a:off x="804672" y="5191506"/>
-            <a:ext cx="4897984" cy="752094"/>
+            <a:off x="804672" y="4804156"/>
+            <a:ext cx="3003194" cy="1139444"/>
           </a:xfrm>
           <a:prstGeom prst="rect">
             <a:avLst/>
@@ -13258,14 +13633,14 @@
               <a:buNone/>
             </a:pPr>
             <a:r>
-              <a:rPr lang="en-US" sz="1500" dirty="0">
+              <a:rPr lang="en-US" sz="1400" dirty="0">
                 <a:solidFill>
                   <a:schemeClr val="tx1"/>
                 </a:solidFill>
               </a:rPr>
               <a:t>Spanning trees prove each listed component connected (strong: one out, one in); a closed partition in topological order proves nothing outside belongs with it.</a:t>
             </a:r>
-            <a:endParaRPr lang="en-US" sz="1500" dirty="0"/>
+            <a:endParaRPr lang="en-US" sz="1400" dirty="0"/>
           </a:p>
         </p:txBody>
       </p:sp>
@@ -13277,12 +13652,12 @@
         </p:nvSpPr>
         <p:spPr>
           <a:xfrm>
-            <a:off x="6233008" y="1691640"/>
-            <a:ext cx="5410048" cy="4526280"/>
+            <a:off x="4338218" y="1691640"/>
+            <a:ext cx="3515258" cy="4526280"/>
           </a:xfrm>
           <a:prstGeom prst="roundRect">
             <a:avLst>
-              <a:gd name="adj" fmla="val 2020"/>
+              <a:gd name="adj" fmla="val 2601"/>
             </a:avLst>
           </a:prstGeom>
           <a:solidFill>
@@ -13299,7 +13674,7 @@
         </p:nvSpPr>
         <p:spPr>
           <a:xfrm>
-            <a:off x="6434176" y="1892808"/>
+            <a:off x="4539386" y="1892808"/>
             <a:ext cx="512064" cy="512064"/>
           </a:xfrm>
           <a:prstGeom prst="ellipse">
@@ -13327,7 +13702,7 @@
         </p:blipFill>
         <p:spPr>
           <a:xfrm>
-            <a:off x="6546830" y="2005462"/>
+            <a:off x="4652040" y="2005462"/>
             <a:ext cx="286756" cy="286756"/>
           </a:xfrm>
           <a:prstGeom prst="rect">
@@ -13343,8 +13718,8 @@
         </p:nvSpPr>
         <p:spPr>
           <a:xfrm>
-            <a:off x="7092544" y="1874520"/>
-            <a:ext cx="4349344" cy="548640"/>
+            <a:off x="5197754" y="1874520"/>
+            <a:ext cx="2454554" cy="693801"/>
           </a:xfrm>
           <a:prstGeom prst="rect">
             <a:avLst/>
@@ -13396,8 +13771,8 @@
         </p:nvSpPr>
         <p:spPr>
           <a:xfrm>
-            <a:off x="6434176" y="2569464"/>
-            <a:ext cx="5007712" cy="2164842"/>
+            <a:off x="4539386" y="2714625"/>
+            <a:ext cx="3112922" cy="1849247"/>
           </a:xfrm>
           <a:prstGeom prst="rect">
             <a:avLst/>
@@ -13411,12 +13786,12 @@
           <a:p>
             <a:pPr indent="0" marL="0">
               <a:spcAft>
-                <a:spcPts val="900"/>
+                <a:spcPts val="840"/>
               </a:spcAft>
               <a:buNone/>
             </a:pPr>
             <a:r>
-              <a:rPr lang="en-US" sz="1500" b="1" dirty="0">
+              <a:rPr lang="en-US" sz="1400" b="1" dirty="0">
                 <a:solidFill>
                   <a:schemeClr val="accent1"/>
                 </a:solidFill>
@@ -13425,26 +13800,26 @@
             </a:r>
             <a:pPr indent="0" marL="0">
               <a:spcAft>
-                <a:spcPts val="900"/>
+                <a:spcPts val="840"/>
               </a:spcAft>
               <a:buNone/>
             </a:pPr>
             <a:r>
-              <a:rPr lang="en-US" sz="1500" dirty="0">
+              <a:rPr lang="en-US" sz="1400" dirty="0">
                 <a:solidFill>
                   <a:schemeClr val="tx1"/>
                 </a:solidFill>
               </a:rPr>
-              <a:t>Articulation points (with the pieces each leaves), bridges and blocks. Parallel edges are distinct links, so two between the same nodes are never bridges.</a:t>
-            </a:r>
-            <a:endParaRPr lang="en-US" sz="1500" dirty="0"/>
-          </a:p>
-          <a:p>
-            <a:pPr indent="0" marL="0">
-              <a:buNone/>
-            </a:pPr>
-            <a:r>
-              <a:rPr lang="en-US" sz="1500" b="1" dirty="0">
+              <a:t>Articulation points (with the pieces each leaves), bridges and blocks. Parallel edges are distinct links, never bridges.</a:t>
+            </a:r>
+            <a:endParaRPr lang="en-US" sz="1400" dirty="0"/>
+          </a:p>
+          <a:p>
+            <a:pPr indent="0" marL="0">
+              <a:buNone/>
+            </a:pPr>
+            <a:r>
+              <a:rPr lang="en-US" sz="1400" b="1" dirty="0">
                 <a:solidFill>
                   <a:schemeClr val="accent1"/>
                 </a:solidFill>
@@ -13455,14 +13830,14 @@
               <a:buNone/>
             </a:pPr>
             <a:r>
-              <a:rPr lang="en-US" sz="1500" dirty="0">
+              <a:rPr lang="en-US" sz="1400" dirty="0">
                 <a:solidFill>
                   <a:schemeClr val="tx1"/>
                 </a:solidFill>
               </a:rPr>
               <a:t>One depth-first search with low points (Hopcroft and Tarjan, 1973). Linear time.</a:t>
             </a:r>
-            <a:endParaRPr lang="en-US" sz="1500" dirty="0"/>
+            <a:endParaRPr lang="en-US" sz="1400" dirty="0"/>
           </a:p>
         </p:txBody>
       </p:sp>
@@ -13474,12 +13849,12 @@
         </p:nvSpPr>
         <p:spPr>
           <a:xfrm>
-            <a:off x="6379312" y="4807458"/>
-            <a:ext cx="5117440" cy="1209294"/>
+            <a:off x="4484522" y="4637024"/>
+            <a:ext cx="3222650" cy="1379728"/>
           </a:xfrm>
           <a:prstGeom prst="roundRect">
             <a:avLst>
-              <a:gd name="adj" fmla="val 6049"/>
+              <a:gd name="adj" fmla="val 5302"/>
             </a:avLst>
           </a:prstGeom>
           <a:solidFill>
@@ -13509,7 +13884,7 @@
         </p:blipFill>
         <p:spPr>
           <a:xfrm>
-            <a:off x="6489040" y="4898898"/>
+            <a:off x="4594250" y="4728464"/>
             <a:ext cx="246888" cy="246888"/>
           </a:xfrm>
           <a:prstGeom prst="rect">
@@ -13525,8 +13900,8 @@
         </p:nvSpPr>
         <p:spPr>
           <a:xfrm>
-            <a:off x="6818224" y="4898898"/>
-            <a:ext cx="4550512" cy="246888"/>
+            <a:off x="4923434" y="4728464"/>
+            <a:ext cx="2655722" cy="246888"/>
           </a:xfrm>
           <a:prstGeom prst="rect">
             <a:avLst/>
@@ -13561,8 +13936,8 @@
         </p:nvSpPr>
         <p:spPr>
           <a:xfrm>
-            <a:off x="6489040" y="5191506"/>
-            <a:ext cx="4897984" cy="752094"/>
+            <a:off x="4594250" y="5021072"/>
+            <a:ext cx="3003194" cy="922528"/>
           </a:xfrm>
           <a:prstGeom prst="rect">
             <a:avLst/>
@@ -13578,14 +13953,334 @@
               <a:buNone/>
             </a:pPr>
             <a:r>
-              <a:rPr lang="en-US" sz="1500" dirty="0">
+              <a:rPr lang="en-US" sz="1400" dirty="0">
                 <a:solidFill>
                   <a:schemeClr val="tx1"/>
                 </a:solidFill>
               </a:rPr>
               <a:t>The depth-first forest: a checker confirms it is one, recomputes every low point from the records, and each claim follows.</a:t>
             </a:r>
+            <a:endParaRPr lang="en-US" sz="1400" dirty="0"/>
+          </a:p>
+        </p:txBody>
+      </p:sp>
+      <p:sp>
+        <p:nvSpPr>
+          <p:cNvPr id="22" name="operation spanning_forest"/>
+          <p:cNvSpPr/>
+          <p:nvPr/>
+        </p:nvSpPr>
+        <p:spPr>
+          <a:xfrm>
+            <a:off x="8127797" y="1691640"/>
+            <a:ext cx="3515258" cy="4526280"/>
+          </a:xfrm>
+          <a:prstGeom prst="roundRect">
+            <a:avLst>
+              <a:gd name="adj" fmla="val 2601"/>
+            </a:avLst>
+          </a:prstGeom>
+          <a:solidFill>
+            <a:schemeClr val="bg2"/>
+          </a:solidFill>
+          <a:ln/>
+        </p:spPr>
+      </p:sp>
+      <p:sp>
+        <p:nvSpPr>
+          <p:cNvPr id="23" name="icon spanning_forest"/>
+          <p:cNvSpPr/>
+          <p:nvPr/>
+        </p:nvSpPr>
+        <p:spPr>
+          <a:xfrm>
+            <a:off x="8328965" y="1892808"/>
+            <a:ext cx="512064" cy="512064"/>
+          </a:xfrm>
+          <a:prstGeom prst="ellipse">
+            <a:avLst/>
+          </a:prstGeom>
+          <a:solidFill>
+            <a:schemeClr val="accent1"/>
+          </a:solidFill>
+          <a:ln/>
+        </p:spPr>
+      </p:sp>
+      <p:pic>
+        <p:nvPicPr>
+          <p:cNvPr id="24" name="Image 4" descr="spanning_forest">    </p:cNvPr>
+          <p:cNvPicPr>
+            <a:picLocks noChangeAspect="1"/>
+          </p:cNvPicPr>
+          <p:nvPr/>
+        </p:nvPicPr>
+        <p:blipFill>
+          <a:blip r:embed="rId5"/>
+          <a:stretch>
+            <a:fillRect/>
+          </a:stretch>
+        </p:blipFill>
+        <p:spPr>
+          <a:xfrm>
+            <a:off x="8441619" y="2005462"/>
+            <a:ext cx="286756" cy="286756"/>
+          </a:xfrm>
+          <a:prstGeom prst="rect">
+            <a:avLst/>
+          </a:prstGeom>
+        </p:spPr>
+      </p:pic>
+      <p:sp>
+        <p:nvSpPr>
+          <p:cNvPr id="25" name="Text 18"/>
+          <p:cNvSpPr txBox="1"/>
+          <p:nvPr/>
+        </p:nvSpPr>
+        <p:spPr>
+          <a:xfrm>
+            <a:off x="8987333" y="1874520"/>
+            <a:ext cx="2454554" cy="693801"/>
+          </a:xfrm>
+          <a:prstGeom prst="rect">
+            <a:avLst/>
+          </a:prstGeom>
+          <a:noFill/>
+          <a:ln/>
+        </p:spPr>
+        <p:txBody>
+          <a:bodyPr wrap="square" lIns="0" tIns="0" rIns="0" bIns="0" rtlCol="0" anchor="ctr"/>
+          <a:lstStyle/>
+          <a:p>
+            <a:pPr indent="0" marL="0">
+              <a:buNone/>
+            </a:pPr>
+            <a:r>
+              <a:rPr lang="en-US" sz="1500" b="1" dirty="0">
+                <a:solidFill>
+                  <a:schemeClr val="accent1"/>
+                </a:solidFill>
+                <a:latin typeface="Courier New" pitchFamily="34" charset="0"/>
+                <a:ea typeface="Courier New" pitchFamily="34" charset="-122"/>
+                <a:cs typeface="Courier New" pitchFamily="34" charset="-120"/>
+              </a:rPr>
+              <a:t>spanning_forest</a:t>
+            </a:r>
             <a:endParaRPr lang="en-US" sz="1500" dirty="0"/>
+          </a:p>
+          <a:p>
+            <a:pPr indent="0" marL="0">
+              <a:buNone/>
+            </a:pPr>
+            <a:r>
+              <a:rPr lang="en-US" sz="1500" b="1" dirty="0">
+                <a:solidFill>
+                  <a:schemeClr val="tx1"/>
+                </a:solidFill>
+              </a:rPr>
+              <a:t>Backbones, single-linkage clusters</a:t>
+            </a:r>
+            <a:endParaRPr lang="en-US" sz="1500" dirty="0"/>
+          </a:p>
+        </p:txBody>
+      </p:sp>
+      <p:sp>
+        <p:nvSpPr>
+          <p:cNvPr id="26" name="Text 19"/>
+          <p:cNvSpPr txBox="1"/>
+          <p:nvPr/>
+        </p:nvSpPr>
+        <p:spPr>
+          <a:xfrm>
+            <a:off x="8328965" y="2714625"/>
+            <a:ext cx="3112922" cy="1849247"/>
+          </a:xfrm>
+          <a:prstGeom prst="rect">
+            <a:avLst/>
+          </a:prstGeom>
+          <a:noFill/>
+          <a:ln/>
+        </p:spPr>
+        <p:txBody>
+          <a:bodyPr wrap="square" lIns="0" tIns="0" rIns="0" bIns="0" rtlCol="0" anchor="t"/>
+          <a:lstStyle/>
+          <a:p>
+            <a:pPr indent="0" marL="0">
+              <a:spcAft>
+                <a:spcPts val="840"/>
+              </a:spcAft>
+              <a:buNone/>
+            </a:pPr>
+            <a:r>
+              <a:rPr lang="en-US" sz="1400" b="1" dirty="0">
+                <a:solidFill>
+                  <a:schemeClr val="accent1"/>
+                </a:solidFill>
+              </a:rPr>
+              <a:t>Theory. </a:t>
+            </a:r>
+            <a:pPr indent="0" marL="0">
+              <a:spcAft>
+                <a:spcPts val="840"/>
+              </a:spcAft>
+              <a:buNone/>
+            </a:pPr>
+            <a:r>
+              <a:rPr lang="en-US" sz="1400" dirty="0">
+                <a:solidFill>
+                  <a:schemeClr val="tx1"/>
+                </a:solidFill>
+              </a:rPr>
+              <a:t>The minimum (or maximum) spanning forest: one tree per piece. Any finite exact weights; ties go to the smaller edge ID.</a:t>
+            </a:r>
+            <a:endParaRPr lang="en-US" sz="1400" dirty="0"/>
+          </a:p>
+          <a:p>
+            <a:pPr indent="0" marL="0">
+              <a:buNone/>
+            </a:pPr>
+            <a:r>
+              <a:rPr lang="en-US" sz="1400" b="1" dirty="0">
+                <a:solidFill>
+                  <a:schemeClr val="accent1"/>
+                </a:solidFill>
+              </a:rPr>
+              <a:t>Algorithm. </a:t>
+            </a:r>
+            <a:pPr indent="0" marL="0">
+              <a:buNone/>
+            </a:pPr>
+            <a:r>
+              <a:rPr lang="en-US" sz="1400" dirty="0">
+                <a:solidFill>
+                  <a:schemeClr val="tx1"/>
+                </a:solidFill>
+              </a:rPr>
+              <a:t>Kruskal (1956) with a union-find, links in the order of (weight, edge ID): the forest is unique in that order.</a:t>
+            </a:r>
+            <a:endParaRPr lang="en-US" sz="1400" dirty="0"/>
+          </a:p>
+        </p:txBody>
+      </p:sp>
+      <p:sp>
+        <p:nvSpPr>
+          <p:cNvPr id="27" name="proof spanning_forest"/>
+          <p:cNvSpPr/>
+          <p:nvPr/>
+        </p:nvSpPr>
+        <p:spPr>
+          <a:xfrm>
+            <a:off x="8274101" y="4637024"/>
+            <a:ext cx="3222650" cy="1379728"/>
+          </a:xfrm>
+          <a:prstGeom prst="roundRect">
+            <a:avLst>
+              <a:gd name="adj" fmla="val 5302"/>
+            </a:avLst>
+          </a:prstGeom>
+          <a:solidFill>
+            <a:schemeClr val="bg1"/>
+          </a:solidFill>
+          <a:ln w="15875">
+            <a:solidFill>
+              <a:schemeClr val="accent1"/>
+            </a:solidFill>
+            <a:prstDash val="solid"/>
+          </a:ln>
+        </p:spPr>
+      </p:sp>
+      <p:pic>
+        <p:nvPicPr>
+          <p:cNvPr id="28" name="Image 5" descr="certificate">    </p:cNvPr>
+          <p:cNvPicPr>
+            <a:picLocks noChangeAspect="1"/>
+          </p:cNvPicPr>
+          <p:nvPr/>
+        </p:nvPicPr>
+        <p:blipFill>
+          <a:blip r:embed="rId6"/>
+          <a:stretch>
+            <a:fillRect/>
+          </a:stretch>
+        </p:blipFill>
+        <p:spPr>
+          <a:xfrm>
+            <a:off x="8383829" y="4728464"/>
+            <a:ext cx="246888" cy="246888"/>
+          </a:xfrm>
+          <a:prstGeom prst="rect">
+            <a:avLst/>
+          </a:prstGeom>
+        </p:spPr>
+      </p:pic>
+      <p:sp>
+        <p:nvSpPr>
+          <p:cNvPr id="29" name="Text 21"/>
+          <p:cNvSpPr txBox="1"/>
+          <p:nvPr/>
+        </p:nvSpPr>
+        <p:spPr>
+          <a:xfrm>
+            <a:off x="8713013" y="4728464"/>
+            <a:ext cx="2655722" cy="246888"/>
+          </a:xfrm>
+          <a:prstGeom prst="rect">
+            <a:avLst/>
+          </a:prstGeom>
+          <a:noFill/>
+          <a:ln/>
+        </p:spPr>
+        <p:txBody>
+          <a:bodyPr wrap="square" lIns="0" tIns="0" rIns="0" bIns="0" rtlCol="0" anchor="ctr"/>
+          <a:lstStyle/>
+          <a:p>
+            <a:pPr indent="0" marL="0">
+              <a:buNone/>
+            </a:pPr>
+            <a:r>
+              <a:rPr lang="en-US" sz="1100" b="1" spc="100" kern="0" dirty="0">
+                <a:solidFill>
+                  <a:schemeClr val="accent1"/>
+                </a:solidFill>
+              </a:rPr>
+              <a:t>PROVES ITSELF BY</a:t>
+            </a:r>
+            <a:endParaRPr lang="en-US" sz="1100" dirty="0"/>
+          </a:p>
+        </p:txBody>
+      </p:sp>
+      <p:sp>
+        <p:nvSpPr>
+          <p:cNvPr id="30" name="Text 22"/>
+          <p:cNvSpPr txBox="1"/>
+          <p:nvPr/>
+        </p:nvSpPr>
+        <p:spPr>
+          <a:xfrm>
+            <a:off x="8383829" y="5021072"/>
+            <a:ext cx="3003194" cy="922528"/>
+          </a:xfrm>
+          <a:prstGeom prst="rect">
+            <a:avLst/>
+          </a:prstGeom>
+          <a:noFill/>
+          <a:ln/>
+        </p:spPr>
+        <p:txBody>
+          <a:bodyPr wrap="square" lIns="0" tIns="0" rIns="0" bIns="0" rtlCol="0" anchor="t"/>
+          <a:lstStyle/>
+          <a:p>
+            <a:pPr indent="0" marL="0">
+              <a:buNone/>
+            </a:pPr>
+            <a:r>
+              <a:rPr lang="en-US" sz="1400" dirty="0">
+                <a:solidFill>
+                  <a:schemeClr val="tx1"/>
+                </a:solidFill>
+              </a:rPr>
+              <a:t>Tarjan's cycle property: each link left out comes after every edge of its tree path (path maxima by binary lifting). Revalidation re-checks it.</a:t>
+            </a:r>
+            <a:endParaRPr lang="en-US" sz="1400" dirty="0"/>
           </a:p>
         </p:txBody>
       </p:sp>
@@ -16027,7 +16722,7 @@
                   <a:schemeClr val="tx1"/>
                 </a:solidFill>
               </a:rPr>
-              <a:t>Still correct on the new projection. Structure, flows, matchings, dominators, incidence, critical paths and d-separation hold exactly when their certificate checks; a cycle or active trail holds by itself.</a:t>
+              <a:t>Still correct on the new projection. Structure, flows, matchings, dominators, incidence, critical paths and d-separation hold exactly when their certificate checks, a forest when it verifies; a cycle or active trail by itself.</a:t>
             </a:r>
             <a:endParaRPr lang="en-US" sz="1800" dirty="0"/>
           </a:p>
@@ -17761,7 +18456,7 @@
                 <a:ea typeface="Cambria" pitchFamily="34" charset="-122"/>
                 <a:cs typeface="Cambria" pitchFamily="34" charset="-120"/>
               </a:rPr>
-              <a:t>563</a:t>
+              <a:t>582</a:t>
             </a:r>
             <a:endParaRPr lang="en-US" sz="3400" dirty="0"/>
           </a:p>
@@ -17836,7 +18531,7 @@
                 <a:ea typeface="Cambria" pitchFamily="34" charset="-122"/>
                 <a:cs typeface="Cambria" pitchFamily="34" charset="-120"/>
               </a:rPr>
-              <a:t>173</a:t>
+              <a:t>180</a:t>
             </a:r>
             <a:endParaRPr lang="en-US" sz="3400" dirty="0"/>
           </a:p>
@@ -18697,7 +19392,7 @@
                   <a:schemeClr val="accent6"/>
                 </a:solidFill>
               </a:rPr>
-              <a:t>Codex reviews each increment adversarially before commit. Found and fixed with regressions: a request_id collision and two certificate holes (structure); an unverified interrupted bound (flows); quadratic checks (dominators, support); a float entry that let a false rank verify, a stale nearest cut held, contradicted answers left unknown (incidence); exact fields beside false values, a path from outside the sources' region, unpolled controls (critical path); a nonuniform PageRank start, a lenient ranking revalidation, a quadratic cyclic join (26 October together); a whole certificate read for an unrelated edit (negative costs, else sound on 12,000 random graphs against an oracle). d-separation: no findings.</a:t>
+              <a:t>Codex reviews each increment adversarially before commit. Found and fixed with regressions: a request_id collision and two certificate holes (structure); an unverified interrupted bound (flows); quadratic checks (dominators, support); a float entry that let a false rank verify, a stale nearest cut held, contradicted answers left unknown (incidence); exact fields beside false values, a path from outside the sources' region, unpolled controls (critical path); a nonuniform PageRank start, a lenient ranking revalidation, a quadratic cyclic join (26 October together); a whole certificate read for an unrelated edit (negative costs, else sound on 12,000 random graphs); the recursion limit hit by a 1,100-step chain (injective patterns); frozen answers the verifier skipped (forests). d-separation: no findings.</a:t>
             </a:r>
             <a:endParaRPr lang="en-US" sz="1200" dirty="0"/>
           </a:p>
@@ -19591,7 +20286,7 @@
         </p:nvGraphicFramePr>
         <p:xfrm>
           <a:off x="548640" y="1691640"/>
-          <a:ext cx="5364328" cy="3382010"/>
+          <a:ext cx="5364328" cy="3583432"/>
         </p:xfrm>
         <a:graphic xmlns:a="http://schemas.openxmlformats.org/drawingml/2006/main">
           <a:graphicData uri="http://schemas.openxmlformats.org/drawingml/2006/chart">
@@ -19607,8 +20302,8 @@
         </p:nvSpPr>
         <p:spPr>
           <a:xfrm>
-            <a:off x="548640" y="5165090"/>
-            <a:ext cx="5364328" cy="1052830"/>
+            <a:off x="548640" y="5366512"/>
+            <a:ext cx="5364328" cy="851408"/>
           </a:xfrm>
           <a:prstGeom prst="rect">
             <a:avLst/>
@@ -19643,7 +20338,7 @@
         </p:nvGraphicFramePr>
         <p:xfrm>
           <a:off x="6278728" y="1691640"/>
-          <a:ext cx="5364328" cy="3382010"/>
+          <a:ext cx="5364328" cy="3583432"/>
         </p:xfrm>
         <a:graphic xmlns:a="http://schemas.openxmlformats.org/drawingml/2006/main">
           <a:graphicData uri="http://schemas.openxmlformats.org/drawingml/2006/chart">
@@ -19659,8 +20354,8 @@
         </p:nvSpPr>
         <p:spPr>
           <a:xfrm>
-            <a:off x="6278728" y="5165090"/>
-            <a:ext cx="5364328" cy="1052830"/>
+            <a:off x="6278728" y="5366512"/>
+            <a:ext cx="5364328" cy="851408"/>
           </a:xfrm>
           <a:prstGeom prst="rect">
             <a:avLst/>
@@ -19681,7 +20376,7 @@
                   <a:schemeClr val="tx1"/>
                 </a:solidFill>
               </a:rPr>
-              <a:t>100k nodes, 500k edges; matching 50k + 50k, 250k edges; dominators 300k edges; critical path 400k edges (networkx: no order certificate). Negative costs: 20k nodes, 100k edges, 31% negative; GRAPH with its certificate, networkx goldberg_radzik 0.39 s. A negative cycle planted near the source: networkx 0.002 s, GRAPH 0.042 s.</a:t>
+              <a:t>100k nodes, 500k edges; matching 50k + 50k, 250k edges; dominators and forest 300k edges; critical path 400k edges (networkx: no order certificate). Negative costs: 20k nodes, 100k edges, 31% negative. Hexagons: 7,200 matches in a 1,300-atom sheet.</a:t>
             </a:r>
             <a:endParaRPr lang="en-US" sz="1300" dirty="0"/>
           </a:p>
@@ -21378,7 +22073,7 @@
                   <a:schemeClr val="accent6"/>
                 </a:solidFill>
               </a:rPr>
-              <a:t>Thirty-seven commits on 25–26 October 2026: from four operations to nineteen.</a:t>
+              <a:t>Forty commits on 25–26 October 2026: from four operations to twenty.</a:t>
             </a:r>
             <a:endParaRPr lang="en-US" sz="1600" dirty="0"/>
           </a:p>
@@ -22702,7 +23397,46 @@
                   <a:schemeClr val="tx1"/>
                 </a:solidFill>
               </a:rPr>
-              <a:t> (conservation laws)</a:t>
+              <a:t> · </a:t>
+            </a:r>
+            <a:pPr indent="0" marL="0">
+              <a:buNone/>
+            </a:pPr>
+            <a:r>
+              <a:rPr lang="en-US" sz="1300" dirty="0">
+                <a:solidFill>
+                  <a:schemeClr val="tx1"/>
+                </a:solidFill>
+                <a:latin typeface="Courier New" pitchFamily="34" charset="0"/>
+                <a:ea typeface="Courier New" pitchFamily="34" charset="-122"/>
+                <a:cs typeface="Courier New" pitchFamily="34" charset="-120"/>
+              </a:rPr>
+              <a:t>critical_path</a:t>
+            </a:r>
+            <a:pPr indent="0" marL="0">
+              <a:buNone/>
+            </a:pPr>
+            <a:r>
+              <a:rPr lang="en-US" sz="1400" dirty="0">
+                <a:solidFill>
+                  <a:schemeClr val="tx1"/>
+                </a:solidFill>
+              </a:rPr>
+              <a:t> · </a:t>
+            </a:r>
+            <a:pPr indent="0" marL="0">
+              <a:buNone/>
+            </a:pPr>
+            <a:r>
+              <a:rPr lang="en-US" sz="1300" dirty="0">
+                <a:solidFill>
+                  <a:schemeClr val="tx1"/>
+                </a:solidFill>
+                <a:latin typeface="Courier New" pitchFamily="34" charset="0"/>
+                <a:ea typeface="Courier New" pitchFamily="34" charset="-122"/>
+                <a:cs typeface="Courier New" pitchFamily="34" charset="-120"/>
+              </a:rPr>
+              <a:t>d_separation</a:t>
             </a:r>
             <a:endParaRPr lang="en-US" sz="1300" dirty="0"/>
           </a:p>
@@ -22710,7 +23444,7 @@
       </p:sp>
       <p:sp>
         <p:nvSpPr>
-          <p:cNvPr id="40" name="milestone 11:32"/>
+          <p:cNvPr id="40" name="milestone 17:45"/>
           <p:cNvSpPr/>
           <p:nvPr/>
         </p:nvSpPr>
@@ -22763,7 +23497,7 @@
                   <a:schemeClr val="accent6"/>
                 </a:solidFill>
               </a:rPr>
-              <a:t>11:32</a:t>
+              <a:t>17:45</a:t>
             </a:r>
             <a:endParaRPr lang="en-US" sz="1300" dirty="0"/>
           </a:p>
@@ -22794,48 +23528,20 @@
               <a:buNone/>
             </a:pPr>
             <a:r>
-              <a:rPr lang="en-US" sz="1300" dirty="0">
+              <a:rPr lang="en-US" sz="1400" dirty="0">
                 <a:solidFill>
                   <a:schemeClr val="tx1"/>
                 </a:solidFill>
-                <a:latin typeface="Courier New" pitchFamily="34" charset="0"/>
-                <a:ea typeface="Courier New" pitchFamily="34" charset="-122"/>
-                <a:cs typeface="Courier New" pitchFamily="34" charset="-120"/>
-              </a:rPr>
-              <a:t>critical_path</a:t>
-            </a:r>
-            <a:pPr indent="0" marL="0">
-              <a:buNone/>
-            </a:pPr>
-            <a:r>
-              <a:rPr lang="en-US" sz="1400" dirty="0">
-                <a:solidFill>
-                  <a:schemeClr val="tx1"/>
-                </a:solidFill>
-              </a:rPr>
-              <a:t> (schedules) · </a:t>
-            </a:r>
-            <a:pPr indent="0" marL="0">
-              <a:buNone/>
-            </a:pPr>
-            <a:r>
-              <a:rPr lang="en-US" sz="1300" dirty="0">
-                <a:solidFill>
-                  <a:schemeClr val="tx1"/>
-                </a:solidFill>
-                <a:latin typeface="Courier New" pitchFamily="34" charset="0"/>
-                <a:ea typeface="Courier New" pitchFamily="34" charset="-122"/>
-                <a:cs typeface="Courier New" pitchFamily="34" charset="-120"/>
-              </a:rPr>
-              <a:t>d_separation</a:t>
-            </a:r>
-            <a:endParaRPr lang="en-US" sz="1300" dirty="0"/>
-          </a:p>
-        </p:txBody>
-      </p:sp>
-      <p:sp>
-        <p:nvSpPr>
-          <p:cNvPr id="43" name="milestone 17:45"/>
+              </a:rPr>
+              <a:t>Review fixes · support certificates, revalidated</a:t>
+            </a:r>
+            <a:endParaRPr lang="en-US" sz="1400" dirty="0"/>
+          </a:p>
+        </p:txBody>
+      </p:sp>
+      <p:sp>
+        <p:nvSpPr>
+          <p:cNvPr id="43" name="milestone 22:11"/>
           <p:cNvSpPr/>
           <p:nvPr/>
         </p:nvSpPr>
@@ -22888,7 +23594,7 @@
                   <a:schemeClr val="accent6"/>
                 </a:solidFill>
               </a:rPr>
-              <a:t>17:45</a:t>
+              <a:t>22:11</a:t>
             </a:r>
             <a:endParaRPr lang="en-US" sz="1300" dirty="0"/>
           </a:p>
@@ -22924,7 +23630,7 @@
                   <a:schemeClr val="tx1"/>
                 </a:solidFill>
               </a:rPr>
-              <a:t>Fixes from a review of the day's increments</a:t>
+              <a:t>Negative-cost shortest paths · faster projection identity</a:t>
             </a:r>
             <a:endParaRPr lang="en-US" sz="1400" dirty="0"/>
           </a:p>
@@ -22932,7 +23638,7 @@
       </p:sp>
       <p:sp>
         <p:nvSpPr>
-          <p:cNvPr id="46" name="milestone 18:23"/>
+          <p:cNvPr id="46" name="milestone 22:38"/>
           <p:cNvSpPr/>
           <p:nvPr/>
         </p:nvSpPr>
@@ -22985,7 +23691,7 @@
                   <a:schemeClr val="accent6"/>
                 </a:solidFill>
               </a:rPr>
-              <a:t>18:23</a:t>
+              <a:t>22:38</a:t>
             </a:r>
             <a:endParaRPr lang="en-US" sz="1300" dirty="0"/>
           </a:p>
@@ -23021,7 +23727,7 @@
                   <a:schemeClr val="tx1"/>
                 </a:solidFill>
               </a:rPr>
-              <a:t>Support certificates · support revalidated</a:t>
+              <a:t>Injective patterns: substructure search</a:t>
             </a:r>
             <a:endParaRPr lang="en-US" sz="1400" dirty="0"/>
           </a:p>
@@ -23029,7 +23735,7 @@
       </p:sp>
       <p:sp>
         <p:nvSpPr>
-          <p:cNvPr id="49" name="milestone 22:11"/>
+          <p:cNvPr id="49" name="milestone 22:55"/>
           <p:cNvSpPr/>
           <p:nvPr/>
         </p:nvSpPr>
@@ -23082,7 +23788,7 @@
                   <a:schemeClr val="accent6"/>
                 </a:solidFill>
               </a:rPr>
-              <a:t>22:11</a:t>
+              <a:t>22:55</a:t>
             </a:r>
             <a:endParaRPr lang="en-US" sz="1300" dirty="0"/>
           </a:p>
@@ -23113,14 +23819,28 @@
               <a:buNone/>
             </a:pPr>
             <a:r>
+              <a:rPr lang="en-US" sz="1300" dirty="0">
+                <a:solidFill>
+                  <a:schemeClr val="tx1"/>
+                </a:solidFill>
+                <a:latin typeface="Courier New" pitchFamily="34" charset="0"/>
+                <a:ea typeface="Courier New" pitchFamily="34" charset="-122"/>
+                <a:cs typeface="Courier New" pitchFamily="34" charset="-120"/>
+              </a:rPr>
+              <a:t>spanning_forest</a:t>
+            </a:r>
+            <a:pPr indent="0" marL="0">
+              <a:buNone/>
+            </a:pPr>
+            <a:r>
               <a:rPr lang="en-US" sz="1400" dirty="0">
                 <a:solidFill>
                   <a:schemeClr val="tx1"/>
                 </a:solidFill>
               </a:rPr>
-              <a:t>Negative-cost shortest paths · faster projection identity</a:t>
-            </a:r>
-            <a:endParaRPr lang="en-US" sz="1400" dirty="0"/>
+              <a:t>, proven by the cycle property</a:t>
+            </a:r>
+            <a:endParaRPr lang="en-US" sz="1300" dirty="0"/>
           </a:p>
         </p:txBody>
       </p:sp>
@@ -23179,7 +23899,7 @@
                 <a:ea typeface="Cambria" pitchFamily="34" charset="-122"/>
                 <a:cs typeface="Cambria" pitchFamily="34" charset="-120"/>
               </a:rPr>
-              <a:t>4 → 19</a:t>
+              <a:t>4 → 20</a:t>
             </a:r>
             <a:endParaRPr lang="en-US" sz="2800" dirty="0"/>
           </a:p>
@@ -23254,7 +23974,7 @@
                 <a:ea typeface="Cambria" pitchFamily="34" charset="-122"/>
                 <a:cs typeface="Cambria" pitchFamily="34" charset="-120"/>
               </a:rPr>
-              <a:t>178 → 563</a:t>
+              <a:t>178 → 582</a:t>
             </a:r>
             <a:endParaRPr lang="en-US" sz="2800" dirty="0"/>
           </a:p>
@@ -23430,7 +24150,7 @@
                   <a:schemeClr val="accent6"/>
                 </a:solidFill>
               </a:rPr>
-              <a:t>Ranked by value against effort in a Codex literature survey; its first, negative costs, is done.</a:t>
+              <a:t>Ranked in a Codex survey. Done: negative costs, injective patterns, spanning forests. Being built: ring perception.</a:t>
             </a:r>
             <a:endParaRPr lang="en-US" sz="1600" dirty="0"/>
           </a:p>
@@ -23582,18 +24302,18 @@
       </p:sp>
       <p:sp>
         <p:nvSpPr>
-          <p:cNvPr id="8" name="roadmap Injective patterns"/>
+          <p:cNvPr id="8" name="roadmap Minimum cycle basis, relevant cycles"/>
           <p:cNvSpPr/>
           <p:nvPr/>
         </p:nvSpPr>
         <p:spPr>
           <a:xfrm>
             <a:off x="548640" y="1911096"/>
-            <a:ext cx="11094415" cy="551011"/>
+            <a:ext cx="11094415" cy="587163"/>
           </a:xfrm>
           <a:prstGeom prst="roundRect">
             <a:avLst>
-              <a:gd name="adj" fmla="val 16595"/>
+              <a:gd name="adj" fmla="val 15573"/>
             </a:avLst>
           </a:prstGeom>
           <a:solidFill>
@@ -23604,13 +24324,13 @@
       </p:sp>
       <p:sp>
         <p:nvSpPr>
-          <p:cNvPr id="9" name="icon Injective patterns"/>
-          <p:cNvSpPr/>
-          <p:nvPr/>
-        </p:nvSpPr>
-        <p:spPr>
-          <a:xfrm>
-            <a:off x="713232" y="1967145"/>
+          <p:cNvPr id="9" name="icon Minimum cycle basis, relevant cycles"/>
+          <p:cNvSpPr/>
+          <p:nvPr/>
+        </p:nvSpPr>
+        <p:spPr>
+          <a:xfrm>
+            <a:off x="713232" y="1985222"/>
             <a:ext cx="438912" cy="438912"/>
           </a:xfrm>
           <a:prstGeom prst="ellipse">
@@ -23624,7 +24344,7 @@
       </p:sp>
       <p:pic>
         <p:nvPicPr>
-          <p:cNvPr id="10" name="Image 0" descr="Injective patterns">    </p:cNvPr>
+          <p:cNvPr id="10" name="Image 0" descr="Minimum cycle basis, relevant cycles">    </p:cNvPr>
           <p:cNvPicPr>
             <a:picLocks noChangeAspect="1"/>
           </p:cNvPicPr>
@@ -23638,7 +24358,7 @@
         </p:blipFill>
         <p:spPr>
           <a:xfrm>
-            <a:off x="809793" y="2063706"/>
+            <a:off x="809793" y="2081782"/>
             <a:ext cx="245791" cy="245791"/>
           </a:xfrm>
           <a:prstGeom prst="rect">
@@ -23655,7 +24375,7 @@
         <p:spPr>
           <a:xfrm>
             <a:off x="1325880" y="1911096"/>
-            <a:ext cx="1828800" cy="551011"/>
+            <a:ext cx="1828800" cy="587163"/>
           </a:xfrm>
           <a:prstGeom prst="rect">
             <a:avLst/>
@@ -23676,7 +24396,7 @@
                   <a:schemeClr val="tx1"/>
                 </a:solidFill>
               </a:rPr>
-              <a:t>Injective patterns</a:t>
+              <a:t>Minimum cycle basis, relevant cycles</a:t>
             </a:r>
             <a:endParaRPr lang="en-US" sz="1500" dirty="0"/>
           </a:p>
@@ -23691,7 +24411,7 @@
         <p:spPr>
           <a:xfrm>
             <a:off x="3383280" y="1911096"/>
-            <a:ext cx="3017520" cy="551011"/>
+            <a:ext cx="3017520" cy="587163"/>
           </a:xfrm>
           <a:prstGeom prst="rect">
             <a:avLst/>
@@ -23712,7 +24432,7 @@
                   <a:schemeClr val="tx1"/>
                 </a:solidFill>
               </a:rPr>
-              <a:t>Substructure search: motifs, catalytic sites, provenance patterns.</a:t>
+              <a:t>Ring perception: a smallest set of smallest rings; the relevant rings.</a:t>
             </a:r>
             <a:endParaRPr lang="en-US" sz="1400" dirty="0"/>
           </a:p>
@@ -23727,7 +24447,7 @@
         <p:spPr>
           <a:xfrm>
             <a:off x="6629400" y="1911096"/>
-            <a:ext cx="3017520" cy="551011"/>
+            <a:ext cx="3017520" cy="587163"/>
           </a:xfrm>
           <a:prstGeom prst="rect">
             <a:avLst/>
@@ -23748,7 +24468,7 @@
                   <a:schemeClr val="tx1"/>
                 </a:solidFill>
               </a:rPr>
-              <a:t>Embeddings check in linear time; absence, by a refutation tree.</a:t>
+              <a:t>Elimination over GF(2) proves a basis; de Pina's supports, a minimum.</a:t>
             </a:r>
             <a:endParaRPr lang="en-US" sz="1400" dirty="0"/>
           </a:p>
@@ -23763,7 +24483,7 @@
         <p:spPr>
           <a:xfrm>
             <a:off x="9875520" y="1911096"/>
-            <a:ext cx="1676095" cy="551011"/>
+            <a:ext cx="1676095" cy="587163"/>
           </a:xfrm>
           <a:prstGeom prst="rect">
             <a:avLst/>
@@ -23784,7 +24504,7 @@
                   <a:schemeClr val="accent6"/>
                 </a:solidFill>
               </a:rPr>
-              <a:t>VF2++ (2018); the Glasgow solver (2020)</a:t>
+              <a:t>Horton 1987; Vismara 1997; Kavitha et al.</a:t>
             </a:r>
             <a:endParaRPr lang="en-US" sz="1200" dirty="0"/>
           </a:p>
@@ -23792,18 +24512,18 @@
       </p:sp>
       <p:sp>
         <p:nvSpPr>
-          <p:cNvPr id="15" name="roadmap Minimum spanning forest"/>
-          <p:cNvSpPr/>
-          <p:nvPr/>
-        </p:nvSpPr>
-        <p:spPr>
-          <a:xfrm>
-            <a:off x="548640" y="2553547"/>
-            <a:ext cx="11094415" cy="551011"/>
+          <p:cNvPr id="15" name="roadmap Weighted matching, min-cost flow"/>
+          <p:cNvSpPr/>
+          <p:nvPr/>
+        </p:nvSpPr>
+        <p:spPr>
+          <a:xfrm>
+            <a:off x="548640" y="2589699"/>
+            <a:ext cx="11094415" cy="587163"/>
           </a:xfrm>
           <a:prstGeom prst="roundRect">
             <a:avLst>
-              <a:gd name="adj" fmla="val 16595"/>
+              <a:gd name="adj" fmla="val 15573"/>
             </a:avLst>
           </a:prstGeom>
           <a:solidFill>
@@ -23814,13 +24534,13 @@
       </p:sp>
       <p:sp>
         <p:nvSpPr>
-          <p:cNvPr id="16" name="icon Minimum spanning forest"/>
-          <p:cNvSpPr/>
-          <p:nvPr/>
-        </p:nvSpPr>
-        <p:spPr>
-          <a:xfrm>
-            <a:off x="713232" y="2609596"/>
+          <p:cNvPr id="16" name="icon Weighted matching, min-cost flow"/>
+          <p:cNvSpPr/>
+          <p:nvPr/>
+        </p:nvSpPr>
+        <p:spPr>
+          <a:xfrm>
+            <a:off x="713232" y="2663825"/>
             <a:ext cx="438912" cy="438912"/>
           </a:xfrm>
           <a:prstGeom prst="ellipse">
@@ -23834,7 +24554,7 @@
       </p:sp>
       <p:pic>
         <p:nvPicPr>
-          <p:cNvPr id="17" name="Image 1" descr="Minimum spanning forest">    </p:cNvPr>
+          <p:cNvPr id="17" name="Image 1" descr="Weighted matching, min-cost flow">    </p:cNvPr>
           <p:cNvPicPr>
             <a:picLocks noChangeAspect="1"/>
           </p:cNvPicPr>
@@ -23848,7 +24568,7 @@
         </p:blipFill>
         <p:spPr>
           <a:xfrm>
-            <a:off x="809793" y="2706157"/>
+            <a:off x="809793" y="2760386"/>
             <a:ext cx="245791" cy="245791"/>
           </a:xfrm>
           <a:prstGeom prst="rect">
@@ -23864,8 +24584,8 @@
         </p:nvSpPr>
         <p:spPr>
           <a:xfrm>
-            <a:off x="1325880" y="2553547"/>
-            <a:ext cx="1828800" cy="551011"/>
+            <a:off x="1325880" y="2589699"/>
+            <a:ext cx="1828800" cy="587163"/>
           </a:xfrm>
           <a:prstGeom prst="rect">
             <a:avLst/>
@@ -23886,7 +24606,7 @@
                   <a:schemeClr val="tx1"/>
                 </a:solidFill>
               </a:rPr>
-              <a:t>Minimum spanning forest</a:t>
+              <a:t>Weighted matching, min-cost flow</a:t>
             </a:r>
             <a:endParaRPr lang="en-US" sz="1500" dirty="0"/>
           </a:p>
@@ -23900,8 +24620,8 @@
         </p:nvSpPr>
         <p:spPr>
           <a:xfrm>
-            <a:off x="3383280" y="2553547"/>
-            <a:ext cx="3017520" cy="551011"/>
+            <a:off x="3383280" y="2589699"/>
+            <a:ext cx="3017520" cy="587163"/>
           </a:xfrm>
           <a:prstGeom prst="rect">
             <a:avLst/>
@@ -23922,7 +24642,7 @@
                   <a:schemeClr val="tx1"/>
                 </a:solidFill>
               </a:rPr>
-              <a:t>Representative connectivity: the lightest forest spanning each piece.</a:t>
+              <a:t>Assignment, allocation and transport at least cost.</a:t>
             </a:r>
             <a:endParaRPr lang="en-US" sz="1400" dirty="0"/>
           </a:p>
@@ -23936,8 +24656,8 @@
         </p:nvSpPr>
         <p:spPr>
           <a:xfrm>
-            <a:off x="6629400" y="2553547"/>
-            <a:ext cx="3017520" cy="551011"/>
+            <a:off x="6629400" y="2589699"/>
+            <a:ext cx="3017520" cy="587163"/>
           </a:xfrm>
           <a:prstGeom prst="rect">
             <a:avLst/>
@@ -23958,7 +24678,7 @@
                   <a:schemeClr val="tx1"/>
                 </a:solidFill>
               </a:rPr>
-              <a:t>Cycle property: each other edge is a heaviest on the cycle it closes.</a:t>
+              <a:t>Dual potentials: no residual arc has a negative reduced cost.</a:t>
             </a:r>
             <a:endParaRPr lang="en-US" sz="1400" dirty="0"/>
           </a:p>
@@ -23972,8 +24692,8 @@
         </p:nvSpPr>
         <p:spPr>
           <a:xfrm>
-            <a:off x="9875520" y="2553547"/>
-            <a:ext cx="1676095" cy="551011"/>
+            <a:off x="9875520" y="2589699"/>
+            <a:ext cx="1676095" cy="587163"/>
           </a:xfrm>
           <a:prstGeom prst="rect">
             <a:avLst/>
@@ -23994,7 +24714,7 @@
                   <a:schemeClr val="accent6"/>
                 </a:solidFill>
               </a:rPr>
-              <a:t>Kruskal 1956; Dixon, Rauch and Tarjan 1992</a:t>
+              <a:t>Munkres 1957; Király and Kovács 2012</a:t>
             </a:r>
             <a:endParaRPr lang="en-US" sz="1200" dirty="0"/>
           </a:p>
@@ -24002,18 +24722,18 @@
       </p:sp>
       <p:sp>
         <p:nvSpPr>
-          <p:cNvPr id="22" name="roadmap Minimum cycle basis, relevant cycles"/>
-          <p:cNvSpPr/>
-          <p:nvPr/>
-        </p:nvSpPr>
-        <p:spPr>
-          <a:xfrm>
-            <a:off x="548640" y="3195997"/>
-            <a:ext cx="11094415" cy="551011"/>
+          <p:cNvPr id="22" name="roadmap Counting cyclic patterns"/>
+          <p:cNvSpPr/>
+          <p:nvPr/>
+        </p:nvSpPr>
+        <p:spPr>
+          <a:xfrm>
+            <a:off x="548640" y="3268303"/>
+            <a:ext cx="11094415" cy="587163"/>
           </a:xfrm>
           <a:prstGeom prst="roundRect">
             <a:avLst>
-              <a:gd name="adj" fmla="val 16595"/>
+              <a:gd name="adj" fmla="val 15573"/>
             </a:avLst>
           </a:prstGeom>
           <a:solidFill>
@@ -24024,13 +24744,13 @@
       </p:sp>
       <p:sp>
         <p:nvSpPr>
-          <p:cNvPr id="23" name="icon Minimum cycle basis, relevant cycles"/>
-          <p:cNvSpPr/>
-          <p:nvPr/>
-        </p:nvSpPr>
-        <p:spPr>
-          <a:xfrm>
-            <a:off x="713232" y="3252047"/>
+          <p:cNvPr id="23" name="icon Counting cyclic patterns"/>
+          <p:cNvSpPr/>
+          <p:nvPr/>
+        </p:nvSpPr>
+        <p:spPr>
+          <a:xfrm>
+            <a:off x="713232" y="3342428"/>
             <a:ext cx="438912" cy="438912"/>
           </a:xfrm>
           <a:prstGeom prst="ellipse">
@@ -24044,7 +24764,7 @@
       </p:sp>
       <p:pic>
         <p:nvPicPr>
-          <p:cNvPr id="24" name="Image 2" descr="Minimum cycle basis, relevant cycles">    </p:cNvPr>
+          <p:cNvPr id="24" name="Image 2" descr="Counting cyclic patterns">    </p:cNvPr>
           <p:cNvPicPr>
             <a:picLocks noChangeAspect="1"/>
           </p:cNvPicPr>
@@ -24058,7 +24778,7 @@
         </p:blipFill>
         <p:spPr>
           <a:xfrm>
-            <a:off x="809793" y="3348607"/>
+            <a:off x="809793" y="3438989"/>
             <a:ext cx="245791" cy="245791"/>
           </a:xfrm>
           <a:prstGeom prst="rect">
@@ -24074,8 +24794,8 @@
         </p:nvSpPr>
         <p:spPr>
           <a:xfrm>
-            <a:off x="1325880" y="3195997"/>
-            <a:ext cx="1828800" cy="551011"/>
+            <a:off x="1325880" y="3268303"/>
+            <a:ext cx="1828800" cy="587163"/>
           </a:xfrm>
           <a:prstGeom prst="rect">
             <a:avLst/>
@@ -24096,7 +24816,7 @@
                   <a:schemeClr val="tx1"/>
                 </a:solidFill>
               </a:rPr>
-              <a:t>Minimum cycle basis, relevant cycles</a:t>
+              <a:t>Counting cyclic patterns</a:t>
             </a:r>
             <a:endParaRPr lang="en-US" sz="1500" dirty="0"/>
           </a:p>
@@ -24110,8 +24830,8 @@
         </p:nvSpPr>
         <p:spPr>
           <a:xfrm>
-            <a:off x="3383280" y="3195997"/>
-            <a:ext cx="3017520" cy="551011"/>
+            <a:off x="3383280" y="3268303"/>
+            <a:ext cx="3017520" cy="587163"/>
           </a:xfrm>
           <a:prstGeom prst="rect">
             <a:avLst/>
@@ -24132,7 +24852,7 @@
                   <a:schemeClr val="tx1"/>
                 </a:solidFill>
               </a:rPr>
-              <a:t>Ring perception: a smallest set of smallest rings; the relevant rings.</a:t>
+              <a:t>Exact motif counts without listing rows, over a tree decomposition.</a:t>
             </a:r>
             <a:endParaRPr lang="en-US" sz="1400" dirty="0"/>
           </a:p>
@@ -24146,8 +24866,8 @@
         </p:nvSpPr>
         <p:spPr>
           <a:xfrm>
-            <a:off x="6629400" y="3195997"/>
-            <a:ext cx="3017520" cy="551011"/>
+            <a:off x="6629400" y="3268303"/>
+            <a:ext cx="3017520" cy="587163"/>
           </a:xfrm>
           <a:prstGeom prst="rect">
             <a:avLst/>
@@ -24168,7 +24888,7 @@
                   <a:schemeClr val="tx1"/>
                 </a:solidFill>
               </a:rPr>
-              <a:t>Elimination over GF(2) proves a basis; de Pina's supports, a minimum.</a:t>
+              <a:t>The decomposition's messages, each recomputed by a checker.</a:t>
             </a:r>
             <a:endParaRPr lang="en-US" sz="1400" dirty="0"/>
           </a:p>
@@ -24182,8 +24902,8 @@
         </p:nvSpPr>
         <p:spPr>
           <a:xfrm>
-            <a:off x="9875520" y="3195997"/>
-            <a:ext cx="1676095" cy="551011"/>
+            <a:off x="9875520" y="3268303"/>
+            <a:ext cx="1676095" cy="587163"/>
           </a:xfrm>
           <a:prstGeom prst="rect">
             <a:avLst/>
@@ -24204,7 +24924,7 @@
                   <a:schemeClr val="accent6"/>
                 </a:solidFill>
               </a:rPr>
-              <a:t>Horton 1987; Vismara 1997; Kavitha et al.</a:t>
+              <a:t>Abo Khamis, Ngo and Rudra 2016 (FAQ)</a:t>
             </a:r>
             <a:endParaRPr lang="en-US" sz="1200" dirty="0"/>
           </a:p>
@@ -24212,18 +24932,18 @@
       </p:sp>
       <p:sp>
         <p:nvSpPr>
-          <p:cNvPr id="29" name="roadmap Weighted matching, min-cost flow"/>
-          <p:cNvSpPr/>
-          <p:nvPr/>
-        </p:nvSpPr>
-        <p:spPr>
-          <a:xfrm>
-            <a:off x="548640" y="3838448"/>
-            <a:ext cx="11094415" cy="551011"/>
+          <p:cNvPr id="29" name="roadmap k shortest simple paths"/>
+          <p:cNvSpPr/>
+          <p:nvPr/>
+        </p:nvSpPr>
+        <p:spPr>
+          <a:xfrm>
+            <a:off x="548640" y="3946906"/>
+            <a:ext cx="11094415" cy="587163"/>
           </a:xfrm>
           <a:prstGeom prst="roundRect">
             <a:avLst>
-              <a:gd name="adj" fmla="val 16595"/>
+              <a:gd name="adj" fmla="val 15573"/>
             </a:avLst>
           </a:prstGeom>
           <a:solidFill>
@@ -24234,13 +24954,13 @@
       </p:sp>
       <p:sp>
         <p:nvSpPr>
-          <p:cNvPr id="30" name="icon Weighted matching, min-cost flow"/>
-          <p:cNvSpPr/>
-          <p:nvPr/>
-        </p:nvSpPr>
-        <p:spPr>
-          <a:xfrm>
-            <a:off x="713232" y="3894497"/>
+          <p:cNvPr id="30" name="icon k shortest simple paths"/>
+          <p:cNvSpPr/>
+          <p:nvPr/>
+        </p:nvSpPr>
+        <p:spPr>
+          <a:xfrm>
+            <a:off x="713232" y="4021032"/>
             <a:ext cx="438912" cy="438912"/>
           </a:xfrm>
           <a:prstGeom prst="ellipse">
@@ -24254,7 +24974,7 @@
       </p:sp>
       <p:pic>
         <p:nvPicPr>
-          <p:cNvPr id="31" name="Image 3" descr="Weighted matching, min-cost flow">    </p:cNvPr>
+          <p:cNvPr id="31" name="Image 3" descr="k shortest simple paths">    </p:cNvPr>
           <p:cNvPicPr>
             <a:picLocks noChangeAspect="1"/>
           </p:cNvPicPr>
@@ -24268,7 +24988,7 @@
         </p:blipFill>
         <p:spPr>
           <a:xfrm>
-            <a:off x="809793" y="3991058"/>
+            <a:off x="809793" y="4117592"/>
             <a:ext cx="245791" cy="245791"/>
           </a:xfrm>
           <a:prstGeom prst="rect">
@@ -24284,8 +25004,8 @@
         </p:nvSpPr>
         <p:spPr>
           <a:xfrm>
-            <a:off x="1325880" y="3838448"/>
-            <a:ext cx="1828800" cy="551011"/>
+            <a:off x="1325880" y="3946906"/>
+            <a:ext cx="1828800" cy="587163"/>
           </a:xfrm>
           <a:prstGeom prst="rect">
             <a:avLst/>
@@ -24306,7 +25026,7 @@
                   <a:schemeClr val="tx1"/>
                 </a:solidFill>
               </a:rPr>
-              <a:t>Weighted matching, min-cost flow</a:t>
+              <a:t>k shortest simple paths</a:t>
             </a:r>
             <a:endParaRPr lang="en-US" sz="1500" dirty="0"/>
           </a:p>
@@ -24320,8 +25040,8 @@
         </p:nvSpPr>
         <p:spPr>
           <a:xfrm>
-            <a:off x="3383280" y="3838448"/>
-            <a:ext cx="3017520" cy="551011"/>
+            <a:off x="3383280" y="3946906"/>
+            <a:ext cx="3017520" cy="587163"/>
           </a:xfrm>
           <a:prstGeom prst="rect">
             <a:avLst/>
@@ -24342,7 +25062,7 @@
                   <a:schemeClr val="tx1"/>
                 </a:solidFill>
               </a:rPr>
-              <a:t>Assignment, allocation and transport at least cost.</a:t>
+              <a:t>Alternative pathways and explanations, not only one optimum.</a:t>
             </a:r>
             <a:endParaRPr lang="en-US" sz="1400" dirty="0"/>
           </a:p>
@@ -24356,8 +25076,8 @@
         </p:nvSpPr>
         <p:spPr>
           <a:xfrm>
-            <a:off x="6629400" y="3838448"/>
-            <a:ext cx="3017520" cy="551011"/>
+            <a:off x="6629400" y="3946906"/>
+            <a:ext cx="3017520" cy="587163"/>
           </a:xfrm>
           <a:prstGeom prst="rect">
             <a:avLst/>
@@ -24378,7 +25098,7 @@
                   <a:schemeClr val="tx1"/>
                 </a:solidFill>
               </a:rPr>
-              <a:t>Dual potentials: no residual arc has a negative reduced cost.</a:t>
+              <a:t>The paths; a Lawler partition tree proves they are the first k.</a:t>
             </a:r>
             <a:endParaRPr lang="en-US" sz="1400" dirty="0"/>
           </a:p>
@@ -24392,8 +25112,8 @@
         </p:nvSpPr>
         <p:spPr>
           <a:xfrm>
-            <a:off x="9875520" y="3838448"/>
-            <a:ext cx="1676095" cy="551011"/>
+            <a:off x="9875520" y="3946906"/>
+            <a:ext cx="1676095" cy="587163"/>
           </a:xfrm>
           <a:prstGeom prst="rect">
             <a:avLst/>
@@ -24414,7 +25134,7 @@
                   <a:schemeClr val="accent6"/>
                 </a:solidFill>
               </a:rPr>
-              <a:t>Munkres 1957; Király and Kovács 2012</a:t>
+              <a:t>Yen 1971; Lawler 1972</a:t>
             </a:r>
             <a:endParaRPr lang="en-US" sz="1200" dirty="0"/>
           </a:p>
@@ -24422,18 +25142,18 @@
       </p:sp>
       <p:sp>
         <p:nvSpPr>
-          <p:cNvPr id="36" name="roadmap Counting cyclic patterns"/>
-          <p:cNvSpPr/>
-          <p:nvPr/>
-        </p:nvSpPr>
-        <p:spPr>
-          <a:xfrm>
-            <a:off x="548640" y="4480899"/>
-            <a:ext cx="11094415" cy="551011"/>
+          <p:cNvPr id="36" name="roadmap Reachability index"/>
+          <p:cNvSpPr/>
+          <p:nvPr/>
+        </p:nvSpPr>
+        <p:spPr>
+          <a:xfrm>
+            <a:off x="548640" y="4625509"/>
+            <a:ext cx="11094415" cy="587163"/>
           </a:xfrm>
           <a:prstGeom prst="roundRect">
             <a:avLst>
-              <a:gd name="adj" fmla="val 16595"/>
+              <a:gd name="adj" fmla="val 15573"/>
             </a:avLst>
           </a:prstGeom>
           <a:solidFill>
@@ -24444,13 +25164,13 @@
       </p:sp>
       <p:sp>
         <p:nvSpPr>
-          <p:cNvPr id="37" name="icon Counting cyclic patterns"/>
-          <p:cNvSpPr/>
-          <p:nvPr/>
-        </p:nvSpPr>
-        <p:spPr>
-          <a:xfrm>
-            <a:off x="713232" y="4536948"/>
+          <p:cNvPr id="37" name="icon Reachability index"/>
+          <p:cNvSpPr/>
+          <p:nvPr/>
+        </p:nvSpPr>
+        <p:spPr>
+          <a:xfrm>
+            <a:off x="713232" y="4699635"/>
             <a:ext cx="438912" cy="438912"/>
           </a:xfrm>
           <a:prstGeom prst="ellipse">
@@ -24464,7 +25184,7 @@
       </p:sp>
       <p:pic>
         <p:nvPicPr>
-          <p:cNvPr id="38" name="Image 4" descr="Counting cyclic patterns">    </p:cNvPr>
+          <p:cNvPr id="38" name="Image 4" descr="Reachability index">    </p:cNvPr>
           <p:cNvPicPr>
             <a:picLocks noChangeAspect="1"/>
           </p:cNvPicPr>
@@ -24478,7 +25198,7 @@
         </p:blipFill>
         <p:spPr>
           <a:xfrm>
-            <a:off x="809793" y="4633509"/>
+            <a:off x="809793" y="4796196"/>
             <a:ext cx="245791" cy="245791"/>
           </a:xfrm>
           <a:prstGeom prst="rect">
@@ -24494,8 +25214,8 @@
         </p:nvSpPr>
         <p:spPr>
           <a:xfrm>
-            <a:off x="1325880" y="4480899"/>
-            <a:ext cx="1828800" cy="551011"/>
+            <a:off x="1325880" y="4625509"/>
+            <a:ext cx="1828800" cy="587163"/>
           </a:xfrm>
           <a:prstGeom prst="rect">
             <a:avLst/>
@@ -24516,7 +25236,7 @@
                   <a:schemeClr val="tx1"/>
                 </a:solidFill>
               </a:rPr>
-              <a:t>Counting cyclic patterns</a:t>
+              <a:t>Reachability index</a:t>
             </a:r>
             <a:endParaRPr lang="en-US" sz="1500" dirty="0"/>
           </a:p>
@@ -24530,8 +25250,8 @@
         </p:nvSpPr>
         <p:spPr>
           <a:xfrm>
-            <a:off x="3383280" y="4480899"/>
-            <a:ext cx="3017520" cy="551011"/>
+            <a:off x="3383280" y="4625509"/>
+            <a:ext cx="3017520" cy="587163"/>
           </a:xfrm>
           <a:prstGeom prst="rect">
             <a:avLst/>
@@ -24552,7 +25272,7 @@
                   <a:schemeClr val="tx1"/>
                 </a:solidFill>
               </a:rPr>
-              <a:t>Exact motif counts without listing rows, over a tree decomposition.</a:t>
+              <a:t>Many reachability queries on one large, fixed projection: 2-hop labels.</a:t>
             </a:r>
             <a:endParaRPr lang="en-US" sz="1400" dirty="0"/>
           </a:p>
@@ -24566,8 +25286,8 @@
         </p:nvSpPr>
         <p:spPr>
           <a:xfrm>
-            <a:off x="6629400" y="4480899"/>
-            <a:ext cx="3017520" cy="551011"/>
+            <a:off x="6629400" y="4625509"/>
+            <a:ext cx="3017520" cy="587163"/>
           </a:xfrm>
           <a:prstGeom prst="rect">
             <a:avLst/>
@@ -24588,7 +25308,7 @@
                   <a:schemeClr val="tx1"/>
                 </a:solidFill>
               </a:rPr>
-              <a:t>The decomposition's messages, each recomputed by a checker.</a:t>
+              <a:t>A positive expands hub pointers into hops; a negative needs a closure.</a:t>
             </a:r>
             <a:endParaRPr lang="en-US" sz="1400" dirty="0"/>
           </a:p>
@@ -24602,8 +25322,8 @@
         </p:nvSpPr>
         <p:spPr>
           <a:xfrm>
-            <a:off x="9875520" y="4480899"/>
-            <a:ext cx="1676095" cy="551011"/>
+            <a:off x="9875520" y="4625509"/>
+            <a:ext cx="1676095" cy="587163"/>
           </a:xfrm>
           <a:prstGeom prst="rect">
             <a:avLst/>
@@ -24624,7 +25344,7 @@
                   <a:schemeClr val="accent6"/>
                 </a:solidFill>
               </a:rPr>
-              <a:t>Abo Khamis, Ngo and Rudra 2016 (FAQ)</a:t>
+              <a:t>Cohen, Halperin, Kaplan and Zwick 2003</a:t>
             </a:r>
             <a:endParaRPr lang="en-US" sz="1200" dirty="0"/>
           </a:p>
@@ -24632,18 +25352,18 @@
       </p:sp>
       <p:sp>
         <p:nvSpPr>
-          <p:cNvPr id="43" name="roadmap k shortest simple paths"/>
-          <p:cNvSpPr/>
-          <p:nvPr/>
-        </p:nvSpPr>
-        <p:spPr>
-          <a:xfrm>
-            <a:off x="548640" y="5123349"/>
-            <a:ext cx="11094415" cy="551011"/>
+          <p:cNvPr id="43" name="roadmap Positive Datalog"/>
+          <p:cNvSpPr/>
+          <p:nvPr/>
+        </p:nvSpPr>
+        <p:spPr>
+          <a:xfrm>
+            <a:off x="548640" y="5304113"/>
+            <a:ext cx="11094415" cy="587163"/>
           </a:xfrm>
           <a:prstGeom prst="roundRect">
             <a:avLst>
-              <a:gd name="adj" fmla="val 16595"/>
+              <a:gd name="adj" fmla="val 15573"/>
             </a:avLst>
           </a:prstGeom>
           <a:solidFill>
@@ -24654,13 +25374,13 @@
       </p:sp>
       <p:sp>
         <p:nvSpPr>
-          <p:cNvPr id="44" name="icon k shortest simple paths"/>
-          <p:cNvSpPr/>
-          <p:nvPr/>
-        </p:nvSpPr>
-        <p:spPr>
-          <a:xfrm>
-            <a:off x="713232" y="5179399"/>
+          <p:cNvPr id="44" name="icon Positive Datalog"/>
+          <p:cNvSpPr/>
+          <p:nvPr/>
+        </p:nvSpPr>
+        <p:spPr>
+          <a:xfrm>
+            <a:off x="713232" y="5378238"/>
             <a:ext cx="438912" cy="438912"/>
           </a:xfrm>
           <a:prstGeom prst="ellipse">
@@ -24674,7 +25394,7 @@
       </p:sp>
       <p:pic>
         <p:nvPicPr>
-          <p:cNvPr id="45" name="Image 5" descr="k shortest simple paths">    </p:cNvPr>
+          <p:cNvPr id="45" name="Image 5" descr="Positive Datalog">    </p:cNvPr>
           <p:cNvPicPr>
             <a:picLocks noChangeAspect="1"/>
           </p:cNvPicPr>
@@ -24688,7 +25408,7 @@
         </p:blipFill>
         <p:spPr>
           <a:xfrm>
-            <a:off x="809793" y="5275959"/>
+            <a:off x="809793" y="5474799"/>
             <a:ext cx="245791" cy="245791"/>
           </a:xfrm>
           <a:prstGeom prst="rect">
@@ -24704,8 +25424,8 @@
         </p:nvSpPr>
         <p:spPr>
           <a:xfrm>
-            <a:off x="1325880" y="5123349"/>
-            <a:ext cx="1828800" cy="551011"/>
+            <a:off x="1325880" y="5304113"/>
+            <a:ext cx="1828800" cy="587163"/>
           </a:xfrm>
           <a:prstGeom prst="rect">
             <a:avLst/>
@@ -24726,7 +25446,7 @@
                   <a:schemeClr val="tx1"/>
                 </a:solidFill>
               </a:rPr>
-              <a:t>k shortest simple paths</a:t>
+              <a:t>Positive Datalog</a:t>
             </a:r>
             <a:endParaRPr lang="en-US" sz="1500" dirty="0"/>
           </a:p>
@@ -24740,8 +25460,8 @@
         </p:nvSpPr>
         <p:spPr>
           <a:xfrm>
-            <a:off x="3383280" y="5123349"/>
-            <a:ext cx="3017520" cy="551011"/>
+            <a:off x="3383280" y="5304113"/>
+            <a:ext cx="3017520" cy="587163"/>
           </a:xfrm>
           <a:prstGeom prst="rect">
             <a:avLst/>
@@ -24762,7 +25482,7 @@
                   <a:schemeClr val="tx1"/>
                 </a:solidFill>
               </a:rPr>
-              <a:t>Alternative pathways and explanations, not only one optimum.</a:t>
+              <a:t>Rules over the records: provenance questions in a small language.</a:t>
             </a:r>
             <a:endParaRPr lang="en-US" sz="1400" dirty="0"/>
           </a:p>
@@ -24776,8 +25496,8 @@
         </p:nvSpPr>
         <p:spPr>
           <a:xfrm>
-            <a:off x="6629400" y="5123349"/>
-            <a:ext cx="3017520" cy="551011"/>
+            <a:off x="6629400" y="5304113"/>
+            <a:ext cx="3017520" cy="587163"/>
           </a:xfrm>
           <a:prstGeom prst="rect">
             <a:avLst/>
@@ -24798,7 +25518,7 @@
                   <a:schemeClr val="tx1"/>
                 </a:solidFill>
               </a:rPr>
-              <a:t>The paths; a Lawler partition tree proves they are the first k.</a:t>
+              <a:t>Derivation trees, ranks strictly increasing, checked in their size.</a:t>
             </a:r>
             <a:endParaRPr lang="en-US" sz="1400" dirty="0"/>
           </a:p>
@@ -24812,8 +25532,8 @@
         </p:nvSpPr>
         <p:spPr>
           <a:xfrm>
-            <a:off x="9875520" y="5123349"/>
-            <a:ext cx="1676095" cy="551011"/>
+            <a:off x="9875520" y="5304113"/>
+            <a:ext cx="1676095" cy="587163"/>
           </a:xfrm>
           <a:prstGeom prst="rect">
             <a:avLst/>
@@ -24834,7 +25554,7 @@
                   <a:schemeClr val="accent6"/>
                 </a:solidFill>
               </a:rPr>
-              <a:t>Yen 1971; Lawler 1972</a:t>
+              <a:t>Abiteboul, Hull and Vianu 1995; Green et al. 2007</a:t>
             </a:r>
             <a:endParaRPr lang="en-US" sz="1200" dirty="0"/>
           </a:p>
@@ -24848,8 +25568,8 @@
         </p:nvSpPr>
         <p:spPr>
           <a:xfrm>
-            <a:off x="685800" y="5784088"/>
-            <a:ext cx="10820095" cy="433832"/>
+            <a:off x="685800" y="6001004"/>
+            <a:ext cx="10820095" cy="216916"/>
           </a:xfrm>
           <a:prstGeom prst="rect">
             <a:avLst/>
@@ -24881,7 +25601,7 @@
                   <a:schemeClr val="tx1"/>
                 </a:solidFill>
               </a:rPr>
-              <a:t> a reachability index (2-hop labels) · positive Datalog with derivation certificates · isomorphism and canonical labeling · elementary flux modes.</a:t>
+              <a:t> isomorphism and canonical labeling · elementary flux modes.</a:t>
             </a:r>
             <a:endParaRPr lang="en-US" sz="1400" dirty="0"/>
           </a:p>
@@ -25605,7 +26325,7 @@
                   <a:schemeClr val="bg1"/>
                 </a:solidFill>
               </a:rPr>
-              <a:t>Nineteen operations with witnesses; certificates on request; revalidation after edits.</a:t>
+              <a:t>Twenty operations with witnesses; certificates on request; revalidation after edits.</a:t>
             </a:r>
             <a:endParaRPr lang="en-US" sz="1800" dirty="0"/>
           </a:p>
@@ -28033,7 +28753,7 @@
                   <a:schemeClr val="tx1"/>
                 </a:solidFill>
               </a:rPr>
-              <a:t>19 exact operations under budget, deadline, cancellation</a:t>
+              <a:t>20 exact operations under budget, deadline, cancellation</a:t>
             </a:r>
             <a:endParaRPr lang="en-US" sz="1400" dirty="0"/>
           </a:p>
@@ -31491,7 +32211,7 @@
                   <a:schemeClr val="tx1"/>
                 </a:solidFill>
               </a:rPr>
-              <a:t>Nineteen exact operations in six families</a:t>
+              <a:t>Twenty exact operations in six families</a:t>
             </a:r>
             <a:endParaRPr lang="en-US" sz="3400" dirty="0"/>
           </a:p>
@@ -32060,7 +32780,7 @@
                   <a:schemeClr val="tx1"/>
                 </a:solidFill>
               </a:rPr>
-              <a:t>Multi-step questions: trees counted exactly, cycles by a worst-case optimal join.</a:t>
+              <a:t>Multi-step questions counted exactly, cycles by a worst-case optimal join, injective substructure search.</a:t>
             </a:r>
             <a:endParaRPr lang="en-US" sz="1400" dirty="0"/>
           </a:p>
@@ -32531,7 +33251,7 @@
         <p:spPr>
           <a:xfrm>
             <a:off x="8328965" y="4933188"/>
-            <a:ext cx="3112922" cy="396240"/>
+            <a:ext cx="3112922" cy="571500"/>
           </a:xfrm>
           <a:prstGeom prst="rect">
             <a:avLst/>
@@ -32555,7 +33275,7 @@
                 <a:ea typeface="Courier New" pitchFamily="34" charset="-122"/>
                 <a:cs typeface="Courier New" pitchFamily="34" charset="-120"/>
               </a:rPr>
-              <a:t>components · biconnectivity · max_flow · matching · dominators</a:t>
+              <a:t>components · biconnectivity · spanning_forest · max_flow · matching · dominators</a:t>
             </a:r>
             <a:endParaRPr lang="en-US" sz="1200" dirty="0"/>
           </a:p>
@@ -32569,8 +33289,8 @@
         </p:nvSpPr>
         <p:spPr>
           <a:xfrm>
-            <a:off x="8328965" y="5420868"/>
-            <a:ext cx="3112922" cy="659892"/>
+            <a:off x="8328965" y="5596128"/>
+            <a:ext cx="3112922" cy="484632"/>
           </a:xfrm>
           <a:prstGeom prst="rect">
             <a:avLst/>
@@ -32591,7 +33311,7 @@
                   <a:schemeClr val="tx1"/>
                 </a:solidFill>
               </a:rPr>
-              <a:t>Pieces, weak points, throughput, pairings and unavoidable nodes.</a:t>
+              <a:t>Pieces, weak points, backbones, flows, pairings and unavoidable nodes.</a:t>
             </a:r>
             <a:endParaRPr lang="en-US" sz="1400" dirty="0"/>
           </a:p>

</xml_diff>

<commit_message>
Slides: cyclic pattern counting
Co-Authored-By: Claude Opus 5.5 <noreply@anthropic.com>
</commit_message>
<xml_diff>
--- a/docs/GRAPH_slides.pptx
+++ b/docs/GRAPH_slides.pptx
@@ -134,21 +134,21 @@
   <p:extLst>
     <p:ext uri="{521415D9-36F7-43E2-AB2F-B90AF26B5E84}">
       <p14:sectionLst xmlns:p14="http://schemas.microsoft.com/office/powerpoint/2010/main">
-        <p14:section name="Why GRAPH" id="{2f712e6c-ab47-d7f1-b464-6ba8e1190dec}">
+        <p14:section name="Why GRAPH" id="{35aac3cf-3ccf-3997-36ec-25575b9e5e3b}">
           <p14:sldIdLst>
             <p14:sldId id="256"/>
             <p14:sldId id="257"/>
             <p14:sldId id="258"/>
           </p14:sldIdLst>
         </p14:section>
-        <p14:section name="Architecture" id="{9004bf4f-a3f0-93bd-d3d6-241e89a1c649}">
+        <p14:section name="Architecture" id="{9df62fe0-8f1f-77d2-2677-7c5b5e19c720}">
           <p14:sldIdLst>
             <p14:sldId id="259"/>
             <p14:sldId id="260"/>
             <p14:sldId id="261"/>
           </p14:sldIdLst>
         </p14:section>
-        <p14:section name="Operations" id="{f07aa9ec-6301-65d9-e4cd-c87e2ac36f63}">
+        <p14:section name="Operations" id="{b303326d-7dbf-870e-416d-c457cee15cdb}">
           <p14:sldIdLst>
             <p14:sldId id="262"/>
             <p14:sldId id="263"/>
@@ -165,7 +165,7 @@
             <p14:sldId id="274"/>
           </p14:sldIdLst>
         </p14:section>
-        <p14:section name="Trust and results" id="{e5de63fc-beaa-9d10-cc88-6b5c231aaad5}">
+        <p14:section name="Trust and results" id="{0b3023d1-a0de-88f9-e679-86fe855e101f}">
           <p14:sldIdLst>
             <p14:sldId id="275"/>
             <p14:sldId id="276"/>
@@ -174,18 +174,18 @@
             <p14:sldId id="279"/>
           </p14:sldIdLst>
         </p14:section>
-        <p14:section name="Development" id="{df746dea-730d-1f20-7c03-0d468e9bb8de}">
+        <p14:section name="Development" id="{7037eae4-0dbe-6270-1cd1-98631bfe4eaa}">
           <p14:sldIdLst>
             <p14:sldId id="280"/>
           </p14:sldIdLst>
         </p14:section>
-        <p14:section name="Roadmap" id="{d1a8af95-de03-65a3-26c2-1ca09ac93da2}">
+        <p14:section name="Roadmap" id="{56f8093a-05e7-e875-d6dd-182224081686}">
           <p14:sldIdLst>
             <p14:sldId id="281"/>
             <p14:sldId id="282"/>
           </p14:sldIdLst>
         </p14:section>
-        <p14:section name="Close" id="{0f858e27-2349-ff0f-59f0-05d5c6d3dddb}">
+        <p14:section name="Close" id="{46f502fe-5b84-e9d6-659a-2e32cea8994f}">
           <p14:sldIdLst>
             <p14:sldId id="283"/>
           </p14:sldIdLst>
@@ -1349,9 +1349,9 @@
           </c:marker>
           <c:cat>
             <c:multiLvlStrRef>
-              <c:f>Sheet1!$A$2:$A$27</c:f>
+              <c:f>Sheet1!$A$2:$A$28</c:f>
               <c:multiLvlStrCache>
-                <c:ptCount val="26"/>
+                <c:ptCount val="27"/>
                 <c:lvl>
                   <c:pt idx="0">
                     <c:v>v0</c:v>
@@ -1431,16 +1431,19 @@
                   <c:pt idx="25">
                     <c:v>min-cost</c:v>
                   </c:pt>
+                  <c:pt idx="26">
+                    <c:v>cyc. count</c:v>
+                  </c:pt>
                 </c:lvl>
               </c:multiLvlStrCache>
             </c:multiLvlStrRef>
           </c:cat>
           <c:val>
             <c:numRef>
-              <c:f>Sheet1!$B$2:$B$27</c:f>
+              <c:f>Sheet1!$B$2:$B$28</c:f>
               <c:numCache>
                 <c:formatCode>General</c:formatCode>
-                <c:ptCount val="26"/>
+                <c:ptCount val="27"/>
                 <c:pt idx="0">
                   <c:v>34</c:v>
                 </c:pt>
@@ -1518,6 +1521,9 @@
                 </c:pt>
                 <c:pt idx="25">
                   <c:v>188</c:v>
+                </c:pt>
+                <c:pt idx="26">
+                  <c:v>195</c:v>
                 </c:pt>
               </c:numCache>
             </c:numRef>
@@ -2318,9 +2324,9 @@
           <a:p>
             <a:r>
               <a:rPr lang="en-US" dirty="0"/>
-              <a:t>Sources: docs/API_CONTRACT.md §4: Pattern, Injective patterns; §6; tests/test_injective_pattern.py; git log 8b79971, 7b39f7d, b7e4f12.
+              <a:t>Sources: docs/API_CONTRACT.md §4: Pattern (with counting without listing), Injective patterns; §6; tests/test_injective_pattern.py, tests/test_cyclic_count.py; git log 8b79971, 7b39f7d, b7e4f12, b7bbe3a.
 pattern · trees: Tree patterns without dead ends. Theory: Variables bound by types (through the hierarchy) or IDs, then steps, each one hop from an earlier variable; optional steps keep their row. Algorithm: Yannakakis' semi-join reduction: discover down, prune up, prune down. Totals are counted exactly without listing the rows. Checked by: verify_result checks every row; rows and totals match a brute-force enumerator (400 random patterns) and SCALE's own engine. Rows come in canonical order; counting without listing handles 60⁴ rows in well under a second (git log 8b79971).
-pattern · cycles: Corroboration and contradiction motifs. Theory: A step may close a cycle between bound variables: two supports of a claim from one dataset, a triangle of citations. Algorithm: Worst-case optimal join (Ngo, Porat, Ré and Rudra; Leapfrog Triejoin): candidates meet what every closing step allows. Checked by: Row for row against a brute-force enumerator (300 random cyclic patterns). An interruption keeps a prefix of the rows, never denies. The join intersects a variable's candidates with what every closing step allows, iterating the smallest set first (Veldhuizen's Leapfrog Triejoin).
+pattern · cycles: Corroboration and contradiction motifs. Theory: A step may close a cycle: two supports of a claim from one dataset, a triangle of citations. Algorithm: Listed by a worst-case optimal join (Ngo, Porat, Ré and Rudra); counted without listing by variable elimination over a tree decomposition (FAQ). Checked by: Rows against brute force (300 random patterns); totals against brute force and numpy einsum (850 more). Not certified; never denies. Listing: the join intersects a variable's candidates with what every closing step allows, iterating the smallest set first (Veldhuizen's Leapfrog Triejoin); an interruption keeps a prefix of the rows and never denies. Counting without listing (docs/API_CONTRACT.md §4, Pattern; git log b7bbe3a): answer count and exists compute the total as a sum of products over the required variables (FAQ's InsideOut; Abo Khamis, Ngo and Rudra, 2016). Each required step is a factor of hop counts between its variables' nodes, optional branches fold in as the number of ways they continue, variables are eliminated in a weighted min-fill order planned from the pattern alone (a tree decomposition), and each bag is joined by a generic join and summed out. answer rows lists rows only up to max_results, then counts the rest. A hub (more than 16 neighbours) is ordered last without its fill; an order needing a bag of more than 32 neighbours counts by listing instead. Every part of the work is charged to the expansion budget before it is done, and a batch of k expansions checks the deadline and cancellation exactly as k single ones would. Totals and rows are unchanged; expansions, and so cyclic pattern result_ids, changed. No certificate: a pattern's total is left to oracles, as for tree patterns (the survey's dynamic-programming transcript is not built). Tests (tests/test_cyclic_count.py): 250 random patterns against numpy einsum over hop-count matrices, 300 with optional branches and 300 under max_results against brute force, triangle counts against networkx, trace(A^4) on K(n, n); 7 hand-worked conformance cases on G23 and G13, two pinning the exact budget boundary. Benchmarks (owner's machine, heavily loaded; against the previous commit's listing, the same totals): closed 4-walks on K(30, 30), 1,620,000 rows, 0.04 s against 3.7 s (116k against 3.3 million expansions); closed 5-walks on a random graph of 1,000 nodes and 5,000 edges 1.1 s against 6.1 s; a provenance diamond 0.14 s against 1.05 s; triangles on par. On K(60, 60), 25.9 million closed 4-walks are counted with 894k expansions; listing them would need about 53 million.
 pattern · injective: Substructure search. Theory: injective: true: distinct variables bind distinct nodes, distinct steps distinct edges. Motifs, catalytic sites, rings. No optional steps yet. Algorithm: Over the same Yannakakis-pruned candidates, skipping held nodes and used edges. NP-complete: budget-bounded; exact totals when done. Checked by: Brute force filtered for distinctness, row for row (400 random patterns); networkx's monomorphisms. Interrupted: no absence claimed. Subgraph monomorphism (docs/API_CONTRACT.md §4, Injective patterns): it counts every binding, so a pattern with automorphisms matches one subgraph several times (a hexagon twelve times). The rows are those of the same pattern without injective that use no node or edge twice, in the same canonical order. Distinctness is global, so no count along the kept hops respects it: an injective pattern, tree or cycle, is enumerated as a cycle's is, over the same semi-join-reduced candidates (a match with distinct nodes is a match). Totals are exact when the enumeration ends; an interruption leaves total null and claims no absence. No optional steps yet (unsupported, unsupported_mode): which node an optional step would bind among those left is not yet defined. The verifier and the contract checks reject a row that repeats a node or an edge. Every pattern request now states injective, so earlier pattern requests have new request and result IDs with the same answers (the golden workload's 160 pattern results regenerated). Row enumeration (cycles, injective patterns, tree rows) runs on an explicit stack: a Codex adversarial review found a 1,100-step chain hit Python's recursion limit. Tests (tests/test_injective_pattern.py): 400 random patterns row for row against the brute-force oracle filtered for distinctness; five shapes (a path, a star, a triangle, a square with a chord, a two-cycle) agree with networkx's subgraph monomorphisms (DiGraphMatcher); 3 hand-worked conformance cases. Benchmark (git log b7e4f12): 7,200 hexagon matches (600 rings × 12 symmetries) in a 1,300-atom graphene-like sheet in 0.05 s; networkx's GraphMatcher 0.54 s.</a:t>
             </a:r>
             <a:endParaRPr lang="en-US" dirty="0"/>
@@ -3213,7 +3219,7 @@
           <a:p>
             <a:r>
               <a:rPr lang="en-US" dirty="0"/>
-              <a:t>Counts as of this build: python3 -m pytest (613 pass), src/graph_runtime/conformance/cases.json (188 cases), SCALE parity (16 tests) and STATES parity (6 tests) in their environments; 73 / 73 real consumer requests answer the same with both engines (git log f144c48). Oracles: tests/oracle.py; regular paths against Brzozowski derivatives on 1,500 random graphs (git log f65497b); PageRank against the exact linear system over fractions on 500 graphs (git log 0d4d2b3); negative costs against an independent fixpoint on 1,500 random graphs (tests/test_negative_costs.py). Parity: docs/SCALE_INTEGRATION.md, docs/STATES_INTEGRATION.md. Reviews: git log 8917563, 7ff04db; Codex adversarial reviews before commit: 99fb868 (a request field named kind was overwritten by the digest's record kind, now connectivity; unlisted groups and stray trees in the components certificate), 573ce2b (an interrupted max flow's upper bound was not verified), 1e8678d, 05d3ea5, 1d6dbbf, 04532ba, 107dc68, 297ca1e; 97723bb and 260d7b2 (negative costs and the faster projection identity, reviewed together: no soundness or identity counterexample, 12,000 larger random graphs all matching an independent oracle; one medium issue, diff-based revalidation reading the whole certificate even for an unrelated edit, fixed, and a regression test now forbids it); b7e4f12 (injective patterns: a 1,100-step chain hit Python's recursion limit, so row enumeration for cycles, injective patterns and tree rows now runs on an explicit stack, with a regression test covering rows, count and exists); 741c2dd (spanning forests: the verifier skipped a forest given as a tuple, a Result's frozen answer, which let a stale forest revalidate as holding; it now checks tuples and refuses a missing edge list, and so do three other list-only checks; regression tests cover a Result, a plain dict and a frozen answer); a482dbf (cycle bases: a witness naming a link twice let a non-minimum basis pass, because parity was counted two ways, now refused by the verifier, the contract and the schema; an exhausted budget still allocated every witness as a bitset; a total beyond the floats was rejected instead of written as null beside its exact value; and forged-answer tests stopped at the result_id check, so the forgeries in the negative-cost, injective, forest and basis tests are now resealed to test the semantic checks); 066dbab (weighted matching: an integer-cost certificate could carry floats, 1e100 potentials swallowing a negative reduced cost; every potential, the source and the sink must now be exact); ffd474a (k shortest paths: settled keys kept every edge-ID prefix, quadratic on a long path, 248 MiB on an 8,000-node chain, now released; the contract reader accepted a misordered or repeated list, now checked). Earlier findings shown on previous builds of this slide: a stale nearest cut held and contradicted answers left unknown (incidence, 05d3ea5); exact fields beside false values and unpolled controls (critical path, 1d6dbbf); a nonuniform PageRank start, a lenient ranking revalidation and a quadratic cyclic join (107dc68, the review of 26 October's increments together); the negative-cost review was otherwise sound on 12,000 random graphs against an oracle. 70ff8b4 (minimum-cost flows: a flow's stated relation went unchecked, so a relabelled edge revalidated as holding; an interrupted answer could send more than was asked; both fixed with regressions).</a:t>
+              <a:t>Counts as of this build: python3 -m pytest (631 pass), src/graph_runtime/conformance/cases.json (195 cases), SCALE parity (16 tests) and STATES parity (6 tests) in their environments; 73 / 73 real consumer requests answer the same with both engines (git log f144c48). Oracles: tests/oracle.py; regular paths against Brzozowski derivatives on 1,500 random graphs (git log f65497b); PageRank against the exact linear system over fractions on 500 graphs (git log 0d4d2b3); negative costs against an independent fixpoint on 1,500 random graphs (tests/test_negative_costs.py). Parity: docs/SCALE_INTEGRATION.md, docs/STATES_INTEGRATION.md. Reviews: git log 8917563, 7ff04db; Codex adversarial reviews before commit: 99fb868 (a request field named kind was overwritten by the digest's record kind, now connectivity; unlisted groups and stray trees in the components certificate), 573ce2b (an interrupted max flow's upper bound was not verified), 1e8678d, 05d3ea5, 1d6dbbf, 04532ba, 107dc68, 297ca1e; 97723bb and 260d7b2 (negative costs and the faster projection identity, reviewed together: no soundness or identity counterexample, 12,000 larger random graphs all matching an independent oracle; one medium issue, diff-based revalidation reading the whole certificate even for an unrelated edit, fixed, and a regression test now forbids it); b7e4f12 (injective patterns: a 1,100-step chain hit Python's recursion limit, so row enumeration for cycles, injective patterns and tree rows now runs on an explicit stack, with a regression test covering rows, count and exists); 741c2dd (spanning forests: the verifier skipped a forest given as a tuple, a Result's frozen answer, which let a stale forest revalidate as holding; it now checks tuples and refuses a missing edge list, and so do three other list-only checks; regression tests cover a Result, a plain dict and a frozen answer); a482dbf (cycle bases: a witness naming a link twice let a non-minimum basis pass, because parity was counted two ways, now refused by the verifier, the contract and the schema; an exhausted budget still allocated every witness as a bitset; a total beyond the floats was rejected instead of written as null beside its exact value; and forged-answer tests stopped at the result_id check, so the forgeries in the negative-cost, injective, forest and basis tests are now resealed to test the semantic checks); 066dbab (weighted matching: an integer-cost certificate could carry floats, 1e100 potentials swallowing a negative reduced cost; every potential, the source and the sink must now be exact); ffd474a (k shortest paths: settled keys kept every edge-ID prefix, quadratic on a long path, 248 MiB on an 8,000-node chain, now released; the contract reader accepted a misordered or repeated list, now checked). Earlier findings shown on previous builds of this slide: a stale nearest cut held and contradicted answers left unknown (incidence, 05d3ea5); exact fields beside false values and unpolled controls (critical path, 1d6dbbf); a nonuniform PageRank start, a lenient ranking revalidation and a quadratic cyclic join (107dc68, the review of 26 October's increments together); the negative-cost review was otherwise sound on 12,000 random graphs against an oracle. 70ff8b4 (minimum-cost flows: a flow's stated relation went unchecked, so a relabelled edge revalidated as holding; an interrupted answer could send more than was asked; both fixed with regressions); b7bbe3a (cyclic pattern counts, four review passes, each finding fixed with a regression test: planning the elimination order was cubic on an 800-variable star pattern, 7.4 s for one row; a batched expansion charge checked cancellation only once per batch, so a batch of k now checks the deadline and cancellation exactly as k single expansions would; planning on K(17, n) patterns and wide bags was not charged to the budget; request normalization of patterns with many steps was quadratic, rebuilding the edge-variable set per step; the setup of a 100,000-spoke pattern was not charged; growing products, up to 2^400000, were built before a zero loop factor, which now removes its node first).</a:t>
             </a:r>
             <a:endParaRPr lang="en-US" dirty="0"/>
           </a:p>
@@ -3394,7 +3400,7 @@
           <a:p>
             <a:r>
               <a:rPr lang="en-US" dirty="0"/>
-              <a:t>Left: docs/STATES_INTEGRATION.md, Cost (benchmarks/consumers.py, 26 October 2026). Mean of 42 contexts: STATES's extract_context 58.5 ms; GRAPH through a lift 305 ms (222 ms lift + 0.34 ms query); GRAPH on the cell 17.1 ms (10.6 ms projection + 0.76 ms query). The cell's projection depends only on the record, so it can be built once and reused. Heavily loaded machine: compare ratios. Right: Structure benchmark (99fb868 increment), git log 573ce2b, 1e8678d and 1d6dbbf; flows, matching, dominators and critical path measured on the owner's machine. Also: weak components 0.45 s, unit-capacity max flow 3.8 s. Negative costs (git log 97723bb; measured on an Apple M4): 20,000 nodes and 100,000 edges, 31% negative, no negative cycle; GRAPH 0.10 s with its feasible-potentials certificate, networkx bellman_ford 0.13 s and goldberg_radzik 0.39 s, the same cost. With a negative cycle planted near the source, networkx find_negative_cycle takes 0.002 s and GRAPH 0.042 s: GRAPH first computes the corridor between the sources and the targets (one linear pass), so that a cycle that cannot reach a target is ignored. Hexagon search (git log b7e4f12): an injective six-ring pattern counted in a graphene-like sheet of 1,300 atoms (networkx hexagonal_lattice_graph(20, 30)), 7,200 matches, 600 rings × 12 symmetries, GRAPH 0.05 s, networkx GraphMatcher's subgraph monomorphisms 0.54 s. Spanning forest (git log 741c2dd): 100,000 nodes and 300,000 random edges with integer weights, GRAPH 0.89 s, networkx minimum_spanning_edges (Kruskal) 0.92 s on the same multigraph; GRAPH's verifier proves the forest in 3.05 s. Weighted matching (git log 066dbab): 300 + 300 nodes and 6,000 random hops with integer costs, GRAPH 0.25 s with its cover-and-potentials certificate (proven in 0.02 s), networkx max_weight_matching (maxcardinality, costs turned into weights) 0.81 s; 2,000 + 2,000 nodes and 40,000 hops: GRAPH 13.9 s. k shortest paths (git log ffd474a): 20,000 nodes and 100,000 edges, k = 20, GRAPH 3.07 s, networkx shortest_simple_paths 0.30 s, the same costs; on 2,000 nodes and 10,000 edges, k = 50, GRAPH 0.32 s, networkx 0.18 s. networkx's spur searches are bidirectional, which GRAPH's strict order of ties (cost, hops, start node and edge IDs) does not allow here. Cycle basis (git log a482dbf), not charted because the sizes differ: GRAPH 0.16 s for 600 six-rings of a 1,300-atom graphene-like sheet, proven in 0.07 s; networkx minimum_cycle_basis 0.59 s for a 124-atom sheet. Min-cost flow (git log 70ff8b4): 5,000 nodes and 30,000 random edges, capacities 1 to 10 and costs 0 to 20, 5 sources and 5 targets, as much as possible: GRAPH 0.61 s with its certificate, proven in 0.11 s; networkx max_flow_min_cost 4.25 s on the same network with a middle node per edge (so parallel edges stay distinct); on 500 nodes and 3,000 edges, GRAPH 0.04 s, networkx 0.17 s. Machine load for the last six was not recorded in the commits. Articulation points: GRAPH's biconnectivity (which also finds bridges) against networkx's articulation_points; max flow: 5 sources, 5 targets, integer capacities, against networkx maximum_flow_value; matching: against networkx hopcroft_karp_matching; dominators: against networkx immediate_dominators (GRAPH 0.65 s, 1.37 s with the low-high certificate). GRAPH's answers come with certificates.</a:t>
+              <a:t>Left: docs/STATES_INTEGRATION.md, Cost (benchmarks/consumers.py, 26 October 2026). Mean of 42 contexts: STATES's extract_context 58.5 ms; GRAPH through a lift 305 ms (222 ms lift + 0.34 ms query); GRAPH on the cell 17.1 ms (10.6 ms projection + 0.76 ms query). The cell's projection depends only on the record, so it can be built once and reused. Heavily loaded machine: compare ratios. Right: Structure benchmark (99fb868 increment), git log 573ce2b, 1e8678d and 1d6dbbf; flows, matching, dominators and critical path measured on the owner's machine. Also: weak components 0.45 s, unit-capacity max flow 3.8 s. Negative costs (git log 97723bb; measured on an Apple M4): 20,000 nodes and 100,000 edges, 31% negative, no negative cycle; GRAPH 0.10 s with its feasible-potentials certificate, networkx bellman_ford 0.13 s and goldberg_radzik 0.39 s, the same cost. With a negative cycle planted near the source, networkx find_negative_cycle takes 0.002 s and GRAPH 0.042 s: GRAPH first computes the corridor between the sources and the targets (one linear pass), so that a cycle that cannot reach a target is ignored. Hexagon search (git log b7e4f12): an injective six-ring pattern counted in a graphene-like sheet of 1,300 atoms (networkx hexagonal_lattice_graph(20, 30)), 7,200 matches, 600 rings × 12 symmetries, GRAPH 0.05 s, networkx GraphMatcher's subgraph monomorphisms 0.54 s. Spanning forest (git log 741c2dd): 100,000 nodes and 300,000 random edges with integer weights, GRAPH 0.89 s, networkx minimum_spanning_edges (Kruskal) 0.92 s on the same multigraph; GRAPH's verifier proves the forest in 3.05 s. Weighted matching (git log 066dbab): 300 + 300 nodes and 6,000 random hops with integer costs, GRAPH 0.25 s with its cover-and-potentials certificate (proven in 0.02 s), networkx max_weight_matching (maxcardinality, costs turned into weights) 0.81 s; 2,000 + 2,000 nodes and 40,000 hops: GRAPH 13.9 s. k shortest paths (git log ffd474a): 20,000 nodes and 100,000 edges, k = 20, GRAPH 3.07 s, networkx shortest_simple_paths 0.30 s, the same costs; on 2,000 nodes and 10,000 edges, k = 50, GRAPH 0.32 s, networkx 0.18 s. networkx's spur searches are bidirectional, which GRAPH's strict order of ties (cost, hops, start node and edge IDs) does not allow here. Cycle basis (git log a482dbf), not charted because the sizes differ: GRAPH 0.16 s for 600 six-rings of a 1,300-atom graphene-like sheet, proven in 0.07 s; networkx minimum_cycle_basis 0.59 s for a 124-atom sheet. Min-cost flow (git log 70ff8b4): 5,000 nodes and 30,000 random edges, capacities 1 to 10 and costs 0 to 20, 5 sources and 5 targets, as much as possible: GRAPH 0.61 s with its certificate, proven in 0.11 s; networkx max_flow_min_cost 4.25 s on the same network with a middle node per edge (so parallel edges stay distinct); on 500 nodes and 3,000 edges, GRAPH 0.04 s, networkx 0.17 s. Machine load for the last six was not recorded in the commits. Cyclic pattern counts (git log b7bbe3a), not charted because the comparison is with GRAPH's own earlier listing (the previous commit, 105393c, with its budget raised so both finish), not with networkx; measured on the owner's machine under heavy load from other processes, the same totals throughout: closed 4-walks on the complete bipartite graph K(30, 30), both directions, 1,620,000 rows, 0.04 s against 3.7 s, 116k against 3.3 million expansions; closed 5-walks on networkx gnm_random_graph(1000, 5000), 149,300 rows, 1.1 s against 6.1 s; a provenance diamond (300 claims and 40 measurements in 30 datasets: two supports of a claim from one dataset), 27,432 rows, 0.14 s against 1.05 s, 111k against 572k expansions; closed 4-walks on gnm_random_graph(2000, 8000), 274,524 rows, 0.31 s against 1.11 s; triangles (closed 3-walks) on gnm_random_graph(3000, 30000), 0.44 s against 0.40 s, on par (networkx triangles takes 0.04 s for the plain triangle count); closed 4-walks on K(60, 60), 25.9 million rows, counted with 894k expansions where listing would need about 53 million. Articulation points: GRAPH's biconnectivity (which also finds bridges) against networkx's articulation_points; max flow: 5 sources, 5 targets, integer capacities, against networkx maximum_flow_value; matching: against networkx hopcroft_karp_matching; dominators: against networkx immediate_dominators (GRAPH 0.65 s, 1.37 s with the low-high certificate). GRAPH's answers come with certificates.</a:t>
             </a:r>
             <a:endParaRPr lang="en-US" dirty="0"/>
           </a:p>
@@ -3570,7 +3576,7 @@
           <a:p>
             <a:r>
               <a:rPr lang="en-US" dirty="0"/>
-              <a:t>Source: git log, 550c362 (25 October, 17:17) to 70ff8b4 (26 October, 23:59): 46 commits, slide commits included; some rows group neighbouring commits (17:17 is v0 with the independent review's fixes at 17:36, 8917563, and the Codex review behind contract v0.1 at 20:46, 7ff04db; 10:29 is flows and matching, 573ce2b, with dominators at 10:43, 1e8678d, and revalidation by certificate at 10:47, 0a58767; 11:16 is incidence, 05d3ea5, with critical paths at 11:32, 1d6dbbf, and d-separation at 11:44, 83f9ffe; 17:45 is the fixes from a review of the day's increments, 107dc68, with support certificates at 18:23, 297ca1e; 22:38 is injective patterns, b7e4f12, with spanning forests at 22:55, 741c2dd; 23:11 is cycle bases, a482dbf, with weighted matching at 23:25, 066dbab; 23:40 is k shortest paths, ffd474a; 23:59 is minimum-cost flows, 70ff8b4), and 22:11 is two (260d7b2, the projection identity hashed with each node ID, relation and type encoded once: 61 to 34 ms, the build 245 to 206 ms on 50,000 nodes and 150,000 edges, identity bytes unchanged on 400 random projections; 97723bb, negative costs). Conformance case counts are from the commit messages (34 at v0, then 49, 54, 62, 70, 74, 78, 91, 100, 112, 116, 121, 133, 143, 148, 153, 158, 165, 168, 173, 176, 180, 182, 183, 185) and cases.json now (188). Tests: 178 → 613. Commit times are local (-0400).</a:t>
+              <a:t>Source: git log, 550c362 (25 October, 17:17) to b7bbe3a (27 October, 10:28): 48 commits, slide commits included; some rows group neighbouring commits (17:17 is v0 with the independent review's fixes at 17:36, 8917563, and the Codex review behind contract v0.1 at 20:46, 7ff04db; 10:29 is flows and matching, 573ce2b, with dominators at 10:43, 1e8678d, and revalidation by certificate at 10:47, 0a58767; 11:16 is incidence, 05d3ea5, with critical paths at 11:32, 1d6dbbf, and d-separation at 11:44, 83f9ffe; 17:45 is the fixes from a review of the day's increments, 107dc68, with support certificates at 18:23, 297ca1e; 22:38 is injective patterns, b7e4f12, with spanning forests at 22:55, 741c2dd, and cycle bases at 23:11, a482dbf; 23:25 is weighted matching, 066dbab, with k shortest paths at 23:40, ffd474a; 23:59 is minimum-cost flows, 70ff8b4; on 27 October, 00:04 is a slide commit, 105393c, and 10:28 is cyclic patterns counted without listing, b7bbe3a), and 22:11 is two (260d7b2, the projection identity hashed with each node ID, relation and type encoded once: 61 to 34 ms, the build 245 to 206 ms on 50,000 nodes and 150,000 edges, identity bytes unchanged on 400 random projections; 97723bb, negative costs). Conformance case counts are from the commit messages (34 at v0, then 49, 54, 62, 70, 74, 78, 91, 100, 112, 116, 121, 133, 143, 148, 153, 158, 165, 168, 173, 176, 180, 182, 183, 185, 188) and cases.json now (195). Tests: 178 → 631. Commit times are local (-0400).</a:t>
             </a:r>
             <a:endParaRPr lang="en-US" dirty="0"/>
           </a:p>
@@ -3658,7 +3664,7 @@
           <a:p>
             <a:r>
               <a:rPr lang="en-US" dirty="0"/>
-              <a:t>Sources: A Codex literature survey of 26 October 2026, kept outside the repository; its recommended order weighs scientific usefulness, implementation effort and the cost of independently proving each answer. Seven of its items have shipped: negative-cost shortest paths (97723bb); injective patterns (b7e4f12: the survey suggested VF2++-style backtracking with Glasgow-style filtering and refutation trees for negatives; GRAPH enumerates over its Yannakakis-pruned candidates, budget-bounded, and an interrupted search claims no absence); the minimum spanning forest (741c2dd: Kruskal, the forest its own certificate by the cycle property); the minimum cycle basis (a482dbf: de Pina's algorithm, minimality proven by its witnesses; relevant cycles, after Vismara, not yet); weighted matching (066dbab: successive shortest paths, the survey's first slice of item 5, proven by König's cover and residual potentials); k shortest simple paths (ffd474a: Yen with Lawler's rule; the survey's certificate, a Lawler partition tree proving the ranking, is not built: each path is a checked witness and the ranking is tested against an oracle); and min-cost flow (70ff8b4: successive shortest paths with potentials, the rest of item 5; costs non-negative, so the survey's pseudoflow start for negative arcs is not needed; proven by residual potentials and, for a maximum flow, a minimum cut). Survey notes per row: cyclic pattern counting (variable elimination, FAQ InsideOut; a decomposition and dynamic-programming transcript); reachability index (strong components condensed, then pruned landmark 2-hop labels; Cohen, Halperin, Kaplan and Zwick 2003; Akiba, Iwata and Yoshida 2013; a positive expands hub routing pointers into ordinary hops, checked in the walk's length; disjoint labels alone do not prove a negative, which needs a closed set); positive Datalog (range-restricted, function-free, semi-naive evaluation; a derivation tree or DAG with strictly increasing ranks, checked in the proof's size; Abiteboul, Hull and Vianu 1995; Green, Karvounarakis and Tannen 2007, provenance semirings); isomorphism and canonical labeling (individualization-refinement; a vertex and edge bijection proves isomorphism in linear time; non-isomorphism and canonical forms need an independently checked individualization-refinement trace, possibly exponential; McKay and Piperno 2014; useful for scientific deduplication); elementary flux modes (exact double description over the incidence operation's stoichiometric matrix, small networks first; each mode's exact balance, and rank(S_J) = |J| - 1 shown by a nonsingular minor, prove its support minimal; completeness needs a full transcript; Gagneur and Klamt 2004; Terzer and Stelling 2008). Each increment is planned to ship with code, docs/API_CONTRACT.md, the schema, hand-worked conformance cases, tests against an independent oracle, verification and revalidation, and a Codex adversarial review of its diff.</a:t>
+              <a:t>Sources: A Codex literature survey of 26 October 2026, kept outside the repository; its recommended order weighs scientific usefulness, implementation effort and the cost of independently proving each answer. Eight of its items have shipped: negative-cost shortest paths (97723bb); injective patterns (b7e4f12: the survey suggested VF2++-style backtracking with Glasgow-style filtering and refutation trees for negatives; GRAPH enumerates over its Yannakakis-pruned candidates, budget-bounded, and an interrupted search claims no absence); the minimum spanning forest (741c2dd: Kruskal, the forest its own certificate by the cycle property); the minimum cycle basis (a482dbf: de Pina's algorithm, minimality proven by its witnesses; relevant cycles, after Vismara, not yet); weighted matching (066dbab: successive shortest paths, the survey's first slice of item 5, proven by König's cover and residual potentials); k shortest simple paths (ffd474a: Yen with Lawler's rule; the survey's certificate, a Lawler partition tree proving the ranking, is not built: each path is a checked witness and the ranking is tested against an oracle); and min-cost flow (70ff8b4: successive shortest paths with potentials, the rest of item 5; costs non-negative, so the survey's pseudoflow start for negative arcs is not needed; proven by residual potentials and, for a maximum flow, a minimum cut); and cyclic pattern counting (b7bbe3a: variable elimination along a tree decomposition, FAQ's InsideOut, in a weighted min-fill order planned from the pattern alone, with a generic join inside each bag; the survey's certificate, a decomposition and dynamic-programming transcript (count_dp) whose messages a checker recomputes, is not built: a pattern's total is left to oracles, numpy einsum and brute force, as for tree patterns). Survey notes per row: reachability index (strong components condensed, then pruned landmark 2-hop labels; Cohen, Halperin, Kaplan and Zwick 2003; Akiba, Iwata and Yoshida 2013; a positive expands hub routing pointers into ordinary hops, checked in the walk's length; disjoint labels alone do not prove a negative, which needs a closed set); positive Datalog (range-restricted, function-free, semi-naive evaluation; a derivation tree or DAG with strictly increasing ranks, checked in the proof's size; Abiteboul, Hull and Vianu 1995; Green, Karvounarakis and Tannen 2007, provenance semirings); isomorphism and canonical labeling (individualization-refinement; a vertex and edge bijection proves isomorphism in linear time; non-isomorphism and canonical forms need an independently checked individualization-refinement trace, possibly exponential; McKay and Piperno 2014; useful for scientific deduplication); elementary flux modes (exact double description over the incidence operation's stoichiometric matrix, small networks first; each mode's exact balance, and rank(S_J) = |J| - 1 shown by a nonsingular minor, prove its support minimal; completeness needs a full transcript; Gagneur and Klamt 2004; Terzer and Stelling 2008). Each increment is planned to ship with code, docs/API_CONTRACT.md, the schema, hand-worked conformance cases, tests against an independent oracle, verification and revalidation, and a Codex adversarial review of its diff.</a:t>
             </a:r>
             <a:endParaRPr lang="en-US" dirty="0"/>
           </a:p>
@@ -8592,7 +8598,7 @@
                   <a:schemeClr val="tx1"/>
                 </a:solidFill>
               </a:rPr>
-              <a:t>A step may close a cycle between bound variables: two supports of a claim from one dataset, a triangle of citations.</a:t>
+              <a:t>A step may close a cycle: two supports of a claim from one dataset, a triangle of citations.</a:t>
             </a:r>
             <a:endParaRPr lang="en-US" sz="1400" dirty="0"/>
           </a:p>
@@ -8617,7 +8623,7 @@
                   <a:schemeClr val="tx1"/>
                 </a:solidFill>
               </a:rPr>
-              <a:t>Worst-case optimal join (Ngo, Porat, Ré and Rudra; Leapfrog Triejoin): candidates meet what every closing step allows.</a:t>
+              <a:t>Listed by a worst-case optimal join (Ngo, Porat, Ré and Rudra); counted without listing by variable elimination over a tree decomposition (FAQ).</a:t>
             </a:r>
             <a:endParaRPr lang="en-US" sz="1400" dirty="0"/>
           </a:p>
@@ -8740,7 +8746,7 @@
                   <a:schemeClr val="tx1"/>
                 </a:solidFill>
               </a:rPr>
-              <a:t>Row for row against a brute-force enumerator (300 random cyclic patterns). An interruption keeps a prefix of the rows, never denies.</a:t>
+              <a:t>Rows against brute force (300 random patterns); totals against brute force and numpy einsum (850 more). Not certified; never denies.</a:t>
             </a:r>
             <a:endParaRPr lang="en-US" sz="1400" dirty="0"/>
           </a:p>
@@ -19396,7 +19402,7 @@
                 <a:ea typeface="Cambria" pitchFamily="34" charset="-122"/>
                 <a:cs typeface="Cambria" pitchFamily="34" charset="-120"/>
               </a:rPr>
-              <a:t>613</a:t>
+              <a:t>631</a:t>
             </a:r>
             <a:endParaRPr lang="en-US" sz="3400" dirty="0"/>
           </a:p>
@@ -19471,7 +19477,7 @@
                 <a:ea typeface="Cambria" pitchFamily="34" charset="-122"/>
                 <a:cs typeface="Cambria" pitchFamily="34" charset="-120"/>
               </a:rPr>
-              <a:t>188</a:t>
+              <a:t>195</a:t>
             </a:r>
             <a:endParaRPr lang="en-US" sz="3400" dirty="0"/>
           </a:p>
@@ -20332,7 +20338,7 @@
                   <a:schemeClr val="accent6"/>
                 </a:solidFill>
               </a:rPr>
-              <a:t>Codex reviews each increment adversarially before commit; every finding is fixed with a regression. Among them: a request_id collision and certificate holes (structure); an unverified interrupted bound (max flow); an unchecked relation and an interruption sending more than asked (min-cost flow); quadratic checks (dominators, support) and memory (k shortest paths); floats that let a false rank or false potentials verify (incidence, weighted matching); a path from outside the sources' region (critical path); a whole certificate read for any edit (negative costs); the recursion limit on long chains (injective patterns); frozen answers left unchecked (forests); a repeated witness link passing a non-minimum basis (cycle bases); a misordered path list (k shortest paths). d-separation: no findings.</a:t>
+              <a:t>Codex reviews each increment adversarially before commit; every finding is fixed with a regression. Among them: a request_id collision and certificate holes (structure); an unverified interrupted bound (max flow); an unchecked relation (min-cost flow); quadratic checks (dominators, support) and memory (k shortest paths); cubic planning, uncharged work and batches checking cancellation once (cyclic counts); floats that let a false rank or potentials verify (incidence, weighted matching); a path from outside the sources' region (critical path); a whole certificate read for any edit (negative costs); the recursion limit (injective patterns); frozen answers left unchecked (forests); a repeated witness link (cycle bases); a misordered path list (k shortest paths). d-separation: no findings.</a:t>
             </a:r>
             <a:endParaRPr lang="en-US" sz="1200" dirty="0"/>
           </a:p>
@@ -21226,7 +21232,7 @@
         </p:nvGraphicFramePr>
         <p:xfrm>
           <a:off x="548640" y="1691640"/>
-          <a:ext cx="5364328" cy="3382010"/>
+          <a:ext cx="5364328" cy="3180588"/>
         </p:xfrm>
         <a:graphic xmlns:a="http://schemas.openxmlformats.org/drawingml/2006/main">
           <a:graphicData uri="http://schemas.openxmlformats.org/drawingml/2006/chart">
@@ -21242,8 +21248,8 @@
         </p:nvSpPr>
         <p:spPr>
           <a:xfrm>
-            <a:off x="548640" y="5165090"/>
-            <a:ext cx="5364328" cy="1052830"/>
+            <a:off x="548640" y="4963668"/>
+            <a:ext cx="5364328" cy="1254252"/>
           </a:xfrm>
           <a:prstGeom prst="rect">
             <a:avLst/>
@@ -21278,7 +21284,7 @@
         </p:nvGraphicFramePr>
         <p:xfrm>
           <a:off x="6278728" y="1691640"/>
-          <a:ext cx="5364328" cy="3382010"/>
+          <a:ext cx="5364328" cy="3180588"/>
         </p:xfrm>
         <a:graphic xmlns:a="http://schemas.openxmlformats.org/drawingml/2006/main">
           <a:graphicData uri="http://schemas.openxmlformats.org/drawingml/2006/chart">
@@ -21294,8 +21300,8 @@
         </p:nvSpPr>
         <p:spPr>
           <a:xfrm>
-            <a:off x="6278728" y="5165090"/>
-            <a:ext cx="5364328" cy="1052830"/>
+            <a:off x="6278728" y="4963668"/>
+            <a:ext cx="5364328" cy="1254252"/>
           </a:xfrm>
           <a:prstGeom prst="rect">
             <a:avLst/>
@@ -21316,7 +21322,7 @@
                   <a:schemeClr val="tx1"/>
                 </a:solidFill>
               </a:rPr>
-              <a:t>100k nodes, 500k edges; min-cost flow 5k nodes, 30k edges; matching 50k + 50k; dominators and forest 300k edges; critical path 400k (networkx: no order certificate). Negative costs 20k nodes; weighted 300 + 300; hexagons in 1,300 atoms; 20 shortest paths in 20k nodes (networkx searches both ways).</a:t>
+              <a:t>100k nodes, 500k edges; min-cost flow 5k nodes, 30k edges; matching 50k + 50k; dominators and forest 300k edges; critical path 400k (networkx: no order certificate). Negative costs 20k nodes; weighted 300 + 300; hexagons in 1,300 atoms; 20 shortest paths in 20k nodes (networkx searches both ways). Not charted: 1.6 M closed 4-walks on K(30,30) counted in 0.04 s, against 3.7 s by GRAPH's earlier listing.</a:t>
             </a:r>
             <a:endParaRPr lang="en-US" sz="1300" dirty="0"/>
           </a:p>
@@ -23013,7 +23019,7 @@
                   <a:schemeClr val="accent6"/>
                 </a:solidFill>
               </a:rPr>
-              <a:t>Forty-six commits on 25–26 October 2026: from four operations to twenty-three.</a:t>
+              <a:t>Forty-eight commits on 25–27 October 2026: from four operations to twenty-three.</a:t>
             </a:r>
             <a:endParaRPr lang="en-US" sz="1600" dirty="0"/>
           </a:p>
@@ -23027,8 +23033,8 @@
         </p:nvSpPr>
         <p:spPr>
           <a:xfrm>
-            <a:off x="1508760" y="1824766"/>
-            <a:ext cx="0" cy="4260028"/>
+            <a:off x="1508760" y="1817370"/>
+            <a:ext cx="0" cy="4274820"/>
           </a:xfrm>
           <a:prstGeom prst="line">
             <a:avLst/>
@@ -23051,7 +23057,7 @@
         <p:spPr>
           <a:xfrm>
             <a:off x="1783080" y="1691640"/>
-            <a:ext cx="4389120" cy="266252"/>
+            <a:ext cx="4389120" cy="251460"/>
           </a:xfrm>
           <a:prstGeom prst="rect">
             <a:avLst/>
@@ -23086,7 +23092,7 @@
         </p:nvSpPr>
         <p:spPr>
           <a:xfrm>
-            <a:off x="1435608" y="2017866"/>
+            <a:off x="1435608" y="1995678"/>
             <a:ext cx="146304" cy="146304"/>
           </a:xfrm>
           <a:prstGeom prst="ellipse">
@@ -23111,8 +23117,8 @@
         </p:nvSpPr>
         <p:spPr>
           <a:xfrm>
-            <a:off x="548640" y="1957892"/>
-            <a:ext cx="777240" cy="266252"/>
+            <a:off x="548640" y="1943100"/>
+            <a:ext cx="777240" cy="251460"/>
           </a:xfrm>
           <a:prstGeom prst="rect">
             <a:avLst/>
@@ -23147,8 +23153,8 @@
         </p:nvSpPr>
         <p:spPr>
           <a:xfrm>
-            <a:off x="1783080" y="1957892"/>
-            <a:ext cx="4434840" cy="266252"/>
+            <a:off x="1783080" y="1943100"/>
+            <a:ext cx="4434840" cy="251460"/>
           </a:xfrm>
           <a:prstGeom prst="rect">
             <a:avLst/>
@@ -23183,7 +23189,7 @@
         </p:nvSpPr>
         <p:spPr>
           <a:xfrm>
-            <a:off x="1435608" y="2284117"/>
+            <a:off x="1435608" y="2247138"/>
             <a:ext cx="146304" cy="146304"/>
           </a:xfrm>
           <a:prstGeom prst="ellipse">
@@ -23208,8 +23214,8 @@
         </p:nvSpPr>
         <p:spPr>
           <a:xfrm>
-            <a:off x="548640" y="2224144"/>
-            <a:ext cx="777240" cy="266252"/>
+            <a:off x="548640" y="2194560"/>
+            <a:ext cx="777240" cy="251460"/>
           </a:xfrm>
           <a:prstGeom prst="rect">
             <a:avLst/>
@@ -23244,8 +23250,8 @@
         </p:nvSpPr>
         <p:spPr>
           <a:xfrm>
-            <a:off x="1783080" y="2224144"/>
-            <a:ext cx="4434840" cy="266252"/>
+            <a:off x="1783080" y="2194560"/>
+            <a:ext cx="4434840" cy="251460"/>
           </a:xfrm>
           <a:prstGeom prst="rect">
             <a:avLst/>
@@ -23280,7 +23286,7 @@
         </p:nvSpPr>
         <p:spPr>
           <a:xfrm>
-            <a:off x="1435608" y="2550369"/>
+            <a:off x="1435608" y="2498598"/>
             <a:ext cx="146304" cy="146304"/>
           </a:xfrm>
           <a:prstGeom prst="ellipse">
@@ -23305,8 +23311,8 @@
         </p:nvSpPr>
         <p:spPr>
           <a:xfrm>
-            <a:off x="548640" y="2490395"/>
-            <a:ext cx="777240" cy="266252"/>
+            <a:off x="548640" y="2446020"/>
+            <a:ext cx="777240" cy="251460"/>
           </a:xfrm>
           <a:prstGeom prst="rect">
             <a:avLst/>
@@ -23341,8 +23347,8 @@
         </p:nvSpPr>
         <p:spPr>
           <a:xfrm>
-            <a:off x="1783080" y="2490395"/>
-            <a:ext cx="4434840" cy="266252"/>
+            <a:off x="1783080" y="2446020"/>
+            <a:ext cx="4434840" cy="251460"/>
           </a:xfrm>
           <a:prstGeom prst="rect">
             <a:avLst/>
@@ -23377,8 +23383,8 @@
         </p:nvSpPr>
         <p:spPr>
           <a:xfrm>
-            <a:off x="1783080" y="2756647"/>
-            <a:ext cx="4389120" cy="266252"/>
+            <a:off x="1783080" y="2697480"/>
+            <a:ext cx="4389120" cy="251460"/>
           </a:xfrm>
           <a:prstGeom prst="rect">
             <a:avLst/>
@@ -23413,7 +23419,7 @@
         </p:nvSpPr>
         <p:spPr>
           <a:xfrm>
-            <a:off x="1435608" y="3082873"/>
+            <a:off x="1435608" y="3001518"/>
             <a:ext cx="146304" cy="146304"/>
           </a:xfrm>
           <a:prstGeom prst="ellipse">
@@ -23438,8 +23444,8 @@
         </p:nvSpPr>
         <p:spPr>
           <a:xfrm>
-            <a:off x="548640" y="3022899"/>
-            <a:ext cx="777240" cy="266252"/>
+            <a:off x="548640" y="2948940"/>
+            <a:ext cx="777240" cy="251460"/>
           </a:xfrm>
           <a:prstGeom prst="rect">
             <a:avLst/>
@@ -23474,8 +23480,8 @@
         </p:nvSpPr>
         <p:spPr>
           <a:xfrm>
-            <a:off x="1783080" y="3022899"/>
-            <a:ext cx="4434840" cy="266252"/>
+            <a:off x="1783080" y="2948940"/>
+            <a:ext cx="4434840" cy="251460"/>
           </a:xfrm>
           <a:prstGeom prst="rect">
             <a:avLst/>
@@ -23524,7 +23530,7 @@
         </p:nvSpPr>
         <p:spPr>
           <a:xfrm>
-            <a:off x="1435608" y="3349124"/>
+            <a:off x="1435608" y="3252978"/>
             <a:ext cx="146304" cy="146304"/>
           </a:xfrm>
           <a:prstGeom prst="ellipse">
@@ -23549,8 +23555,8 @@
         </p:nvSpPr>
         <p:spPr>
           <a:xfrm>
-            <a:off x="548640" y="3289151"/>
-            <a:ext cx="777240" cy="266252"/>
+            <a:off x="548640" y="3200400"/>
+            <a:ext cx="777240" cy="251460"/>
           </a:xfrm>
           <a:prstGeom prst="rect">
             <a:avLst/>
@@ -23585,8 +23591,8 @@
         </p:nvSpPr>
         <p:spPr>
           <a:xfrm>
-            <a:off x="1783080" y="3289151"/>
-            <a:ext cx="4434840" cy="266252"/>
+            <a:off x="1783080" y="3200400"/>
+            <a:ext cx="4434840" cy="251460"/>
           </a:xfrm>
           <a:prstGeom prst="rect">
             <a:avLst/>
@@ -23660,7 +23666,7 @@
         </p:nvSpPr>
         <p:spPr>
           <a:xfrm>
-            <a:off x="1435608" y="3615376"/>
+            <a:off x="1435608" y="3504438"/>
             <a:ext cx="146304" cy="146304"/>
           </a:xfrm>
           <a:prstGeom prst="ellipse">
@@ -23685,8 +23691,8 @@
         </p:nvSpPr>
         <p:spPr>
           <a:xfrm>
-            <a:off x="548640" y="3555402"/>
-            <a:ext cx="777240" cy="266252"/>
+            <a:off x="548640" y="3451860"/>
+            <a:ext cx="777240" cy="251460"/>
           </a:xfrm>
           <a:prstGeom prst="rect">
             <a:avLst/>
@@ -23721,8 +23727,8 @@
         </p:nvSpPr>
         <p:spPr>
           <a:xfrm>
-            <a:off x="1783080" y="3555402"/>
-            <a:ext cx="4434840" cy="266252"/>
+            <a:off x="1783080" y="3451860"/>
+            <a:ext cx="4434840" cy="251460"/>
           </a:xfrm>
           <a:prstGeom prst="rect">
             <a:avLst/>
@@ -23771,7 +23777,7 @@
         </p:nvSpPr>
         <p:spPr>
           <a:xfrm>
-            <a:off x="1435608" y="3881628"/>
+            <a:off x="1435608" y="3755898"/>
             <a:ext cx="146304" cy="146304"/>
           </a:xfrm>
           <a:prstGeom prst="ellipse">
@@ -23796,8 +23802,8 @@
         </p:nvSpPr>
         <p:spPr>
           <a:xfrm>
-            <a:off x="548640" y="3821654"/>
-            <a:ext cx="777240" cy="266252"/>
+            <a:off x="548640" y="3703320"/>
+            <a:ext cx="777240" cy="251460"/>
           </a:xfrm>
           <a:prstGeom prst="rect">
             <a:avLst/>
@@ -23832,8 +23838,8 @@
         </p:nvSpPr>
         <p:spPr>
           <a:xfrm>
-            <a:off x="1783080" y="3821654"/>
-            <a:ext cx="4434840" cy="266252"/>
+            <a:off x="1783080" y="3703320"/>
+            <a:ext cx="4434840" cy="251460"/>
           </a:xfrm>
           <a:prstGeom prst="rect">
             <a:avLst/>
@@ -23907,7 +23913,7 @@
         </p:nvSpPr>
         <p:spPr>
           <a:xfrm>
-            <a:off x="1435608" y="4147880"/>
+            <a:off x="1435608" y="4007358"/>
             <a:ext cx="146304" cy="146304"/>
           </a:xfrm>
           <a:prstGeom prst="ellipse">
@@ -23932,8 +23938,8 @@
         </p:nvSpPr>
         <p:spPr>
           <a:xfrm>
-            <a:off x="548640" y="4087906"/>
-            <a:ext cx="777240" cy="266252"/>
+            <a:off x="548640" y="3954780"/>
+            <a:ext cx="777240" cy="251460"/>
           </a:xfrm>
           <a:prstGeom prst="rect">
             <a:avLst/>
@@ -23968,8 +23974,8 @@
         </p:nvSpPr>
         <p:spPr>
           <a:xfrm>
-            <a:off x="1783080" y="4087906"/>
-            <a:ext cx="4434840" cy="266252"/>
+            <a:off x="1783080" y="3954780"/>
+            <a:ext cx="4434840" cy="251460"/>
           </a:xfrm>
           <a:prstGeom prst="rect">
             <a:avLst/>
@@ -24068,7 +24074,7 @@
         </p:nvSpPr>
         <p:spPr>
           <a:xfrm>
-            <a:off x="1435608" y="4414132"/>
+            <a:off x="1435608" y="4258818"/>
             <a:ext cx="146304" cy="146304"/>
           </a:xfrm>
           <a:prstGeom prst="ellipse">
@@ -24093,8 +24099,8 @@
         </p:nvSpPr>
         <p:spPr>
           <a:xfrm>
-            <a:off x="548640" y="4354158"/>
-            <a:ext cx="777240" cy="266252"/>
+            <a:off x="548640" y="4206240"/>
+            <a:ext cx="777240" cy="251460"/>
           </a:xfrm>
           <a:prstGeom prst="rect">
             <a:avLst/>
@@ -24129,8 +24135,8 @@
         </p:nvSpPr>
         <p:spPr>
           <a:xfrm>
-            <a:off x="1783080" y="4354158"/>
-            <a:ext cx="4434840" cy="266252"/>
+            <a:off x="1783080" y="4206240"/>
+            <a:ext cx="4434840" cy="251460"/>
           </a:xfrm>
           <a:prstGeom prst="rect">
             <a:avLst/>
@@ -24218,7 +24224,7 @@
         </p:nvSpPr>
         <p:spPr>
           <a:xfrm>
-            <a:off x="1435608" y="4680383"/>
+            <a:off x="1435608" y="4510278"/>
             <a:ext cx="146304" cy="146304"/>
           </a:xfrm>
           <a:prstGeom prst="ellipse">
@@ -24243,8 +24249,8 @@
         </p:nvSpPr>
         <p:spPr>
           <a:xfrm>
-            <a:off x="548640" y="4620409"/>
-            <a:ext cx="777240" cy="266252"/>
+            <a:off x="548640" y="4457700"/>
+            <a:ext cx="777240" cy="251460"/>
           </a:xfrm>
           <a:prstGeom prst="rect">
             <a:avLst/>
@@ -24279,8 +24285,8 @@
         </p:nvSpPr>
         <p:spPr>
           <a:xfrm>
-            <a:off x="1783080" y="4620409"/>
-            <a:ext cx="4434840" cy="266252"/>
+            <a:off x="1783080" y="4457700"/>
+            <a:ext cx="4434840" cy="251460"/>
           </a:xfrm>
           <a:prstGeom prst="rect">
             <a:avLst/>
@@ -24315,7 +24321,7 @@
         </p:nvSpPr>
         <p:spPr>
           <a:xfrm>
-            <a:off x="1435608" y="4946635"/>
+            <a:off x="1435608" y="4761738"/>
             <a:ext cx="146304" cy="146304"/>
           </a:xfrm>
           <a:prstGeom prst="ellipse">
@@ -24340,8 +24346,8 @@
         </p:nvSpPr>
         <p:spPr>
           <a:xfrm>
-            <a:off x="548640" y="4886661"/>
-            <a:ext cx="777240" cy="266252"/>
+            <a:off x="548640" y="4709160"/>
+            <a:ext cx="777240" cy="251460"/>
           </a:xfrm>
           <a:prstGeom prst="rect">
             <a:avLst/>
@@ -24376,8 +24382,8 @@
         </p:nvSpPr>
         <p:spPr>
           <a:xfrm>
-            <a:off x="1783080" y="4886661"/>
-            <a:ext cx="4434840" cy="266252"/>
+            <a:off x="1783080" y="4709160"/>
+            <a:ext cx="4434840" cy="251460"/>
           </a:xfrm>
           <a:prstGeom prst="rect">
             <a:avLst/>
@@ -24412,7 +24418,7 @@
         </p:nvSpPr>
         <p:spPr>
           <a:xfrm>
-            <a:off x="1435608" y="5212887"/>
+            <a:off x="1435608" y="5013198"/>
             <a:ext cx="146304" cy="146304"/>
           </a:xfrm>
           <a:prstGeom prst="ellipse">
@@ -24437,8 +24443,8 @@
         </p:nvSpPr>
         <p:spPr>
           <a:xfrm>
-            <a:off x="548640" y="5152913"/>
-            <a:ext cx="777240" cy="266252"/>
+            <a:off x="548640" y="4960620"/>
+            <a:ext cx="777240" cy="251460"/>
           </a:xfrm>
           <a:prstGeom prst="rect">
             <a:avLst/>
@@ -24473,8 +24479,8 @@
         </p:nvSpPr>
         <p:spPr>
           <a:xfrm>
-            <a:off x="1783080" y="5152913"/>
-            <a:ext cx="4434840" cy="266252"/>
+            <a:off x="1783080" y="4960620"/>
+            <a:ext cx="4434840" cy="251460"/>
           </a:xfrm>
           <a:prstGeom prst="rect">
             <a:avLst/>
@@ -24495,7 +24501,7 @@
                   <a:schemeClr val="tx1"/>
                 </a:solidFill>
               </a:rPr>
-              <a:t>Injective patterns · </a:t>
+              <a:t>Injective patterns · forests · </a:t>
             </a:r>
             <a:pPr indent="0" marL="0">
               <a:buNone/>
@@ -24509,7 +24515,7 @@
                 <a:ea typeface="Courier New" pitchFamily="34" charset="-122"/>
                 <a:cs typeface="Courier New" pitchFamily="34" charset="-120"/>
               </a:rPr>
-              <a:t>spanning_forest</a:t>
+              <a:t>cycle_basis</a:t>
             </a:r>
             <a:endParaRPr lang="en-US" sz="1400" dirty="0"/>
           </a:p>
@@ -24517,13 +24523,13 @@
       </p:sp>
       <p:sp>
         <p:nvSpPr>
-          <p:cNvPr id="43" name="milestone 23:11"/>
-          <p:cNvSpPr/>
-          <p:nvPr/>
-        </p:nvSpPr>
-        <p:spPr>
-          <a:xfrm>
-            <a:off x="1435608" y="5479139"/>
+          <p:cNvPr id="43" name="milestone 23:25"/>
+          <p:cNvSpPr/>
+          <p:nvPr/>
+        </p:nvSpPr>
+        <p:spPr>
+          <a:xfrm>
+            <a:off x="1435608" y="5264658"/>
             <a:ext cx="146304" cy="146304"/>
           </a:xfrm>
           <a:prstGeom prst="ellipse">
@@ -24548,8 +24554,8 @@
         </p:nvSpPr>
         <p:spPr>
           <a:xfrm>
-            <a:off x="548640" y="5419165"/>
-            <a:ext cx="777240" cy="266252"/>
+            <a:off x="548640" y="5212080"/>
+            <a:ext cx="777240" cy="251460"/>
           </a:xfrm>
           <a:prstGeom prst="rect">
             <a:avLst/>
@@ -24570,7 +24576,7 @@
                   <a:schemeClr val="accent6"/>
                 </a:solidFill>
               </a:rPr>
-              <a:t>23:11</a:t>
+              <a:t>23:25</a:t>
             </a:r>
             <a:endParaRPr lang="en-US" sz="1300" dirty="0"/>
           </a:p>
@@ -24584,8 +24590,8 @@
         </p:nvSpPr>
         <p:spPr>
           <a:xfrm>
-            <a:off x="1783080" y="5419165"/>
-            <a:ext cx="4434840" cy="266252"/>
+            <a:off x="1783080" y="5212080"/>
+            <a:ext cx="4434840" cy="251460"/>
           </a:xfrm>
           <a:prstGeom prst="rect">
             <a:avLst/>
@@ -24597,6 +24603,17 @@
           <a:bodyPr wrap="square" lIns="0" tIns="0" rIns="0" bIns="0" rtlCol="0" anchor="ctr"/>
           <a:lstStyle/>
           <a:p>
+            <a:pPr indent="0" marL="0">
+              <a:buNone/>
+            </a:pPr>
+            <a:r>
+              <a:rPr lang="en-US" sz="1400" dirty="0">
+                <a:solidFill>
+                  <a:schemeClr val="tx1"/>
+                </a:solidFill>
+              </a:rPr>
+              <a:t>Weighted matching · </a:t>
+            </a:r>
             <a:pPr indent="0" marL="0">
               <a:buNone/>
             </a:pPr>
@@ -24609,32 +24626,21 @@
                 <a:ea typeface="Courier New" pitchFamily="34" charset="-122"/>
                 <a:cs typeface="Courier New" pitchFamily="34" charset="-120"/>
               </a:rPr>
-              <a:t>cycle_basis</a:t>
-            </a:r>
-            <a:pPr indent="0" marL="0">
-              <a:buNone/>
-            </a:pPr>
-            <a:r>
-              <a:rPr lang="en-US" sz="1400" dirty="0">
-                <a:solidFill>
-                  <a:schemeClr val="tx1"/>
-                </a:solidFill>
-              </a:rPr>
-              <a:t> (ring perception) · weighted matching</a:t>
-            </a:r>
-            <a:endParaRPr lang="en-US" sz="1300" dirty="0"/>
-          </a:p>
-        </p:txBody>
-      </p:sp>
-      <p:sp>
-        <p:nvSpPr>
-          <p:cNvPr id="46" name="milestone 23:40"/>
-          <p:cNvSpPr/>
-          <p:nvPr/>
-        </p:nvSpPr>
-        <p:spPr>
-          <a:xfrm>
-            <a:off x="1435608" y="5745390"/>
+              <a:t>k_shortest_paths</a:t>
+            </a:r>
+            <a:endParaRPr lang="en-US" sz="1400" dirty="0"/>
+          </a:p>
+        </p:txBody>
+      </p:sp>
+      <p:sp>
+        <p:nvSpPr>
+          <p:cNvPr id="46" name="milestone 23:59"/>
+          <p:cNvSpPr/>
+          <p:nvPr/>
+        </p:nvSpPr>
+        <p:spPr>
+          <a:xfrm>
+            <a:off x="1435608" y="5516118"/>
             <a:ext cx="146304" cy="146304"/>
           </a:xfrm>
           <a:prstGeom prst="ellipse">
@@ -24659,8 +24665,8 @@
         </p:nvSpPr>
         <p:spPr>
           <a:xfrm>
-            <a:off x="548640" y="5685416"/>
-            <a:ext cx="777240" cy="266252"/>
+            <a:off x="548640" y="5463540"/>
+            <a:ext cx="777240" cy="251460"/>
           </a:xfrm>
           <a:prstGeom prst="rect">
             <a:avLst/>
@@ -24681,7 +24687,7 @@
                   <a:schemeClr val="accent6"/>
                 </a:solidFill>
               </a:rPr>
-              <a:t>23:40</a:t>
+              <a:t>23:59</a:t>
             </a:r>
             <a:endParaRPr lang="en-US" sz="1300" dirty="0"/>
           </a:p>
@@ -24695,8 +24701,8 @@
         </p:nvSpPr>
         <p:spPr>
           <a:xfrm>
-            <a:off x="1783080" y="5685416"/>
-            <a:ext cx="4434840" cy="266252"/>
+            <a:off x="1783080" y="5463540"/>
+            <a:ext cx="4434840" cy="251460"/>
           </a:xfrm>
           <a:prstGeom prst="rect">
             <a:avLst/>
@@ -24720,7 +24726,7 @@
                 <a:ea typeface="Courier New" pitchFamily="34" charset="-122"/>
                 <a:cs typeface="Courier New" pitchFamily="34" charset="-120"/>
               </a:rPr>
-              <a:t>k_shortest_paths</a:t>
+              <a:t>min_cost_flow</a:t>
             </a:r>
             <a:pPr indent="0" marL="0">
               <a:buNone/>
@@ -24731,7 +24737,7 @@
                   <a:schemeClr val="tx1"/>
                 </a:solidFill>
               </a:rPr>
-              <a:t> (Yen with Lawler's rule)</a:t>
+              <a:t>, proven by potentials and a cut</a:t>
             </a:r>
             <a:endParaRPr lang="en-US" sz="1300" dirty="0"/>
           </a:p>
@@ -24739,13 +24745,49 @@
       </p:sp>
       <p:sp>
         <p:nvSpPr>
-          <p:cNvPr id="49" name="milestone 23:59"/>
-          <p:cNvSpPr/>
-          <p:nvPr/>
-        </p:nvSpPr>
-        <p:spPr>
-          <a:xfrm>
-            <a:off x="1417320" y="5993354"/>
+          <p:cNvPr id="49" name="Text 47"/>
+          <p:cNvSpPr txBox="1"/>
+          <p:nvPr/>
+        </p:nvSpPr>
+        <p:spPr>
+          <a:xfrm>
+            <a:off x="1783080" y="5715000"/>
+            <a:ext cx="4389120" cy="251460"/>
+          </a:xfrm>
+          <a:prstGeom prst="rect">
+            <a:avLst/>
+          </a:prstGeom>
+          <a:noFill/>
+          <a:ln/>
+        </p:spPr>
+        <p:txBody>
+          <a:bodyPr wrap="square" lIns="0" tIns="0" rIns="0" bIns="0" rtlCol="0" anchor="ctr"/>
+          <a:lstStyle/>
+          <a:p>
+            <a:pPr indent="0" marL="0">
+              <a:buNone/>
+            </a:pPr>
+            <a:r>
+              <a:rPr lang="en-US" sz="1200" b="1" spc="100" kern="0" dirty="0">
+                <a:solidFill>
+                  <a:schemeClr val="accent1"/>
+                </a:solidFill>
+              </a:rPr>
+              <a:t>27 OCT 2026</a:t>
+            </a:r>
+            <a:endParaRPr lang="en-US" sz="1200" dirty="0"/>
+          </a:p>
+        </p:txBody>
+      </p:sp>
+      <p:sp>
+        <p:nvSpPr>
+          <p:cNvPr id="50" name="milestone 10:28"/>
+          <p:cNvSpPr/>
+          <p:nvPr/>
+        </p:nvSpPr>
+        <p:spPr>
+          <a:xfrm>
+            <a:off x="1417320" y="6000750"/>
             <a:ext cx="182880" cy="182880"/>
           </a:xfrm>
           <a:prstGeom prst="ellipse">
@@ -24764,50 +24806,14 @@
       </p:sp>
       <p:sp>
         <p:nvSpPr>
-          <p:cNvPr id="50" name="Text 48"/>
-          <p:cNvSpPr txBox="1"/>
-          <p:nvPr/>
-        </p:nvSpPr>
-        <p:spPr>
-          <a:xfrm>
-            <a:off x="548640" y="5951668"/>
-            <a:ext cx="777240" cy="266252"/>
-          </a:xfrm>
-          <a:prstGeom prst="rect">
-            <a:avLst/>
-          </a:prstGeom>
-          <a:noFill/>
-          <a:ln/>
-        </p:spPr>
-        <p:txBody>
-          <a:bodyPr wrap="square" lIns="0" tIns="0" rIns="0" bIns="0" rtlCol="0" anchor="ctr"/>
-          <a:lstStyle/>
-          <a:p>
-            <a:pPr algn="r" indent="0" marL="0">
-              <a:buNone/>
-            </a:pPr>
-            <a:r>
-              <a:rPr lang="en-US" sz="1300" dirty="0">
-                <a:solidFill>
-                  <a:schemeClr val="accent6"/>
-                </a:solidFill>
-              </a:rPr>
-              <a:t>23:59</a:t>
-            </a:r>
-            <a:endParaRPr lang="en-US" sz="1300" dirty="0"/>
-          </a:p>
-        </p:txBody>
-      </p:sp>
-      <p:sp>
-        <p:nvSpPr>
           <p:cNvPr id="51" name="Text 49"/>
           <p:cNvSpPr txBox="1"/>
           <p:nvPr/>
         </p:nvSpPr>
         <p:spPr>
           <a:xfrm>
-            <a:off x="1783080" y="5951668"/>
-            <a:ext cx="4434840" cy="266252"/>
+            <a:off x="548640" y="5966460"/>
+            <a:ext cx="777240" cy="251460"/>
           </a:xfrm>
           <a:prstGeom prst="rect">
             <a:avLst/>
@@ -24819,38 +24825,60 @@
           <a:bodyPr wrap="square" lIns="0" tIns="0" rIns="0" bIns="0" rtlCol="0" anchor="ctr"/>
           <a:lstStyle/>
           <a:p>
-            <a:pPr indent="0" marL="0">
+            <a:pPr algn="r" indent="0" marL="0">
               <a:buNone/>
             </a:pPr>
             <a:r>
               <a:rPr lang="en-US" sz="1300" dirty="0">
                 <a:solidFill>
+                  <a:schemeClr val="accent6"/>
+                </a:solidFill>
+              </a:rPr>
+              <a:t>10:28</a:t>
+            </a:r>
+            <a:endParaRPr lang="en-US" sz="1300" dirty="0"/>
+          </a:p>
+        </p:txBody>
+      </p:sp>
+      <p:sp>
+        <p:nvSpPr>
+          <p:cNvPr id="52" name="Text 50"/>
+          <p:cNvSpPr txBox="1"/>
+          <p:nvPr/>
+        </p:nvSpPr>
+        <p:spPr>
+          <a:xfrm>
+            <a:off x="1783080" y="5966460"/>
+            <a:ext cx="4434840" cy="251460"/>
+          </a:xfrm>
+          <a:prstGeom prst="rect">
+            <a:avLst/>
+          </a:prstGeom>
+          <a:noFill/>
+          <a:ln/>
+        </p:spPr>
+        <p:txBody>
+          <a:bodyPr wrap="square" lIns="0" tIns="0" rIns="0" bIns="0" rtlCol="0" anchor="ctr"/>
+          <a:lstStyle/>
+          <a:p>
+            <a:pPr indent="0" marL="0">
+              <a:buNone/>
+            </a:pPr>
+            <a:r>
+              <a:rPr lang="en-US" sz="1400" dirty="0">
+                <a:solidFill>
                   <a:schemeClr val="tx1"/>
                 </a:solidFill>
-                <a:latin typeface="Courier New" pitchFamily="34" charset="0"/>
-                <a:ea typeface="Courier New" pitchFamily="34" charset="-122"/>
-                <a:cs typeface="Courier New" pitchFamily="34" charset="-120"/>
-              </a:rPr>
-              <a:t>min_cost_flow</a:t>
-            </a:r>
-            <a:pPr indent="0" marL="0">
-              <a:buNone/>
-            </a:pPr>
-            <a:r>
-              <a:rPr lang="en-US" sz="1400" dirty="0">
-                <a:solidFill>
-                  <a:schemeClr val="tx1"/>
-                </a:solidFill>
-              </a:rPr>
-              <a:t>, proven by potentials and a cut</a:t>
-            </a:r>
-            <a:endParaRPr lang="en-US" sz="1300" dirty="0"/>
-          </a:p>
-        </p:txBody>
-      </p:sp>
-      <p:sp>
-        <p:nvSpPr>
-          <p:cNvPr id="52" name="growth operations"/>
+              </a:rPr>
+              <a:t>Cyclic patterns counted by variable elimination</a:t>
+            </a:r>
+            <a:endParaRPr lang="en-US" sz="1400" dirty="0"/>
+          </a:p>
+        </p:txBody>
+      </p:sp>
+      <p:sp>
+        <p:nvSpPr>
+          <p:cNvPr id="53" name="growth operations"/>
           <p:cNvSpPr/>
           <p:nvPr/>
         </p:nvSpPr>
@@ -24872,7 +24900,7 @@
       </p:sp>
       <p:sp>
         <p:nvSpPr>
-          <p:cNvPr id="53" name="Text 51"/>
+          <p:cNvPr id="54" name="Text 52"/>
           <p:cNvSpPr txBox="1"/>
           <p:nvPr/>
         </p:nvSpPr>
@@ -24925,7 +24953,7 @@
       </p:sp>
       <p:sp>
         <p:nvSpPr>
-          <p:cNvPr id="54" name="growth runtime tests"/>
+          <p:cNvPr id="55" name="growth runtime tests"/>
           <p:cNvSpPr/>
           <p:nvPr/>
         </p:nvSpPr>
@@ -24947,7 +24975,7 @@
       </p:sp>
       <p:sp>
         <p:nvSpPr>
-          <p:cNvPr id="55" name="Text 53"/>
+          <p:cNvPr id="56" name="Text 54"/>
           <p:cNvSpPr txBox="1"/>
           <p:nvPr/>
         </p:nvSpPr>
@@ -24978,7 +25006,7 @@
                 <a:ea typeface="Cambria" pitchFamily="34" charset="-122"/>
                 <a:cs typeface="Cambria" pitchFamily="34" charset="-120"/>
               </a:rPr>
-              <a:t>178 → 613</a:t>
+              <a:t>178 → 631</a:t>
             </a:r>
             <a:endParaRPr lang="en-US" sz="2800" dirty="0"/>
           </a:p>
@@ -25000,7 +25028,7 @@
       </p:sp>
       <p:graphicFrame>
         <p:nvGraphicFramePr>
-          <p:cNvPr id="56" name="conformance growth chart" descr=""/>
+          <p:cNvPr id="57" name="conformance growth chart" descr=""/>
           <p:cNvGraphicFramePr/>
           <p:nvPr/>
         </p:nvGraphicFramePr>
@@ -25154,7 +25182,7 @@
                   <a:schemeClr val="accent6"/>
                 </a:solidFill>
               </a:rPr>
-              <a:t>Ranked by value against effort in a Codex literature survey: seven done, these five to go, in this order.</a:t>
+              <a:t>Ranked by value against effort in a Codex literature survey: eight done, these four to go, in this order.</a:t>
             </a:r>
             <a:endParaRPr lang="en-US" sz="1600" dirty="0"/>
           </a:p>
@@ -25306,18 +25334,18 @@
       </p:sp>
       <p:sp>
         <p:nvSpPr>
-          <p:cNvPr id="8" name="roadmap Counting cyclic patterns"/>
+          <p:cNvPr id="8" name="roadmap Reachability index"/>
           <p:cNvSpPr/>
           <p:nvPr/>
         </p:nvSpPr>
         <p:spPr>
           <a:xfrm>
             <a:off x="548640" y="1911096"/>
-            <a:ext cx="11094415" cy="722884"/>
+            <a:ext cx="11094415" cy="872236"/>
           </a:xfrm>
           <a:prstGeom prst="roundRect">
             <a:avLst>
-              <a:gd name="adj" fmla="val 12649"/>
+              <a:gd name="adj" fmla="val 10483"/>
             </a:avLst>
           </a:prstGeom>
           <a:solidFill>
@@ -25328,13 +25356,13 @@
       </p:sp>
       <p:sp>
         <p:nvSpPr>
-          <p:cNvPr id="9" name="icon Counting cyclic patterns"/>
-          <p:cNvSpPr/>
-          <p:nvPr/>
-        </p:nvSpPr>
-        <p:spPr>
-          <a:xfrm>
-            <a:off x="713232" y="2053082"/>
+          <p:cNvPr id="9" name="icon Reachability index"/>
+          <p:cNvSpPr/>
+          <p:nvPr/>
+        </p:nvSpPr>
+        <p:spPr>
+          <a:xfrm>
+            <a:off x="713232" y="2127758"/>
             <a:ext cx="438912" cy="438912"/>
           </a:xfrm>
           <a:prstGeom prst="ellipse">
@@ -25348,7 +25376,7 @@
       </p:sp>
       <p:pic>
         <p:nvPicPr>
-          <p:cNvPr id="10" name="Image 0" descr="Counting cyclic patterns">    </p:cNvPr>
+          <p:cNvPr id="10" name="Image 0" descr="Reachability index">    </p:cNvPr>
           <p:cNvPicPr>
             <a:picLocks noChangeAspect="1"/>
           </p:cNvPicPr>
@@ -25362,7 +25390,7 @@
         </p:blipFill>
         <p:spPr>
           <a:xfrm>
-            <a:off x="809793" y="2149643"/>
+            <a:off x="809793" y="2224319"/>
             <a:ext cx="245791" cy="245791"/>
           </a:xfrm>
           <a:prstGeom prst="rect">
@@ -25379,7 +25407,7 @@
         <p:spPr>
           <a:xfrm>
             <a:off x="1325880" y="1911096"/>
-            <a:ext cx="1828800" cy="722884"/>
+            <a:ext cx="1828800" cy="872236"/>
           </a:xfrm>
           <a:prstGeom prst="rect">
             <a:avLst/>
@@ -25400,7 +25428,7 @@
                   <a:schemeClr val="tx1"/>
                 </a:solidFill>
               </a:rPr>
-              <a:t>Counting cyclic patterns</a:t>
+              <a:t>Reachability index</a:t>
             </a:r>
             <a:endParaRPr lang="en-US" sz="1500" dirty="0"/>
           </a:p>
@@ -25415,7 +25443,7 @@
         <p:spPr>
           <a:xfrm>
             <a:off x="3383280" y="1911096"/>
-            <a:ext cx="3017520" cy="722884"/>
+            <a:ext cx="3017520" cy="872236"/>
           </a:xfrm>
           <a:prstGeom prst="rect">
             <a:avLst/>
@@ -25436,7 +25464,7 @@
                   <a:schemeClr val="tx1"/>
                 </a:solidFill>
               </a:rPr>
-              <a:t>Exact motif counts without listing rows, over a tree decomposition.</a:t>
+              <a:t>Many reachability queries on one large, fixed projection: 2-hop labels.</a:t>
             </a:r>
             <a:endParaRPr lang="en-US" sz="1400" dirty="0"/>
           </a:p>
@@ -25451,7 +25479,7 @@
         <p:spPr>
           <a:xfrm>
             <a:off x="6629400" y="1911096"/>
-            <a:ext cx="3017520" cy="722884"/>
+            <a:ext cx="3017520" cy="872236"/>
           </a:xfrm>
           <a:prstGeom prst="rect">
             <a:avLst/>
@@ -25472,7 +25500,7 @@
                   <a:schemeClr val="tx1"/>
                 </a:solidFill>
               </a:rPr>
-              <a:t>The decomposition's messages, each recomputed by a checker.</a:t>
+              <a:t>A positive expands hub pointers into hops; a negative needs a closure.</a:t>
             </a:r>
             <a:endParaRPr lang="en-US" sz="1400" dirty="0"/>
           </a:p>
@@ -25487,7 +25515,7 @@
         <p:spPr>
           <a:xfrm>
             <a:off x="9875520" y="1911096"/>
-            <a:ext cx="1676095" cy="722884"/>
+            <a:ext cx="1676095" cy="872236"/>
           </a:xfrm>
           <a:prstGeom prst="rect">
             <a:avLst/>
@@ -25508,7 +25536,7 @@
                   <a:schemeClr val="accent6"/>
                 </a:solidFill>
               </a:rPr>
-              <a:t>Abo Khamis, Ngo and Rudra 2016 (FAQ)</a:t>
+              <a:t>Cohen, Halperin, Kaplan and Zwick 2003</a:t>
             </a:r>
             <a:endParaRPr lang="en-US" sz="1200" dirty="0"/>
           </a:p>
@@ -25516,18 +25544,18 @@
       </p:sp>
       <p:sp>
         <p:nvSpPr>
-          <p:cNvPr id="15" name="roadmap Reachability index"/>
-          <p:cNvSpPr/>
-          <p:nvPr/>
-        </p:nvSpPr>
-        <p:spPr>
-          <a:xfrm>
-            <a:off x="548640" y="2725420"/>
-            <a:ext cx="11094415" cy="722884"/>
+          <p:cNvPr id="15" name="roadmap Positive Datalog"/>
+          <p:cNvSpPr/>
+          <p:nvPr/>
+        </p:nvSpPr>
+        <p:spPr>
+          <a:xfrm>
+            <a:off x="548640" y="2874772"/>
+            <a:ext cx="11094415" cy="872236"/>
           </a:xfrm>
           <a:prstGeom prst="roundRect">
             <a:avLst>
-              <a:gd name="adj" fmla="val 12649"/>
+              <a:gd name="adj" fmla="val 10483"/>
             </a:avLst>
           </a:prstGeom>
           <a:solidFill>
@@ -25538,13 +25566,13 @@
       </p:sp>
       <p:sp>
         <p:nvSpPr>
-          <p:cNvPr id="16" name="icon Reachability index"/>
-          <p:cNvSpPr/>
-          <p:nvPr/>
-        </p:nvSpPr>
-        <p:spPr>
-          <a:xfrm>
-            <a:off x="713232" y="2867406"/>
+          <p:cNvPr id="16" name="icon Positive Datalog"/>
+          <p:cNvSpPr/>
+          <p:nvPr/>
+        </p:nvSpPr>
+        <p:spPr>
+          <a:xfrm>
+            <a:off x="713232" y="3091434"/>
             <a:ext cx="438912" cy="438912"/>
           </a:xfrm>
           <a:prstGeom prst="ellipse">
@@ -25558,7 +25586,7 @@
       </p:sp>
       <p:pic>
         <p:nvPicPr>
-          <p:cNvPr id="17" name="Image 1" descr="Reachability index">    </p:cNvPr>
+          <p:cNvPr id="17" name="Image 1" descr="Positive Datalog">    </p:cNvPr>
           <p:cNvPicPr>
             <a:picLocks noChangeAspect="1"/>
           </p:cNvPicPr>
@@ -25572,7 +25600,7 @@
         </p:blipFill>
         <p:spPr>
           <a:xfrm>
-            <a:off x="809793" y="2963967"/>
+            <a:off x="809793" y="3187995"/>
             <a:ext cx="245791" cy="245791"/>
           </a:xfrm>
           <a:prstGeom prst="rect">
@@ -25588,8 +25616,8 @@
         </p:nvSpPr>
         <p:spPr>
           <a:xfrm>
-            <a:off x="1325880" y="2725420"/>
-            <a:ext cx="1828800" cy="722884"/>
+            <a:off x="1325880" y="2874772"/>
+            <a:ext cx="1828800" cy="872236"/>
           </a:xfrm>
           <a:prstGeom prst="rect">
             <a:avLst/>
@@ -25610,7 +25638,7 @@
                   <a:schemeClr val="tx1"/>
                 </a:solidFill>
               </a:rPr>
-              <a:t>Reachability index</a:t>
+              <a:t>Positive Datalog</a:t>
             </a:r>
             <a:endParaRPr lang="en-US" sz="1500" dirty="0"/>
           </a:p>
@@ -25624,8 +25652,8 @@
         </p:nvSpPr>
         <p:spPr>
           <a:xfrm>
-            <a:off x="3383280" y="2725420"/>
-            <a:ext cx="3017520" cy="722884"/>
+            <a:off x="3383280" y="2874772"/>
+            <a:ext cx="3017520" cy="872236"/>
           </a:xfrm>
           <a:prstGeom prst="rect">
             <a:avLst/>
@@ -25646,7 +25674,7 @@
                   <a:schemeClr val="tx1"/>
                 </a:solidFill>
               </a:rPr>
-              <a:t>Many reachability queries on one large, fixed projection: 2-hop labels.</a:t>
+              <a:t>Rules over the records: provenance questions in a small language.</a:t>
             </a:r>
             <a:endParaRPr lang="en-US" sz="1400" dirty="0"/>
           </a:p>
@@ -25660,8 +25688,8 @@
         </p:nvSpPr>
         <p:spPr>
           <a:xfrm>
-            <a:off x="6629400" y="2725420"/>
-            <a:ext cx="3017520" cy="722884"/>
+            <a:off x="6629400" y="2874772"/>
+            <a:ext cx="3017520" cy="872236"/>
           </a:xfrm>
           <a:prstGeom prst="rect">
             <a:avLst/>
@@ -25682,7 +25710,7 @@
                   <a:schemeClr val="tx1"/>
                 </a:solidFill>
               </a:rPr>
-              <a:t>A positive expands hub pointers into hops; a negative needs a closure.</a:t>
+              <a:t>Derivation trees, ranks strictly increasing, checked in their size.</a:t>
             </a:r>
             <a:endParaRPr lang="en-US" sz="1400" dirty="0"/>
           </a:p>
@@ -25696,8 +25724,8 @@
         </p:nvSpPr>
         <p:spPr>
           <a:xfrm>
-            <a:off x="9875520" y="2725420"/>
-            <a:ext cx="1676095" cy="722884"/>
+            <a:off x="9875520" y="2874772"/>
+            <a:ext cx="1676095" cy="872236"/>
           </a:xfrm>
           <a:prstGeom prst="rect">
             <a:avLst/>
@@ -25718,7 +25746,7 @@
                   <a:schemeClr val="accent6"/>
                 </a:solidFill>
               </a:rPr>
-              <a:t>Cohen, Halperin, Kaplan and Zwick 2003</a:t>
+              <a:t>Abiteboul, Hull and Vianu 1995; Green et al. 2007</a:t>
             </a:r>
             <a:endParaRPr lang="en-US" sz="1200" dirty="0"/>
           </a:p>
@@ -25726,18 +25754,18 @@
       </p:sp>
       <p:sp>
         <p:nvSpPr>
-          <p:cNvPr id="22" name="roadmap Positive Datalog"/>
-          <p:cNvSpPr/>
-          <p:nvPr/>
-        </p:nvSpPr>
-        <p:spPr>
-          <a:xfrm>
-            <a:off x="548640" y="3539744"/>
-            <a:ext cx="11094415" cy="722884"/>
+          <p:cNvPr id="22" name="roadmap Isomorphism, canonical labeling"/>
+          <p:cNvSpPr/>
+          <p:nvPr/>
+        </p:nvSpPr>
+        <p:spPr>
+          <a:xfrm>
+            <a:off x="548640" y="3838448"/>
+            <a:ext cx="11094415" cy="872236"/>
           </a:xfrm>
           <a:prstGeom prst="roundRect">
             <a:avLst>
-              <a:gd name="adj" fmla="val 12649"/>
+              <a:gd name="adj" fmla="val 10483"/>
             </a:avLst>
           </a:prstGeom>
           <a:solidFill>
@@ -25748,13 +25776,13 @@
       </p:sp>
       <p:sp>
         <p:nvSpPr>
-          <p:cNvPr id="23" name="icon Positive Datalog"/>
-          <p:cNvSpPr/>
-          <p:nvPr/>
-        </p:nvSpPr>
-        <p:spPr>
-          <a:xfrm>
-            <a:off x="713232" y="3681730"/>
+          <p:cNvPr id="23" name="icon Isomorphism, canonical labeling"/>
+          <p:cNvSpPr/>
+          <p:nvPr/>
+        </p:nvSpPr>
+        <p:spPr>
+          <a:xfrm>
+            <a:off x="713232" y="4055110"/>
             <a:ext cx="438912" cy="438912"/>
           </a:xfrm>
           <a:prstGeom prst="ellipse">
@@ -25768,7 +25796,7 @@
       </p:sp>
       <p:pic>
         <p:nvPicPr>
-          <p:cNvPr id="24" name="Image 2" descr="Positive Datalog">    </p:cNvPr>
+          <p:cNvPr id="24" name="Image 2" descr="Isomorphism, canonical labeling">    </p:cNvPr>
           <p:cNvPicPr>
             <a:picLocks noChangeAspect="1"/>
           </p:cNvPicPr>
@@ -25782,7 +25810,7 @@
         </p:blipFill>
         <p:spPr>
           <a:xfrm>
-            <a:off x="809793" y="3778291"/>
+            <a:off x="809793" y="4151671"/>
             <a:ext cx="245791" cy="245791"/>
           </a:xfrm>
           <a:prstGeom prst="rect">
@@ -25798,8 +25826,8 @@
         </p:nvSpPr>
         <p:spPr>
           <a:xfrm>
-            <a:off x="1325880" y="3539744"/>
-            <a:ext cx="1828800" cy="722884"/>
+            <a:off x="1325880" y="3838448"/>
+            <a:ext cx="1828800" cy="872236"/>
           </a:xfrm>
           <a:prstGeom prst="rect">
             <a:avLst/>
@@ -25820,7 +25848,7 @@
                   <a:schemeClr val="tx1"/>
                 </a:solidFill>
               </a:rPr>
-              <a:t>Positive Datalog</a:t>
+              <a:t>Isomorphism, canonical labeling</a:t>
             </a:r>
             <a:endParaRPr lang="en-US" sz="1500" dirty="0"/>
           </a:p>
@@ -25834,8 +25862,8 @@
         </p:nvSpPr>
         <p:spPr>
           <a:xfrm>
-            <a:off x="3383280" y="3539744"/>
-            <a:ext cx="3017520" cy="722884"/>
+            <a:off x="3383280" y="3838448"/>
+            <a:ext cx="3017520" cy="872236"/>
           </a:xfrm>
           <a:prstGeom prst="rect">
             <a:avLst/>
@@ -25856,7 +25884,7 @@
                   <a:schemeClr val="tx1"/>
                 </a:solidFill>
               </a:rPr>
-              <a:t>Rules over the records: provenance questions in a small language.</a:t>
+              <a:t>Whether two structures are the same; canonical forms for deduplication.</a:t>
             </a:r>
             <a:endParaRPr lang="en-US" sz="1400" dirty="0"/>
           </a:p>
@@ -25870,8 +25898,8 @@
         </p:nvSpPr>
         <p:spPr>
           <a:xfrm>
-            <a:off x="6629400" y="3539744"/>
-            <a:ext cx="3017520" cy="722884"/>
+            <a:off x="6629400" y="3838448"/>
+            <a:ext cx="3017520" cy="872236"/>
           </a:xfrm>
           <a:prstGeom prst="rect">
             <a:avLst/>
@@ -25892,7 +25920,7 @@
                   <a:schemeClr val="tx1"/>
                 </a:solidFill>
               </a:rPr>
-              <a:t>Derivation trees, ranks strictly increasing, checked in their size.</a:t>
+              <a:t>A node and edge bijection proves a match; a refinement trace, a mismatch.</a:t>
             </a:r>
             <a:endParaRPr lang="en-US" sz="1400" dirty="0"/>
           </a:p>
@@ -25906,8 +25934,8 @@
         </p:nvSpPr>
         <p:spPr>
           <a:xfrm>
-            <a:off x="9875520" y="3539744"/>
-            <a:ext cx="1676095" cy="722884"/>
+            <a:off x="9875520" y="3838448"/>
+            <a:ext cx="1676095" cy="872236"/>
           </a:xfrm>
           <a:prstGeom prst="rect">
             <a:avLst/>
@@ -25928,7 +25956,7 @@
                   <a:schemeClr val="accent6"/>
                 </a:solidFill>
               </a:rPr>
-              <a:t>Abiteboul, Hull and Vianu 1995; Green et al. 2007</a:t>
+              <a:t>McKay and Piperno 2014</a:t>
             </a:r>
             <a:endParaRPr lang="en-US" sz="1200" dirty="0"/>
           </a:p>
@@ -25936,18 +25964,18 @@
       </p:sp>
       <p:sp>
         <p:nvSpPr>
-          <p:cNvPr id="29" name="roadmap Isomorphism, canonical labeling"/>
-          <p:cNvSpPr/>
-          <p:nvPr/>
-        </p:nvSpPr>
-        <p:spPr>
-          <a:xfrm>
-            <a:off x="548640" y="4354068"/>
-            <a:ext cx="11094415" cy="722884"/>
+          <p:cNvPr id="29" name="roadmap Elementary flux modes"/>
+          <p:cNvSpPr/>
+          <p:nvPr/>
+        </p:nvSpPr>
+        <p:spPr>
+          <a:xfrm>
+            <a:off x="548640" y="4802124"/>
+            <a:ext cx="11094415" cy="872236"/>
           </a:xfrm>
           <a:prstGeom prst="roundRect">
             <a:avLst>
-              <a:gd name="adj" fmla="val 12649"/>
+              <a:gd name="adj" fmla="val 10483"/>
             </a:avLst>
           </a:prstGeom>
           <a:solidFill>
@@ -25958,13 +25986,13 @@
       </p:sp>
       <p:sp>
         <p:nvSpPr>
-          <p:cNvPr id="30" name="icon Isomorphism, canonical labeling"/>
-          <p:cNvSpPr/>
-          <p:nvPr/>
-        </p:nvSpPr>
-        <p:spPr>
-          <a:xfrm>
-            <a:off x="713232" y="4496054"/>
+          <p:cNvPr id="30" name="icon Elementary flux modes"/>
+          <p:cNvSpPr/>
+          <p:nvPr/>
+        </p:nvSpPr>
+        <p:spPr>
+          <a:xfrm>
+            <a:off x="713232" y="5018786"/>
             <a:ext cx="438912" cy="438912"/>
           </a:xfrm>
           <a:prstGeom prst="ellipse">
@@ -25978,7 +26006,7 @@
       </p:sp>
       <p:pic>
         <p:nvPicPr>
-          <p:cNvPr id="31" name="Image 3" descr="Isomorphism, canonical labeling">    </p:cNvPr>
+          <p:cNvPr id="31" name="Image 3" descr="Elementary flux modes">    </p:cNvPr>
           <p:cNvPicPr>
             <a:picLocks noChangeAspect="1"/>
           </p:cNvPicPr>
@@ -25992,7 +26020,7 @@
         </p:blipFill>
         <p:spPr>
           <a:xfrm>
-            <a:off x="809793" y="4592615"/>
+            <a:off x="809793" y="5115347"/>
             <a:ext cx="245791" cy="245791"/>
           </a:xfrm>
           <a:prstGeom prst="rect">
@@ -26008,8 +26036,8 @@
         </p:nvSpPr>
         <p:spPr>
           <a:xfrm>
-            <a:off x="1325880" y="4354068"/>
-            <a:ext cx="1828800" cy="722884"/>
+            <a:off x="1325880" y="4802124"/>
+            <a:ext cx="1828800" cy="872236"/>
           </a:xfrm>
           <a:prstGeom prst="rect">
             <a:avLst/>
@@ -26030,7 +26058,7 @@
                   <a:schemeClr val="tx1"/>
                 </a:solidFill>
               </a:rPr>
-              <a:t>Isomorphism, canonical labeling</a:t>
+              <a:t>Elementary flux modes</a:t>
             </a:r>
             <a:endParaRPr lang="en-US" sz="1500" dirty="0"/>
           </a:p>
@@ -26044,8 +26072,8 @@
         </p:nvSpPr>
         <p:spPr>
           <a:xfrm>
-            <a:off x="3383280" y="4354068"/>
-            <a:ext cx="3017520" cy="722884"/>
+            <a:off x="3383280" y="4802124"/>
+            <a:ext cx="3017520" cy="872236"/>
           </a:xfrm>
           <a:prstGeom prst="rect">
             <a:avLst/>
@@ -26066,7 +26094,7 @@
                   <a:schemeClr val="tx1"/>
                 </a:solidFill>
               </a:rPr>
-              <a:t>Whether two structures are the same; canonical forms for deduplication.</a:t>
+              <a:t>A reaction network's minimal steady pathways, small networks first.</a:t>
             </a:r>
             <a:endParaRPr lang="en-US" sz="1400" dirty="0"/>
           </a:p>
@@ -26080,8 +26108,8 @@
         </p:nvSpPr>
         <p:spPr>
           <a:xfrm>
-            <a:off x="6629400" y="4354068"/>
-            <a:ext cx="3017520" cy="722884"/>
+            <a:off x="6629400" y="4802124"/>
+            <a:ext cx="3017520" cy="872236"/>
           </a:xfrm>
           <a:prstGeom prst="rect">
             <a:avLst/>
@@ -26102,7 +26130,7 @@
                   <a:schemeClr val="tx1"/>
                 </a:solidFill>
               </a:rPr>
-              <a:t>A node and edge bijection proves a match; a refinement trace, a mismatch.</a:t>
+              <a:t>A mode balances exactly; a nonsingular minor proves its support minimal.</a:t>
             </a:r>
             <a:endParaRPr lang="en-US" sz="1400" dirty="0"/>
           </a:p>
@@ -26116,8 +26144,8 @@
         </p:nvSpPr>
         <p:spPr>
           <a:xfrm>
-            <a:off x="9875520" y="4354068"/>
-            <a:ext cx="1676095" cy="722884"/>
+            <a:off x="9875520" y="4802124"/>
+            <a:ext cx="1676095" cy="872236"/>
           </a:xfrm>
           <a:prstGeom prst="rect">
             <a:avLst/>
@@ -26138,7 +26166,7 @@
                   <a:schemeClr val="accent6"/>
                 </a:solidFill>
               </a:rPr>
-              <a:t>McKay and Piperno 2014</a:t>
+              <a:t>Gagneur and Klamt 2004; Terzer and Stelling 2008</a:t>
             </a:r>
             <a:endParaRPr lang="en-US" sz="1200" dirty="0"/>
           </a:p>
@@ -26146,80 +26174,14 @@
       </p:sp>
       <p:sp>
         <p:nvSpPr>
-          <p:cNvPr id="36" name="roadmap Elementary flux modes"/>
-          <p:cNvSpPr/>
-          <p:nvPr/>
-        </p:nvSpPr>
-        <p:spPr>
-          <a:xfrm>
-            <a:off x="548640" y="5168392"/>
-            <a:ext cx="11094415" cy="722884"/>
-          </a:xfrm>
-          <a:prstGeom prst="roundRect">
-            <a:avLst>
-              <a:gd name="adj" fmla="val 12649"/>
-            </a:avLst>
-          </a:prstGeom>
-          <a:solidFill>
-            <a:schemeClr val="bg2"/>
-          </a:solidFill>
-          <a:ln/>
-        </p:spPr>
-      </p:sp>
-      <p:sp>
-        <p:nvSpPr>
-          <p:cNvPr id="37" name="icon Elementary flux modes"/>
-          <p:cNvSpPr/>
-          <p:nvPr/>
-        </p:nvSpPr>
-        <p:spPr>
-          <a:xfrm>
-            <a:off x="713232" y="5310378"/>
-            <a:ext cx="438912" cy="438912"/>
-          </a:xfrm>
-          <a:prstGeom prst="ellipse">
-            <a:avLst/>
-          </a:prstGeom>
-          <a:solidFill>
-            <a:schemeClr val="accent1"/>
-          </a:solidFill>
-          <a:ln/>
-        </p:spPr>
-      </p:sp>
-      <p:pic>
-        <p:nvPicPr>
-          <p:cNvPr id="38" name="Image 4" descr="Elementary flux modes">    </p:cNvPr>
-          <p:cNvPicPr>
-            <a:picLocks noChangeAspect="1"/>
-          </p:cNvPicPr>
-          <p:nvPr/>
-        </p:nvPicPr>
-        <p:blipFill>
-          <a:blip r:embed="rId5"/>
-          <a:stretch>
-            <a:fillRect/>
-          </a:stretch>
-        </p:blipFill>
-        <p:spPr>
-          <a:xfrm>
-            <a:off x="809793" y="5406939"/>
-            <a:ext cx="245791" cy="245791"/>
-          </a:xfrm>
-          <a:prstGeom prst="rect">
-            <a:avLst/>
-          </a:prstGeom>
-        </p:spPr>
-      </p:pic>
-      <p:sp>
-        <p:nvSpPr>
-          <p:cNvPr id="39" name="Text 32"/>
+          <p:cNvPr id="36" name="roadmap later"/>
           <p:cNvSpPr txBox="1"/>
           <p:nvPr/>
         </p:nvSpPr>
         <p:spPr>
           <a:xfrm>
-            <a:off x="1325880" y="5168392"/>
-            <a:ext cx="1828800" cy="722884"/>
+            <a:off x="685800" y="5784088"/>
+            <a:ext cx="10820095" cy="433832"/>
           </a:xfrm>
           <a:prstGeom prst="rect">
             <a:avLst/>
@@ -26235,38 +26197,13 @@
               <a:buNone/>
             </a:pPr>
             <a:r>
-              <a:rPr lang="en-US" sz="1500" b="1" dirty="0">
+              <a:rPr lang="en-US" sz="1400" b="1" dirty="0">
                 <a:solidFill>
                   <a:schemeClr val="tx1"/>
                 </a:solidFill>
               </a:rPr>
-              <a:t>Elementary flux modes</a:t>
-            </a:r>
-            <a:endParaRPr lang="en-US" sz="1500" dirty="0"/>
-          </a:p>
-        </p:txBody>
-      </p:sp>
-      <p:sp>
-        <p:nvSpPr>
-          <p:cNvPr id="40" name="Text 33"/>
-          <p:cNvSpPr txBox="1"/>
-          <p:nvPr/>
-        </p:nvSpPr>
-        <p:spPr>
-          <a:xfrm>
-            <a:off x="3383280" y="5168392"/>
-            <a:ext cx="3017520" cy="722884"/>
-          </a:xfrm>
-          <a:prstGeom prst="rect">
-            <a:avLst/>
-          </a:prstGeom>
-          <a:noFill/>
-          <a:ln/>
-        </p:spPr>
-        <p:txBody>
-          <a:bodyPr wrap="square" lIns="0" tIns="0" rIns="0" bIns="0" rtlCol="0" anchor="ctr"/>
-          <a:lstStyle/>
-          <a:p>
+              <a:t>Done from the survey:</a:t>
+            </a:r>
             <a:pPr indent="0" marL="0">
               <a:buNone/>
             </a:pPr>
@@ -26276,126 +26213,7 @@
                   <a:schemeClr val="tx1"/>
                 </a:solidFill>
               </a:rPr>
-              <a:t>A reaction network's minimal steady pathways, small networks first.</a:t>
-            </a:r>
-            <a:endParaRPr lang="en-US" sz="1400" dirty="0"/>
-          </a:p>
-        </p:txBody>
-      </p:sp>
-      <p:sp>
-        <p:nvSpPr>
-          <p:cNvPr id="41" name="Text 34"/>
-          <p:cNvSpPr txBox="1"/>
-          <p:nvPr/>
-        </p:nvSpPr>
-        <p:spPr>
-          <a:xfrm>
-            <a:off x="6629400" y="5168392"/>
-            <a:ext cx="3017520" cy="722884"/>
-          </a:xfrm>
-          <a:prstGeom prst="rect">
-            <a:avLst/>
-          </a:prstGeom>
-          <a:noFill/>
-          <a:ln/>
-        </p:spPr>
-        <p:txBody>
-          <a:bodyPr wrap="square" lIns="0" tIns="0" rIns="0" bIns="0" rtlCol="0" anchor="ctr"/>
-          <a:lstStyle/>
-          <a:p>
-            <a:pPr indent="0" marL="0">
-              <a:buNone/>
-            </a:pPr>
-            <a:r>
-              <a:rPr lang="en-US" sz="1400" dirty="0">
-                <a:solidFill>
-                  <a:schemeClr val="tx1"/>
-                </a:solidFill>
-              </a:rPr>
-              <a:t>A mode balances exactly; a nonsingular minor proves its support minimal.</a:t>
-            </a:r>
-            <a:endParaRPr lang="en-US" sz="1400" dirty="0"/>
-          </a:p>
-        </p:txBody>
-      </p:sp>
-      <p:sp>
-        <p:nvSpPr>
-          <p:cNvPr id="42" name="Text 35"/>
-          <p:cNvSpPr txBox="1"/>
-          <p:nvPr/>
-        </p:nvSpPr>
-        <p:spPr>
-          <a:xfrm>
-            <a:off x="9875520" y="5168392"/>
-            <a:ext cx="1676095" cy="722884"/>
-          </a:xfrm>
-          <a:prstGeom prst="rect">
-            <a:avLst/>
-          </a:prstGeom>
-          <a:noFill/>
-          <a:ln/>
-        </p:spPr>
-        <p:txBody>
-          <a:bodyPr wrap="square" lIns="0" tIns="0" rIns="0" bIns="0" rtlCol="0" anchor="ctr"/>
-          <a:lstStyle/>
-          <a:p>
-            <a:pPr indent="0" marL="0">
-              <a:buNone/>
-            </a:pPr>
-            <a:r>
-              <a:rPr lang="en-US" sz="1200" i="1" dirty="0">
-                <a:solidFill>
-                  <a:schemeClr val="accent6"/>
-                </a:solidFill>
-              </a:rPr>
-              <a:t>Gagneur and Klamt 2004; Terzer and Stelling 2008</a:t>
-            </a:r>
-            <a:endParaRPr lang="en-US" sz="1200" dirty="0"/>
-          </a:p>
-        </p:txBody>
-      </p:sp>
-      <p:sp>
-        <p:nvSpPr>
-          <p:cNvPr id="43" name="roadmap later"/>
-          <p:cNvSpPr txBox="1"/>
-          <p:nvPr/>
-        </p:nvSpPr>
-        <p:spPr>
-          <a:xfrm>
-            <a:off x="685800" y="6001004"/>
-            <a:ext cx="10820095" cy="216916"/>
-          </a:xfrm>
-          <a:prstGeom prst="rect">
-            <a:avLst/>
-          </a:prstGeom>
-          <a:noFill/>
-          <a:ln/>
-        </p:spPr>
-        <p:txBody>
-          <a:bodyPr wrap="square" lIns="0" tIns="0" rIns="0" bIns="0" rtlCol="0" anchor="ctr"/>
-          <a:lstStyle/>
-          <a:p>
-            <a:pPr indent="0" marL="0">
-              <a:buNone/>
-            </a:pPr>
-            <a:r>
-              <a:rPr lang="en-US" sz="1400" b="1" dirty="0">
-                <a:solidFill>
-                  <a:schemeClr val="tx1"/>
-                </a:solidFill>
-              </a:rPr>
-              <a:t>Done from the survey:</a:t>
-            </a:r>
-            <a:pPr indent="0" marL="0">
-              <a:buNone/>
-            </a:pPr>
-            <a:r>
-              <a:rPr lang="en-US" sz="1400" dirty="0">
-                <a:solidFill>
-                  <a:schemeClr val="tx1"/>
-                </a:solidFill>
-              </a:rPr>
-              <a:t> negative costs · injective patterns · spanning forests · cycle bases · weighted matching · k shortest paths · min-cost flow.</a:t>
+              <a:t> negative costs · injective patterns · spanning forests · cycle bases · weighted matching · k shortest paths · min-cost flow · cyclic pattern counts (variable elimination; the totals are checked by oracles, not certified).</a:t>
             </a:r>
             <a:endParaRPr lang="en-US" sz="1400" dirty="0"/>
           </a:p>
@@ -33574,7 +33392,7 @@
                   <a:schemeClr val="tx1"/>
                 </a:solidFill>
               </a:rPr>
-              <a:t>Multi-step questions counted exactly, cycles by a worst-case optimal join, injective substructure search.</a:t>
+              <a:t>Multi-step questions counted exactly, cycles too (variable elimination); injective substructure search.</a:t>
             </a:r>
             <a:endParaRPr lang="en-US" sz="1400" dirty="0"/>
           </a:p>

</xml_diff>

<commit_message>
Slides: k shortest paths certified, and the deep review
- The k shortest paths card now says its certificate proves the ranking (8089024). Its
  notes cover the potentials, the explored prefixes, the oracle and forgery tests, the cost
  and the review.
- The done grid now says the ranking is certified and revalidated.
- The review sources add 8089024 and the deep review (gpt-6-astra, effort max, 4251e84).

Kept small on purpose: the other session's flux modes (60d5cc6) replaced this session's,
and its slides are its own. The deck builds with no fit warnings; it was not rendered,
since LibreOffice is not installed here.

Co-Authored-By: Claude Opus 5.5 <noreply@anthropic.com>
Claude-Session: https://claude.ai/code/session_013RgeQG29grTkK2yzfquiAN
</commit_message>
<xml_diff>
--- a/docs/GRAPH_slides.pptx
+++ b/docs/GRAPH_slides.pptx
@@ -137,21 +137,21 @@
   <p:extLst>
     <p:ext uri="{521415D9-36F7-43E2-AB2F-B90AF26B5E84}">
       <p14:sectionLst xmlns:p14="http://schemas.microsoft.com/office/powerpoint/2010/main">
-        <p14:section name="Why GRAPH" id="{0099c091-0a84-b4c6-2f33-f4d90bbef99a}">
+        <p14:section name="Why GRAPH" id="{90722641-e2c4-f964-951a-71ce9182e187}">
           <p14:sldIdLst>
             <p14:sldId id="256"/>
             <p14:sldId id="257"/>
             <p14:sldId id="258"/>
           </p14:sldIdLst>
         </p14:section>
-        <p14:section name="Architecture" id="{487ef9f8-6ad3-7994-5f92-178f8dc7b55e}">
+        <p14:section name="Architecture" id="{eefab595-71e8-29f6-20ac-1a765ca9406c}">
           <p14:sldIdLst>
             <p14:sldId id="259"/>
             <p14:sldId id="260"/>
             <p14:sldId id="261"/>
           </p14:sldIdLst>
         </p14:section>
-        <p14:section name="Operations" id="{6f2ce8d7-f5e6-1ed1-f59b-8c5f897d3c2a}">
+        <p14:section name="Operations" id="{3cba5cd6-1761-6b41-578d-f9ece40c590d}">
           <p14:sldIdLst>
             <p14:sldId id="262"/>
             <p14:sldId id="263"/>
@@ -171,7 +171,7 @@
             <p14:sldId id="277"/>
           </p14:sldIdLst>
         </p14:section>
-        <p14:section name="Trust and results" id="{4ddf571b-df22-e72d-f38f-9197978ecb93}">
+        <p14:section name="Trust and results" id="{5a816b00-2b7e-dc7a-b1e9-7705635b5431}">
           <p14:sldIdLst>
             <p14:sldId id="278"/>
             <p14:sldId id="279"/>
@@ -180,18 +180,18 @@
             <p14:sldId id="282"/>
           </p14:sldIdLst>
         </p14:section>
-        <p14:section name="Development" id="{394e5d1a-b996-0b0c-fc5a-f6f4af024b3c}">
+        <p14:section name="Development" id="{d8e9ac52-778f-dc6a-212f-e35c0c62c1ac}">
           <p14:sldIdLst>
             <p14:sldId id="283"/>
           </p14:sldIdLst>
         </p14:section>
-        <p14:section name="Roadmap" id="{a28e149e-5606-a829-115b-eb0b8baa0da5}">
+        <p14:section name="Roadmap" id="{12f971c6-8adb-0e17-68f2-6c7019cf0e87}">
           <p14:sldIdLst>
             <p14:sldId id="284"/>
             <p14:sldId id="285"/>
           </p14:sldIdLst>
         </p14:section>
-        <p14:section name="Close" id="{0359bf8d-f165-d08c-caa6-929c1236a2d0}">
+        <p14:section name="Close" id="{47c389db-995e-fc0d-a1ae-2bfaec7cd966}">
           <p14:sldIdLst>
             <p14:sldId id="286"/>
           </p14:sldIdLst>
@@ -3547,7 +3547,7 @@
           <a:p>
             <a:r>
               <a:rPr lang="en-US" dirty="0"/>
-              <a:t>Counts as of this build: python3 -m pytest (689 pass), src/graph_runtime/conformance/cases.json (209 cases), SCALE parity (16 tests) and STATES parity (6 tests) in their environments; 73 / 73 real consumer requests answer the same with both engines (git log f144c48). Oracles: tests/oracle.py; regular paths against Brzozowski derivatives on 1,500 random graphs (git log f65497b); PageRank against the exact linear system over fractions on 500 graphs (git log 0d4d2b3); negative costs against an independent fixpoint on 1,500 random graphs (tests/test_negative_costs.py); Datalog against an independent naive fixpoint on 400 random programs (tests/test_datalog.py); isomorphism against networkx's VF2 on 500 random cases, and the canonical identities of 300 relabeled or perturbed copies (tests/test_canonical.py). Parity: docs/SCALE_INTEGRATION.md, docs/STATES_INTEGRATION.md. Reviews: git log 8917563, 7ff04db; Codex adversarial reviews before commit: 99fb868 (a request field named kind was overwritten by the digest's record kind, now connectivity; unlisted groups and stray trees in the components certificate), 573ce2b (an interrupted max flow's upper bound was not verified), 1e8678d, 05d3ea5, 1d6dbbf, 04532ba, 107dc68, 297ca1e; 97723bb and 260d7b2 (negative costs and the faster projection identity, reviewed together: no soundness or identity counterexample, 12,000 larger random graphs all matching an independent oracle; one medium issue, diff-based revalidation reading the whole certificate even for an unrelated edit, fixed, and a regression test now forbids it); b7e4f12 (injective patterns: a 1,100-step chain hit Python's recursion limit, so row enumeration for cycles, injective patterns and tree rows now runs on an explicit stack, with a regression test covering rows, count and exists); 741c2dd (spanning forests: the verifier skipped a forest given as a tuple, a Result's frozen answer, which let a stale forest revalidate as holding; it now checks tuples and refuses a missing edge list, and so do three other list-only checks; regression tests cover a Result, a plain dict and a frozen answer); a482dbf (cycle bases: a witness naming a link twice let a non-minimum basis pass, because parity was counted two ways, now refused by the verifier, the contract and the schema; an exhausted budget still allocated every witness as a bitset; a total beyond the floats was rejected instead of written as null beside its exact value; and forged-answer tests stopped at the result_id check, so the forgeries in the negative-cost, injective, forest and basis tests are now resealed to test the semantic checks); 066dbab (weighted matching: an integer-cost certificate could carry floats, 1e100 potentials swallowing a negative reduced cost; every potential, the source and the sink must now be exact); ffd474a (k shortest paths: settled keys kept every edge-ID prefix, quadratic on a long path, 248 MiB on an 8,000-node chain, now released; the contract reader accepted a misordered or repeated list, now checked). Earlier findings shown on previous builds of this slide: a path from outside the sources' region (critical path, 1d6dbbf); a stale nearest cut held and contradicted answers left unknown (incidence, 05d3ea5); exact fields beside false values and unpolled controls (critical path, 1d6dbbf); a nonuniform PageRank start, a lenient ranking revalidation and a quadratic cyclic join (107dc68, the review of 26 October's increments together); the negative-cost review was otherwise sound on 12,000 random graphs against an oracle. 70ff8b4 (minimum-cost flows: a flow's stated relation went unchecked, so a relabelled edge revalidated as holding; an interrupted answer could send more than was asked; both fixed with regressions); b7bbe3a (cyclic pattern counts, four review passes, each finding fixed with a regression test: planning the elimination order was cubic on an 800-variable star pattern, 7.4 s for one row; a batched expansion charge checked cancellation only once per batch, so a batch of k now checks the deadline and cancellation exactly as k single expansions would; planning on K(17, n) patterns and wide bags was not charged to the budget; request normalization of patterns with many steps was quadratic, rebuilding the edge-variable set per step; the setup of a 100,000-spoke pattern was not charged; growing products, up to 2^400000, were built before a zero loop factor, which now removes its node first); 61dff27 (reachability between pairs, three passes, the third approving with no findings; each finding fixed with a regression: revalidation held witness-free positives on a closure certificate, which proves only negatives; hop lists were read before the first budget check; the index was cached per scope without bound, now the last four; closure verification was quadratic, twice; witness walks were charged only after the fact, now hop by hop before each is followed); 61cabb1 (positive Datalog, six passes, the sixth approving; each finding fixed with a regression: verifier joins materialized every substitution, twice; index builds, join plans, premise copies, ancestor walks and type decoding were not charged to the budget; a certificate was left on an output-limited answer; rows named facts when derivations were off; rounds were committed in hash order when interrupted; predicate arity was unbounded, now at most 32; the closure check was unbounded, now it stops after five million reads and says the certificate was not checked); 32507b6 (canonical forms and isomorphism, three passes; each finding fixed with a regression: the induced subgraph was read before any budget check; the verifier accepted nonexistent nodes; duplicate mapping entries hid invalid pairs; isomorphism answers carried unverified canonical ids, now removed, since canonical_form gives a verified one; revalidation took a mere relabeling for the canonical form, now refuted or unknown on another projection; float positions were accepted. The third pass's remaining point, that a result holds unchecked on its own projection, was resolved by stating revalidation's trust model in docs/API_CONTRACT.md §7, not by code).</a:t>
+              <a:t>Counts as of this build: python3 -m pytest (689 pass), src/graph_runtime/conformance/cases.json (209 cases), SCALE parity (16 tests) and STATES parity (6 tests) in their environments; 73 / 73 real consumer requests answer the same with both engines (git log f144c48). Oracles: tests/oracle.py; regular paths against Brzozowski derivatives on 1,500 random graphs (git log f65497b); PageRank against the exact linear system over fractions on 500 graphs (git log 0d4d2b3); negative costs against an independent fixpoint on 1,500 random graphs (tests/test_negative_costs.py); Datalog against an independent naive fixpoint on 400 random programs (tests/test_datalog.py); isomorphism against networkx's VF2 on 500 random cases, and the canonical identities of 300 relabeled or perturbed copies (tests/test_canonical.py). Parity: docs/SCALE_INTEGRATION.md, docs/STATES_INTEGRATION.md. Reviews: git log 8917563, 7ff04db; Codex adversarial reviews before commit: 99fb868 (a request field named kind was overwritten by the digest's record kind, now connectivity; unlisted groups and stray trees in the components certificate), 573ce2b (an interrupted max flow's upper bound was not verified), 1e8678d, 05d3ea5, 1d6dbbf, 04532ba, 107dc68, 297ca1e; 97723bb and 260d7b2 (negative costs and the faster projection identity, reviewed together: no soundness or identity counterexample, 12,000 larger random graphs all matching an independent oracle; one medium issue, diff-based revalidation reading the whole certificate even for an unrelated edit, fixed, and a regression test now forbids it); b7e4f12 (injective patterns: a 1,100-step chain hit Python's recursion limit, so row enumeration for cycles, injective patterns and tree rows now runs on an explicit stack, with a regression test covering rows, count and exists); 741c2dd (spanning forests: the verifier skipped a forest given as a tuple, a Result's frozen answer, which let a stale forest revalidate as holding; it now checks tuples and refuses a missing edge list, and so do three other list-only checks; regression tests cover a Result, a plain dict and a frozen answer); a482dbf (cycle bases: a witness naming a link twice let a non-minimum basis pass, because parity was counted two ways, now refused by the verifier, the contract and the schema; an exhausted budget still allocated every witness as a bitset; a total beyond the floats was rejected instead of written as null beside its exact value; and forged-answer tests stopped at the result_id check, so the forgeries in the negative-cost, injective, forest and basis tests are now resealed to test the semantic checks); 066dbab (weighted matching: an integer-cost certificate could carry floats, 1e100 potentials swallowing a negative reduced cost; every potential, the source and the sink must now be exact); ffd474a (k shortest paths: settled keys kept every edge-ID prefix, quadratic on a long path, 248 MiB on an 8,000-node chain, now released; the contract reader accepted a misordered or repeated list, now checked). Earlier findings shown on previous builds of this slide: a path from outside the sources' region (critical path, 1d6dbbf); a stale nearest cut held and contradicted answers left unknown (incidence, 05d3ea5); exact fields beside false values and unpolled controls (critical path, 1d6dbbf); a nonuniform PageRank start, a lenient ranking revalidation and a quadratic cyclic join (107dc68, the review of 26 October's increments together); the negative-cost review was otherwise sound on 12,000 random graphs against an oracle. 70ff8b4 (minimum-cost flows: a flow's stated relation went unchecked, so a relabelled edge revalidated as holding; an interrupted answer could send more than was asked; both fixed with regressions); b7bbe3a (cyclic pattern counts, four review passes, each finding fixed with a regression test: planning the elimination order was cubic on an 800-variable star pattern, 7.4 s for one row; a batched expansion charge checked cancellation only once per batch, so a batch of k now checks the deadline and cancellation exactly as k single expansions would; planning on K(17, n) patterns and wide bags was not charged to the budget; request normalization of patterns with many steps was quadratic, rebuilding the edge-variable set per step; the setup of a 100,000-spoke pattern was not charged; growing products, up to 2^400000, were built before a zero loop factor, which now removes its node first); 61dff27 (reachability between pairs, three passes, the third approving with no findings; each finding fixed with a regression: revalidation held witness-free positives on a closure certificate, which proves only negatives; hop lists were read before the first budget check; the index was cached per scope without bound, now the last four; closure verification was quadratic, twice; witness walks were charged only after the fact, now hop by hop before each is followed); 61cabb1 (positive Datalog, six passes, the sixth approving; each finding fixed with a regression: verifier joins materialized every substitution, twice; index builds, join plans, premise copies, ancestor walks and type decoding were not charged to the budget; a certificate was left on an output-limited answer; rows named facts when derivations were off; rounds were committed in hash order when interrupted; predicate arity was unbounded, now at most 32; the closure check was unbounded, now it stops after five million reads and says the certificate was not checked); 32507b6 (canonical forms and isomorphism, three passes; each finding fixed with a regression: the induced subgraph was read before any budget check; the verifier accepted nonexistent nodes; duplicate mapping entries hid invalid pairs; isomorphism answers carried unverified canonical ids, now removed, since canonical_form gives a verified one; revalidation took a mere relabeling for the canonical form, now refuted or unknown on another projection; float positions were accepted. The third pass's remaining point, that a result holds unchecked on its own projection, was resolved by stating revalidation's trust model in docs/API_CONTRACT.md §7, not by code); 8089024 (k shortest paths certificates: 46,999 forged rankings all refused; the potentials' check rebuilt the reversed scope for every node, 28 s on a 16,000-node chain with a relation per edge, now built once, with a regression); 4251e84 (a deep review of 04532ba..HEAD, 24 commits of both sessions, by gpt-6-astra at reasoning effort max: about 15,000 random cases against its own oracles and 18,000 revalidation checks found no wrong answer, false certificate or wrong revalidation; it found a fewest-hop witness search outside the budget (signed shortest paths), cycle extraction quadratic in the edges out of scope, k = 2 quadratic on a chain, a PageRank verifier that accepted the wrong top node (older than the range), summaries missing a negative cycle and a matching cost, and quadratic work in this session's flux modes, which 60d5cc6's replaces and which passes the same cases; the five fixed with regressions that fail on the old code).</a:t>
             </a:r>
             <a:endParaRPr lang="en-US" dirty="0"/>
           </a:p>
@@ -4787,10 +4787,10 @@
           <a:p>
             <a:r>
               <a:rPr lang="en-US" dirty="0"/>
-              <a:t>Sources: docs/API_CONTRACT.md §4: Bottleneck path, Regular path, K shortest paths; §6; tests/test_k_shortest_paths.py; git log ae48035, f65497b, ffd474a.
+              <a:t>Sources: docs/API_CONTRACT.md §4: Bottleneck path, Regular path, K shortest paths; §6; tests/test_k_shortest_paths.py, tests/test_k_paths_certificate.py; git log ae48035, f65497b, ffd474a, 8089024.
 bottleneck_path: Fastest rate-limiting step, lowest barrier. Theory: The path whose weakest edge is strongest (max_min: rates) or highest edge lowest (min_max: barriers); fewest hops among those. Algorithm: Settle nodes best value first, as Dijkstra settles costs; then a breadth-first search over hops as good finds the fewest hops. Certificate proves: Threshold: what the sources reach by strictly better hops is closed and holds no target. A closure proves a negative. max_min, e.g. rates: the fastest rate-limiting step; min_max, e.g. barriers: the lowest highest barrier. Weights are compared, never added. The breadth-first search runs over the hops at least as good as the value. Certificate: what the sources reach by hops strictly better than the value is closed and holds no target, so no path is better.
 regular_path: Walks matching a regular expression. Theory: Regular path queries (Mendelzon and Wood, 1995), as SPARQL property paths and GQL write them: DERIVED_FROM*/SUPPORTED_BY Algorithm: Breadth-first search over the graph times the expression's Glushkov automaton: one fewest-hop walk, or every node reached. Certificate proves: Closed product states below a bound prove the fewest hops, a negative or a reached set. The verifier builds its own automaton. A fuller expression: DERIVED_FROM*/SUPPORTED_BY[Measurement]/IN. The search runs over the product of the graph and the expression's Glushkov automaton. Closed product states below a bound prove the fewest hops, a negative or a complete reached set.
-k_shortest_paths: Alternatives: the first k simple paths. Theory: Alternative pathways, backup routes: k simple paths ranked by cost, hops, then IDs, so ties have one order and parallel edges differ. Algorithm: Yen (1971) with Lawler's rule: spur only from where a path left its parent; each least path a Dijkstra search on the full order. Checked by: Each path is a witness a checker confirms. The ranking is Yen's theorem, tested on 700 random cases: not certified or revalidated. docs/API_CONTRACT.md §4, K shortest paths: a path visits no node twice; other sources and targets may lie on it, and a source that is a target is a path of no hops. Costs as for shortest paths, non-negative and exact; without costs every hop costs 1. The order: cost, then hops, then the start node's ID and the sequence of edge IDs. Yen's algorithm: for each accepted path and each of its nodes, the least path that keeps the hops before that spur node, avoids the nodes before it, and leaves it neither by a hop nor by stopping that an accepted path with the same root took is a candidate; stopping is one more way to leave a spur node, so paths that end at a target on the way, or go on past one, are found. A virtual start before the sources makes several sources one problem. Lawler's rule spurs only from where a path left its parent, and searches stop at the key of the last candidate that could still be listed. Each least path is Dijkstra's search on the full key, which extending a path preserves. exhausted is true when fewer than k simple paths exist, false when k are listed, null when interrupted; an interrupted search lists a prefix of the order. The ranking is not certified, so revalidation answers unknown (not_certified). A Codex adversarial review found that settled keys kept every edge-ID prefix, quadratic on a long path (248 MiB on an 8,000-node chain), and that the contract reader accepted a misordered or repeated list; settled labels are now released and the contract checks the order, with regressions. Tests (tests/test_k_shortest_paths.py): 700 random cases (several sources and targets, ties, zero costs, both scope directions) list exactly the brute force's first k; networkx's shortest_simple_paths agrees on costs; forgeries are refused; interruptions list a prefix of the order; 2 hand-worked conformance cases. Benchmark (git log ffd474a): 2,000 nodes and 10,000 edges, k = 50, 0.32 s (networkx 0.18 s); 20,000 nodes and 100,000 edges, k = 20, 3.07 s (networkx 0.30 s, with bidirectional searches that the strict tie order does not allow here).</a:t>
+k_shortest_paths: Alternatives: the first k simple paths. Theory: Alternative pathways, backup routes: k simple paths ranked by cost, hops, then IDs, so ties have one order and parallel edges differ. Algorithm: Yen (1971) with Lawler's rule: spur only from where a path left its parent; each least path a Dijkstra search on the full order. Certificate proves: Potentials bound every node's cost to a target; labels show no walk leaving the listed prefixes reaches one before the last path. docs/API_CONTRACT.md §4, K shortest paths: a path visits no node twice; other sources and targets may lie on it, and a source that is a target is a path of no hops. Costs as for shortest paths, non-negative and exact; without costs every hop costs 1. The order: cost, then hops, then the start node's ID and the sequence of edge IDs. Yen's algorithm: for each accepted path and each of its nodes, the least path that keeps the hops before that spur node, avoids the nodes before it, and leaves it neither by a hop nor by stopping that an accepted path with the same root took is a candidate; stopping is one more way to leave a spur node, so paths that end at a target on the way, or go on past one, are found. A virtual start before the sources makes several sources one problem. Lawler's rule spurs only from where a path left its parent, and searches stop at the key of the last candidate that could still be listed. Each least path is Dijkstra's search on the full key, which extending a path preserves. exhausted is true when fewer than k simple paths exist, false when k are listed, null when interrupted; an interrupted search lists a prefix of the order. With certificate: true (git log 8089024) the ranking is proven: potentials, from a reverse search, bound every node's (cost, hops) to a target, and a node without one reaches none; every unlisted simple path leaves the tree of the listed paths' prefixes by a hop no listed path with that prefix takes, and for each prefix the walks leaving it are explored by A* while their potentials could still put them before the last path, each node labelled with its least (cost, hops, side), side breaking a tie by IDs. No label is a target, so nothing comes before the last path; the checker confirms each label by its hops, without searching, and revalidation checks the certificate against the new records. An independent oracle builds the strongest certificate for any claimed list: on 1,200 random cases the engine's is exactly that one, and false rankings (a path left out, the last skipped, a full list called exhausted) are refused even with it. The certificate costs about 1%: 5.94 s against 5.88 s on 20,000 nodes and 100,000 edges, k = 20, checked in 0.57 s. Its Codex adversarial review refused all 46,999 forged rankings and found the reversed scope rebuilt per node, quadratic with many relations (28 s at 16,000 nodes), now built once with a regression. A Codex adversarial review found that settled keys kept every edge-ID prefix, quadratic on a long path (248 MiB on an 8,000-node chain), and that the contract reader accepted a misordered or repeated list; settled labels are now released and the contract checks the order, with regressions. Tests (tests/test_k_shortest_paths.py): 700 random cases (several sources and targets, ties, zero costs, both scope directions) list exactly the brute force's first k; networkx's shortest_simple_paths agrees on costs; forgeries are refused; interruptions list a prefix of the order; 2 hand-worked conformance cases. Benchmark (git log ffd474a): 2,000 nodes and 10,000 edges, k = 50, 0.32 s (networkx 0.18 s); 20,000 nodes and 100,000 edges, k = 20, 3.07 s (networkx 0.30 s, with bidirectional searches that the strict tie order does not allow here).</a:t>
             </a:r>
             <a:endParaRPr lang="en-US" dirty="0"/>
           </a:p>
@@ -31640,7 +31640,7 @@
                   <a:schemeClr val="accent6"/>
                 </a:solidFill>
               </a:rPr>
-              <a:t>the ranking tested, not certified</a:t>
+              <a:t>the ranking certified, revalidated</a:t>
             </a:r>
             <a:endParaRPr lang="en-US" sz="1400" dirty="0"/>
           </a:p>
@@ -42241,7 +42241,7 @@
                   <a:schemeClr val="accent1"/>
                 </a:solidFill>
               </a:rPr>
-              <a:t>CHECKED BY</a:t>
+              <a:t>CERTIFICATE PROVES</a:t>
             </a:r>
             <a:endParaRPr lang="en-US" sz="1100" dirty="0"/>
           </a:p>
@@ -42277,7 +42277,7 @@
                   <a:schemeClr val="tx1"/>
                 </a:solidFill>
               </a:rPr>
-              <a:t>Each path is a witness a checker confirms. The ranking is Yen's theorem, tested on 700 random cases: not certified or revalidated.</a:t>
+              <a:t>Potentials bound every node's cost to a target; labels show no walk leaving the listed prefixes reaches one before the last path.</a:t>
             </a:r>
             <a:endParaRPr lang="en-US" sz="1400" dirty="0"/>
           </a:p>

</xml_diff>